<commit_message>
台割 案3 v2改: rebalance P.08-09 vertical spacing
Co-Authored-By: Claude Opus 5.5 <noreply@anthropic.com>
Claude-Session: https://claude.ai/code/session_01RaAHJjFzQLBQzv3hdCW4ED
</commit_message>
<xml_diff>
--- a/cover-proposals/v13_1007_case3_v2plus/台割案3_v2改_P02-11_編集用.pptx
+++ b/cover-proposals/v13_1007_case3_v2plus/台割案3_v2改_P02-11_編集用.pptx
@@ -12255,7 +12255,7 @@
         </p:nvSpPr>
         <p:spPr>
           <a:xfrm>
-            <a:off x="1168911" y="3054891"/>
+            <a:off x="1168911" y="3258179"/>
             <a:ext cx="483208" cy="114350"/>
           </a:xfrm>
           <a:prstGeom prst="rect">
@@ -12297,7 +12297,7 @@
         </p:nvSpPr>
         <p:spPr>
           <a:xfrm>
-            <a:off x="1168911" y="3191666"/>
+            <a:off x="1168911" y="3394955"/>
             <a:ext cx="373364" cy="145733"/>
           </a:xfrm>
           <a:prstGeom prst="rect">
@@ -12339,7 +12339,7 @@
         </p:nvSpPr>
         <p:spPr>
           <a:xfrm>
-            <a:off x="508222" y="3608090"/>
+            <a:off x="508222" y="3811379"/>
             <a:ext cx="1197081" cy="126039"/>
           </a:xfrm>
           <a:prstGeom prst="rect">
@@ -12381,7 +12381,7 @@
         </p:nvSpPr>
         <p:spPr>
           <a:xfrm>
-            <a:off x="3379676" y="3054891"/>
+            <a:off x="3379676" y="3258179"/>
             <a:ext cx="386249" cy="114350"/>
           </a:xfrm>
           <a:prstGeom prst="rect">
@@ -12423,7 +12423,7 @@
         </p:nvSpPr>
         <p:spPr>
           <a:xfrm>
-            <a:off x="3379676" y="3191666"/>
+            <a:off x="3379676" y="3394955"/>
             <a:ext cx="480806" cy="145733"/>
           </a:xfrm>
           <a:prstGeom prst="rect">
@@ -12465,7 +12465,7 @@
         </p:nvSpPr>
         <p:spPr>
           <a:xfrm>
-            <a:off x="2718988" y="3608090"/>
+            <a:off x="2718988" y="3811379"/>
             <a:ext cx="1690176" cy="126039"/>
           </a:xfrm>
           <a:prstGeom prst="rect">
@@ -12507,7 +12507,7 @@
         </p:nvSpPr>
         <p:spPr>
           <a:xfrm>
-            <a:off x="5590442" y="3054891"/>
+            <a:off x="5590442" y="3258179"/>
             <a:ext cx="448923" cy="114350"/>
           </a:xfrm>
           <a:prstGeom prst="rect">
@@ -12549,7 +12549,7 @@
         </p:nvSpPr>
         <p:spPr>
           <a:xfrm>
-            <a:off x="5590442" y="3191666"/>
+            <a:off x="5590442" y="3394955"/>
             <a:ext cx="480806" cy="145733"/>
           </a:xfrm>
           <a:prstGeom prst="rect">
@@ -12591,7 +12591,7 @@
         </p:nvSpPr>
         <p:spPr>
           <a:xfrm>
-            <a:off x="4929753" y="3608090"/>
+            <a:off x="4929753" y="3811379"/>
             <a:ext cx="973027" cy="126039"/>
           </a:xfrm>
           <a:prstGeom prst="rect">
@@ -12633,7 +12633,7 @@
         </p:nvSpPr>
         <p:spPr>
           <a:xfrm>
-            <a:off x="1168911" y="4223801"/>
+            <a:off x="1168911" y="4579557"/>
             <a:ext cx="1120431" cy="114350"/>
           </a:xfrm>
           <a:prstGeom prst="rect">
@@ -12675,7 +12675,7 @@
         </p:nvSpPr>
         <p:spPr>
           <a:xfrm>
-            <a:off x="1168911" y="4360576"/>
+            <a:off x="1168911" y="4716332"/>
             <a:ext cx="1447122" cy="145733"/>
           </a:xfrm>
           <a:prstGeom prst="rect">
@@ -12717,7 +12717,7 @@
         </p:nvSpPr>
         <p:spPr>
           <a:xfrm>
-            <a:off x="508222" y="4777001"/>
+            <a:off x="508222" y="5132756"/>
             <a:ext cx="1385103" cy="126039"/>
           </a:xfrm>
           <a:prstGeom prst="rect">
@@ -12759,7 +12759,7 @@
         </p:nvSpPr>
         <p:spPr>
           <a:xfrm>
-            <a:off x="3379676" y="4223801"/>
+            <a:off x="3379676" y="4579557"/>
             <a:ext cx="530377" cy="114350"/>
           </a:xfrm>
           <a:prstGeom prst="rect">
@@ -12801,7 +12801,7 @@
         </p:nvSpPr>
         <p:spPr>
           <a:xfrm>
-            <a:off x="3379676" y="4360576"/>
+            <a:off x="3379676" y="4716332"/>
             <a:ext cx="480806" cy="145733"/>
           </a:xfrm>
           <a:prstGeom prst="rect">
@@ -12843,7 +12843,7 @@
         </p:nvSpPr>
         <p:spPr>
           <a:xfrm>
-            <a:off x="2718988" y="4777001"/>
+            <a:off x="2718988" y="5132756"/>
             <a:ext cx="860563" cy="126039"/>
           </a:xfrm>
           <a:prstGeom prst="rect">
@@ -12885,7 +12885,7 @@
         </p:nvSpPr>
         <p:spPr>
           <a:xfrm>
-            <a:off x="5590442" y="4223801"/>
+            <a:off x="5590442" y="4579557"/>
             <a:ext cx="541514" cy="114350"/>
           </a:xfrm>
           <a:prstGeom prst="rect">
@@ -12927,7 +12927,7 @@
         </p:nvSpPr>
         <p:spPr>
           <a:xfrm>
-            <a:off x="5590442" y="4360576"/>
+            <a:off x="5590442" y="4716332"/>
             <a:ext cx="480806" cy="145733"/>
           </a:xfrm>
           <a:prstGeom prst="rect">
@@ -12969,7 +12969,7 @@
         </p:nvSpPr>
         <p:spPr>
           <a:xfrm>
-            <a:off x="4929753" y="4777001"/>
+            <a:off x="4929753" y="5132756"/>
             <a:ext cx="1084399" cy="126039"/>
           </a:xfrm>
           <a:prstGeom prst="rect">
@@ -13011,7 +13011,7 @@
         </p:nvSpPr>
         <p:spPr>
           <a:xfrm>
-            <a:off x="508222" y="5519767"/>
+            <a:off x="508222" y="6002578"/>
             <a:ext cx="3200468" cy="101644"/>
           </a:xfrm>
           <a:prstGeom prst="rect">
@@ -13053,7 +13053,7 @@
         </p:nvSpPr>
         <p:spPr>
           <a:xfrm>
-            <a:off x="508222" y="5659528"/>
+            <a:off x="508222" y="6142339"/>
             <a:ext cx="3368837" cy="127055"/>
           </a:xfrm>
           <a:prstGeom prst="rect">
@@ -13095,7 +13095,7 @@
         </p:nvSpPr>
         <p:spPr>
           <a:xfrm>
-            <a:off x="609866" y="6040695"/>
+            <a:off x="609866" y="6523506"/>
             <a:ext cx="307415" cy="114350"/>
           </a:xfrm>
           <a:prstGeom prst="rect">
@@ -13137,7 +13137,7 @@
         </p:nvSpPr>
         <p:spPr>
           <a:xfrm>
-            <a:off x="609866" y="6174611"/>
+            <a:off x="609866" y="6657422"/>
             <a:ext cx="223776" cy="126039"/>
           </a:xfrm>
           <a:prstGeom prst="rect">
@@ -13179,7 +13179,7 @@
         </p:nvSpPr>
         <p:spPr>
           <a:xfrm>
-            <a:off x="609866" y="6310370"/>
+            <a:off x="609866" y="6793181"/>
             <a:ext cx="445210" cy="108632"/>
           </a:xfrm>
           <a:prstGeom prst="rect">
@@ -13221,7 +13221,7 @@
         </p:nvSpPr>
         <p:spPr>
           <a:xfrm>
-            <a:off x="1931244" y="6040695"/>
+            <a:off x="1931244" y="6523506"/>
             <a:ext cx="698964" cy="114350"/>
           </a:xfrm>
           <a:prstGeom prst="rect">
@@ -13263,7 +13263,7 @@
         </p:nvSpPr>
         <p:spPr>
           <a:xfrm>
-            <a:off x="1931244" y="6174611"/>
+            <a:off x="1931244" y="6657422"/>
             <a:ext cx="483208" cy="126039"/>
           </a:xfrm>
           <a:prstGeom prst="rect">
@@ -13305,7 +13305,7 @@
         </p:nvSpPr>
         <p:spPr>
           <a:xfrm>
-            <a:off x="1931244" y="6310370"/>
+            <a:off x="1931244" y="6793181"/>
             <a:ext cx="677782" cy="108632"/>
           </a:xfrm>
           <a:prstGeom prst="rect">
@@ -13347,7 +13347,7 @@
         </p:nvSpPr>
         <p:spPr>
           <a:xfrm>
-            <a:off x="3252621" y="6040695"/>
+            <a:off x="3252621" y="6523506"/>
             <a:ext cx="492380" cy="114350"/>
           </a:xfrm>
           <a:prstGeom prst="rect">
@@ -13389,7 +13389,7 @@
         </p:nvSpPr>
         <p:spPr>
           <a:xfrm>
-            <a:off x="3252621" y="6174611"/>
+            <a:off x="3252621" y="6657422"/>
             <a:ext cx="483208" cy="126039"/>
           </a:xfrm>
           <a:prstGeom prst="rect">
@@ -13431,7 +13431,7 @@
         </p:nvSpPr>
         <p:spPr>
           <a:xfrm>
-            <a:off x="3252621" y="6310370"/>
+            <a:off x="3252621" y="6793181"/>
             <a:ext cx="642623" cy="108632"/>
           </a:xfrm>
           <a:prstGeom prst="rect">
@@ -13473,7 +13473,7 @@
         </p:nvSpPr>
         <p:spPr>
           <a:xfrm>
-            <a:off x="4573998" y="6040695"/>
+            <a:off x="4573998" y="6523506"/>
             <a:ext cx="466611" cy="114350"/>
           </a:xfrm>
           <a:prstGeom prst="rect">
@@ -13515,7 +13515,7 @@
         </p:nvSpPr>
         <p:spPr>
           <a:xfrm>
-            <a:off x="4573998" y="6174611"/>
+            <a:off x="4573998" y="6657422"/>
             <a:ext cx="396731" cy="126039"/>
           </a:xfrm>
           <a:prstGeom prst="rect">
@@ -13557,7 +13557,7 @@
         </p:nvSpPr>
         <p:spPr>
           <a:xfrm>
-            <a:off x="4573998" y="6310370"/>
+            <a:off x="4573998" y="6793181"/>
             <a:ext cx="916904" cy="108632"/>
           </a:xfrm>
           <a:prstGeom prst="rect">
@@ -13599,7 +13599,7 @@
         </p:nvSpPr>
         <p:spPr>
           <a:xfrm>
-            <a:off x="5895375" y="6040695"/>
+            <a:off x="5895375" y="6523506"/>
             <a:ext cx="462025" cy="114350"/>
           </a:xfrm>
           <a:prstGeom prst="rect">
@@ -13641,7 +13641,7 @@
         </p:nvSpPr>
         <p:spPr>
           <a:xfrm>
-            <a:off x="5895375" y="6174611"/>
+            <a:off x="5895375" y="6657422"/>
             <a:ext cx="223776" cy="126039"/>
           </a:xfrm>
           <a:prstGeom prst="rect">
@@ -13683,7 +13683,7 @@
         </p:nvSpPr>
         <p:spPr>
           <a:xfrm>
-            <a:off x="5895375" y="6310370"/>
+            <a:off x="5895375" y="6793181"/>
             <a:ext cx="666863" cy="108632"/>
           </a:xfrm>
           <a:prstGeom prst="rect">
@@ -13725,7 +13725,7 @@
         </p:nvSpPr>
         <p:spPr>
           <a:xfrm>
-            <a:off x="622572" y="7044433"/>
+            <a:off x="622572" y="7527244"/>
             <a:ext cx="792429" cy="76233"/>
           </a:xfrm>
           <a:prstGeom prst="rect">
@@ -13767,7 +13767,7 @@
         </p:nvSpPr>
         <p:spPr>
           <a:xfrm>
-            <a:off x="622572" y="7158783"/>
+            <a:off x="622572" y="7641594"/>
             <a:ext cx="444337" cy="127055"/>
           </a:xfrm>
           <a:prstGeom prst="rect">
@@ -13809,7 +13809,7 @@
         </p:nvSpPr>
         <p:spPr>
           <a:xfrm>
-            <a:off x="622572" y="7305405"/>
+            <a:off x="622572" y="7788216"/>
             <a:ext cx="1431181" cy="252078"/>
           </a:xfrm>
           <a:prstGeom prst="rect">
@@ -13871,7 +13871,7 @@
         </p:nvSpPr>
         <p:spPr>
           <a:xfrm>
-            <a:off x="2274293" y="7044433"/>
+            <a:off x="2274293" y="7527244"/>
             <a:ext cx="792429" cy="76233"/>
           </a:xfrm>
           <a:prstGeom prst="rect">
@@ -13913,7 +13913,7 @@
         </p:nvSpPr>
         <p:spPr>
           <a:xfrm>
-            <a:off x="2274293" y="7158783"/>
+            <a:off x="2274293" y="7641594"/>
             <a:ext cx="327942" cy="127055"/>
           </a:xfrm>
           <a:prstGeom prst="rect">
@@ -13955,7 +13955,7 @@
         </p:nvSpPr>
         <p:spPr>
           <a:xfrm>
-            <a:off x="2274293" y="7305405"/>
+            <a:off x="2274293" y="7788216"/>
             <a:ext cx="1431181" cy="252078"/>
           </a:xfrm>
           <a:prstGeom prst="rect">
@@ -14017,7 +14017,7 @@
         </p:nvSpPr>
         <p:spPr>
           <a:xfrm>
-            <a:off x="3926015" y="7044433"/>
+            <a:off x="3926015" y="7527244"/>
             <a:ext cx="1151877" cy="76233"/>
           </a:xfrm>
           <a:prstGeom prst="rect">
@@ -14059,7 +14059,7 @@
         </p:nvSpPr>
         <p:spPr>
           <a:xfrm>
-            <a:off x="3926015" y="7158783"/>
+            <a:off x="3926015" y="7641594"/>
             <a:ext cx="932190" cy="127055"/>
           </a:xfrm>
           <a:prstGeom prst="rect">
@@ -14101,7 +14101,7 @@
         </p:nvSpPr>
         <p:spPr>
           <a:xfrm>
-            <a:off x="3926015" y="7305405"/>
+            <a:off x="3926015" y="7788216"/>
             <a:ext cx="1433146" cy="252078"/>
           </a:xfrm>
           <a:prstGeom prst="rect">
@@ -14163,7 +14163,7 @@
         </p:nvSpPr>
         <p:spPr>
           <a:xfrm>
-            <a:off x="5577736" y="7044433"/>
+            <a:off x="5577736" y="7527244"/>
             <a:ext cx="910353" cy="76233"/>
           </a:xfrm>
           <a:prstGeom prst="rect">
@@ -14205,7 +14205,7 @@
         </p:nvSpPr>
         <p:spPr>
           <a:xfrm>
-            <a:off x="5577736" y="7158783"/>
+            <a:off x="5577736" y="7641594"/>
             <a:ext cx="651795" cy="127055"/>
           </a:xfrm>
           <a:prstGeom prst="rect">
@@ -14247,7 +14247,7 @@
         </p:nvSpPr>
         <p:spPr>
           <a:xfrm>
-            <a:off x="5577736" y="7305405"/>
+            <a:off x="5577736" y="7788216"/>
             <a:ext cx="1434457" cy="252078"/>
           </a:xfrm>
           <a:prstGeom prst="rect">
@@ -14309,7 +14309,7 @@
         </p:nvSpPr>
         <p:spPr>
           <a:xfrm>
-            <a:off x="508222" y="7924261"/>
+            <a:off x="508222" y="8483305"/>
             <a:ext cx="3544848" cy="686354"/>
           </a:xfrm>
           <a:prstGeom prst="rect">
@@ -14411,7 +14411,7 @@
         </p:nvSpPr>
         <p:spPr>
           <a:xfrm>
-            <a:off x="4065776" y="8899443"/>
+            <a:off x="4065776" y="9661776"/>
             <a:ext cx="820818" cy="88939"/>
           </a:xfrm>
           <a:prstGeom prst="rect">
@@ -14453,7 +14453,7 @@
         </p:nvSpPr>
         <p:spPr>
           <a:xfrm>
-            <a:off x="4065776" y="9013793"/>
+            <a:off x="4065776" y="9776126"/>
             <a:ext cx="300427" cy="88939"/>
           </a:xfrm>
           <a:prstGeom prst="rect">
@@ -14745,7 +14745,7 @@
         </p:nvSpPr>
         <p:spPr>
           <a:xfrm>
-            <a:off x="8068024" y="2607417"/>
+            <a:off x="8068024" y="2810706"/>
             <a:ext cx="317678" cy="241405"/>
           </a:xfrm>
           <a:prstGeom prst="rect">
@@ -14787,7 +14787,7 @@
         </p:nvSpPr>
         <p:spPr>
           <a:xfrm>
-            <a:off x="8474602" y="2626475"/>
+            <a:off x="8474602" y="2829764"/>
             <a:ext cx="894848" cy="114350"/>
           </a:xfrm>
           <a:prstGeom prst="rect">
@@ -14829,7 +14829,7 @@
         </p:nvSpPr>
         <p:spPr>
           <a:xfrm>
-            <a:off x="8474602" y="2761281"/>
+            <a:off x="8474602" y="2964570"/>
             <a:ext cx="1809628" cy="149671"/>
           </a:xfrm>
           <a:prstGeom prst="rect">
@@ -14871,7 +14871,7 @@
         </p:nvSpPr>
         <p:spPr>
           <a:xfrm>
-            <a:off x="8474602" y="2938270"/>
+            <a:off x="8474602" y="3141558"/>
             <a:ext cx="2378935" cy="126039"/>
           </a:xfrm>
           <a:prstGeom prst="rect">
@@ -14913,7 +14913,7 @@
         </p:nvSpPr>
         <p:spPr>
           <a:xfrm>
-            <a:off x="11396878" y="2607417"/>
+            <a:off x="11396878" y="2810706"/>
             <a:ext cx="373583" cy="241405"/>
           </a:xfrm>
           <a:prstGeom prst="rect">
@@ -14955,7 +14955,7 @@
         </p:nvSpPr>
         <p:spPr>
           <a:xfrm>
-            <a:off x="11803456" y="2626475"/>
+            <a:off x="11803456" y="2829764"/>
             <a:ext cx="920835" cy="114350"/>
           </a:xfrm>
           <a:prstGeom prst="rect">
@@ -14997,7 +14997,7 @@
         </p:nvSpPr>
         <p:spPr>
           <a:xfrm>
-            <a:off x="11803456" y="2761281"/>
+            <a:off x="11803456" y="2964570"/>
             <a:ext cx="1945676" cy="149671"/>
           </a:xfrm>
           <a:prstGeom prst="rect">
@@ -15039,7 +15039,7 @@
         </p:nvSpPr>
         <p:spPr>
           <a:xfrm>
-            <a:off x="11803456" y="2938270"/>
+            <a:off x="11803456" y="3141558"/>
             <a:ext cx="1517658" cy="126039"/>
           </a:xfrm>
           <a:prstGeom prst="rect">
@@ -15081,7 +15081,7 @@
         </p:nvSpPr>
         <p:spPr>
           <a:xfrm>
-            <a:off x="8068024" y="3395161"/>
+            <a:off x="8068024" y="3750916"/>
             <a:ext cx="381881" cy="241405"/>
           </a:xfrm>
           <a:prstGeom prst="rect">
@@ -15123,7 +15123,7 @@
         </p:nvSpPr>
         <p:spPr>
           <a:xfrm>
-            <a:off x="8474602" y="3414219"/>
+            <a:off x="8474602" y="3769975"/>
             <a:ext cx="1020196" cy="114350"/>
           </a:xfrm>
           <a:prstGeom prst="rect">
@@ -15165,7 +15165,7 @@
         </p:nvSpPr>
         <p:spPr>
           <a:xfrm>
-            <a:off x="8474602" y="3549025"/>
+            <a:off x="8474602" y="3904781"/>
             <a:ext cx="2367798" cy="149671"/>
           </a:xfrm>
           <a:prstGeom prst="rect">
@@ -15207,7 +15207,7 @@
         </p:nvSpPr>
         <p:spPr>
           <a:xfrm>
-            <a:off x="8474602" y="3726014"/>
+            <a:off x="8474602" y="4081769"/>
             <a:ext cx="2205981" cy="126039"/>
           </a:xfrm>
           <a:prstGeom prst="rect">
@@ -15249,7 +15249,7 @@
         </p:nvSpPr>
         <p:spPr>
           <a:xfrm>
-            <a:off x="11396878" y="3395161"/>
+            <a:off x="11396878" y="3750916"/>
             <a:ext cx="385812" cy="241405"/>
           </a:xfrm>
           <a:prstGeom prst="rect">
@@ -15291,7 +15291,7 @@
         </p:nvSpPr>
         <p:spPr>
           <a:xfrm>
-            <a:off x="11803456" y="3414219"/>
+            <a:off x="11803456" y="3769975"/>
             <a:ext cx="726698" cy="114350"/>
           </a:xfrm>
           <a:prstGeom prst="rect">
@@ -15333,7 +15333,7 @@
         </p:nvSpPr>
         <p:spPr>
           <a:xfrm>
-            <a:off x="11803456" y="3549025"/>
+            <a:off x="11803456" y="3904781"/>
             <a:ext cx="2252059" cy="149671"/>
           </a:xfrm>
           <a:prstGeom prst="rect">
@@ -15375,7 +15375,7 @@
         </p:nvSpPr>
         <p:spPr>
           <a:xfrm>
-            <a:off x="11803456" y="3726014"/>
+            <a:off x="11803456" y="4081769"/>
             <a:ext cx="1866842" cy="126039"/>
           </a:xfrm>
           <a:prstGeom prst="rect">
@@ -15417,7 +15417,7 @@
         </p:nvSpPr>
         <p:spPr>
           <a:xfrm>
-            <a:off x="8068024" y="4341725"/>
+            <a:off x="8068024" y="4900769"/>
             <a:ext cx="1366323" cy="101644"/>
           </a:xfrm>
           <a:prstGeom prst="rect">
@@ -15459,7 +15459,7 @@
         </p:nvSpPr>
         <p:spPr>
           <a:xfrm>
-            <a:off x="9440223" y="4341725"/>
+            <a:off x="9440223" y="4900769"/>
             <a:ext cx="2137629" cy="127055"/>
           </a:xfrm>
           <a:prstGeom prst="rect">
@@ -15501,7 +15501,7 @@
         </p:nvSpPr>
         <p:spPr>
           <a:xfrm>
-            <a:off x="8068024" y="6196052"/>
+            <a:off x="8068024" y="6949848"/>
             <a:ext cx="3805808" cy="126039"/>
           </a:xfrm>
           <a:prstGeom prst="rect">
@@ -15543,7 +15543,7 @@
         </p:nvSpPr>
         <p:spPr>
           <a:xfrm>
-            <a:off x="12514966" y="4609812"/>
+            <a:off x="13023188" y="5219678"/>
             <a:ext cx="359170" cy="289687"/>
           </a:xfrm>
           <a:prstGeom prst="rect">
@@ -15585,7 +15585,7 @@
         </p:nvSpPr>
         <p:spPr>
           <a:xfrm>
-            <a:off x="12946955" y="4748302"/>
+            <a:off x="13023188" y="5574163"/>
             <a:ext cx="830864" cy="88939"/>
           </a:xfrm>
           <a:prstGeom prst="rect">
@@ -15627,7 +15627,7 @@
         </p:nvSpPr>
         <p:spPr>
           <a:xfrm>
-            <a:off x="12514966" y="5118034"/>
+            <a:off x="13023188" y="5829544"/>
             <a:ext cx="441498" cy="289687"/>
           </a:xfrm>
           <a:prstGeom prst="rect">
@@ -15669,7 +15669,7 @@
         </p:nvSpPr>
         <p:spPr>
           <a:xfrm>
-            <a:off x="12946955" y="5256524"/>
+            <a:off x="13023188" y="6184029"/>
             <a:ext cx="817543" cy="88939"/>
           </a:xfrm>
           <a:prstGeom prst="rect">
@@ -15711,7 +15711,7 @@
         </p:nvSpPr>
         <p:spPr>
           <a:xfrm>
-            <a:off x="12514966" y="5626256"/>
+            <a:off x="13023188" y="6439411"/>
             <a:ext cx="1056665" cy="289687"/>
           </a:xfrm>
           <a:prstGeom prst="rect">
@@ -15753,7 +15753,7 @@
         </p:nvSpPr>
         <p:spPr>
           <a:xfrm>
-            <a:off x="13556821" y="5764746"/>
+            <a:off x="13023188" y="6793896"/>
             <a:ext cx="1113225" cy="88939"/>
           </a:xfrm>
           <a:prstGeom prst="rect">
@@ -15795,7 +15795,7 @@
         </p:nvSpPr>
         <p:spPr>
           <a:xfrm>
-            <a:off x="8068024" y="6659296"/>
+            <a:off x="8068024" y="7540148"/>
             <a:ext cx="1223723" cy="101644"/>
           </a:xfrm>
           <a:prstGeom prst="rect">
@@ -15837,7 +15837,7 @@
         </p:nvSpPr>
         <p:spPr>
           <a:xfrm>
-            <a:off x="9236935" y="6659296"/>
+            <a:off x="9236935" y="7540148"/>
             <a:ext cx="1073917" cy="127055"/>
           </a:xfrm>
           <a:prstGeom prst="rect">
@@ -15879,7 +15879,7 @@
         </p:nvSpPr>
         <p:spPr>
           <a:xfrm>
-            <a:off x="8068024" y="6861632"/>
+            <a:off x="8068024" y="7742484"/>
             <a:ext cx="488667" cy="205195"/>
           </a:xfrm>
           <a:prstGeom prst="rect">
@@ -15921,7 +15921,7 @@
         </p:nvSpPr>
         <p:spPr>
           <a:xfrm>
-            <a:off x="9592690" y="6861632"/>
+            <a:off x="9592690" y="7742484"/>
             <a:ext cx="923892" cy="205195"/>
           </a:xfrm>
           <a:prstGeom prst="rect">
@@ -15963,7 +15963,7 @@
         </p:nvSpPr>
         <p:spPr>
           <a:xfrm>
-            <a:off x="11117356" y="6861632"/>
+            <a:off x="11117356" y="7742484"/>
             <a:ext cx="1659384" cy="205195"/>
           </a:xfrm>
           <a:prstGeom prst="rect">
@@ -16005,7 +16005,7 @@
         </p:nvSpPr>
         <p:spPr>
           <a:xfrm>
-            <a:off x="12794488" y="6856740"/>
+            <a:off x="12794488" y="7737592"/>
             <a:ext cx="829117" cy="252078"/>
           </a:xfrm>
           <a:prstGeom prst="rect">
@@ -16067,7 +16067,7 @@
         </p:nvSpPr>
         <p:spPr>
           <a:xfrm>
-            <a:off x="8068024" y="7294574"/>
+            <a:off x="8068024" y="8302481"/>
             <a:ext cx="1823167" cy="101644"/>
           </a:xfrm>
           <a:prstGeom prst="rect">
@@ -16109,7 +16109,7 @@
         </p:nvSpPr>
         <p:spPr>
           <a:xfrm>
-            <a:off x="9846801" y="7294574"/>
+            <a:off x="9846801" y="8302481"/>
             <a:ext cx="1358025" cy="127055"/>
           </a:xfrm>
           <a:prstGeom prst="rect">
@@ -16151,7 +16151,7 @@
         </p:nvSpPr>
         <p:spPr>
           <a:xfrm>
-            <a:off x="8195079" y="7599507"/>
+            <a:off x="8220491" y="8632825"/>
             <a:ext cx="983509" cy="76233"/>
           </a:xfrm>
           <a:prstGeom prst="rect">
@@ -16193,7 +16193,7 @@
         </p:nvSpPr>
         <p:spPr>
           <a:xfrm>
-            <a:off x="8195079" y="7692702"/>
+            <a:off x="8220491" y="8726021"/>
             <a:ext cx="921053" cy="169365"/>
           </a:xfrm>
           <a:prstGeom prst="rect">
@@ -16235,8 +16235,8 @@
         </p:nvSpPr>
         <p:spPr>
           <a:xfrm>
-            <a:off x="8195079" y="7902566"/>
-            <a:ext cx="2035647" cy="252078"/>
+            <a:off x="8220491" y="8935884"/>
+            <a:ext cx="1949170" cy="252078"/>
           </a:xfrm>
           <a:prstGeom prst="rect">
             <a:avLst/>
@@ -16263,7 +16263,7 @@
                 <a:ea typeface="Noto Sans JP" pitchFamily="34" charset="-122"/>
                 <a:cs typeface="Noto Sans JP" pitchFamily="34" charset="-120"/>
               </a:rPr>
-              <a:t>資源事業は長期にわたる。短期的リターンを求める</a:t>
+              <a:t>資源事業は長期にわたる。短期的リターンを求め</a:t>
             </a:r>
             <a:endParaRPr lang="en-US" sz="620" dirty="0"/>
           </a:p>
@@ -16283,7 +16283,7 @@
                 <a:ea typeface="Noto Sans JP" pitchFamily="34" charset="-122"/>
                 <a:cs typeface="Noto Sans JP" pitchFamily="34" charset="-120"/>
               </a:rPr>
-              <a:t>投資家とは一線を画す。</a:t>
+              <a:t>る投資家とは一線を画す。</a:t>
             </a:r>
             <a:endParaRPr lang="en-US" sz="620" dirty="0"/>
           </a:p>
@@ -16297,7 +16297,7 @@
         </p:nvSpPr>
         <p:spPr>
           <a:xfrm>
-            <a:off x="10431256" y="7599507"/>
+            <a:off x="10456667" y="8632825"/>
             <a:ext cx="806842" cy="76233"/>
           </a:xfrm>
           <a:prstGeom prst="rect">
@@ -16339,7 +16339,7 @@
         </p:nvSpPr>
         <p:spPr>
           <a:xfrm>
-            <a:off x="10431256" y="7692702"/>
+            <a:off x="10456667" y="8726021"/>
             <a:ext cx="1169566" cy="169365"/>
           </a:xfrm>
           <a:prstGeom prst="rect">
@@ -16381,8 +16381,8 @@
         </p:nvSpPr>
         <p:spPr>
           <a:xfrm>
-            <a:off x="10431256" y="7902566"/>
-            <a:ext cx="2035647" cy="126039"/>
+            <a:off x="10456667" y="8935884"/>
+            <a:ext cx="1862693" cy="252078"/>
           </a:xfrm>
           <a:prstGeom prst="rect">
             <a:avLst/>
@@ -16409,10 +16409,30 @@
                 <a:ea typeface="Noto Sans JP" pitchFamily="34" charset="-122"/>
                 <a:cs typeface="Noto Sans JP" pitchFamily="34" charset="-120"/>
               </a:rPr>
-              <a:t>リスクの高い案件ほど、資金面の分担を担保する。</a:t>
+              <a:t>リスクの高い案件ほど、資金面の分担を担保す</a:t>
             </a:r>
             <a:endParaRPr lang="en-US" sz="620" dirty="0"/>
           </a:p>
+          <a:p>
+            <a:pPr algn="l" indent="0" marL="0">
+              <a:lnSpc>
+                <a:spcPts val="992"/>
+              </a:lnSpc>
+              <a:buNone/>
+            </a:pPr>
+            <a:r>
+              <a:rPr lang="en-US" sz="620" dirty="0">
+                <a:solidFill>
+                  <a:srgbClr val="7D838A"/>
+                </a:solidFill>
+                <a:latin typeface="Noto Sans JP" pitchFamily="34" charset="0"/>
+                <a:ea typeface="Noto Sans JP" pitchFamily="34" charset="-122"/>
+                <a:cs typeface="Noto Sans JP" pitchFamily="34" charset="-120"/>
+              </a:rPr>
+              <a:t>る。</a:t>
+            </a:r>
+            <a:endParaRPr lang="en-US" sz="620" dirty="0"/>
+          </a:p>
         </p:txBody>
       </p:sp>
       <p:sp>
@@ -16423,7 +16443,7 @@
         </p:nvSpPr>
         <p:spPr>
           <a:xfrm>
-            <a:off x="12667433" y="7599507"/>
+            <a:off x="12692844" y="8632825"/>
             <a:ext cx="1309982" cy="76233"/>
           </a:xfrm>
           <a:prstGeom prst="rect">
@@ -16465,7 +16485,7 @@
         </p:nvSpPr>
         <p:spPr>
           <a:xfrm>
-            <a:off x="12667433" y="7692702"/>
+            <a:off x="12692844" y="8726021"/>
             <a:ext cx="423809" cy="169365"/>
           </a:xfrm>
           <a:prstGeom prst="rect">
@@ -16507,8 +16527,8 @@
         </p:nvSpPr>
         <p:spPr>
           <a:xfrm>
-            <a:off x="12667433" y="7902566"/>
-            <a:ext cx="2035647" cy="252078"/>
+            <a:off x="12692844" y="8935884"/>
+            <a:ext cx="1949170" cy="252078"/>
           </a:xfrm>
           <a:prstGeom prst="rect">
             <a:avLst/>
@@ -16535,7 +16555,7 @@
                 <a:ea typeface="Noto Sans JP" pitchFamily="34" charset="-122"/>
                 <a:cs typeface="Noto Sans JP" pitchFamily="34" charset="-120"/>
               </a:rPr>
-              <a:t>幅広い産業接点を通じ、多様なバリューチェーンに</a:t>
+              <a:t>幅広い産業接点を通じ、多様なバリューチェーン</a:t>
             </a:r>
             <a:endParaRPr lang="en-US" sz="620" dirty="0"/>
           </a:p>
@@ -16555,7 +16575,7 @@
                 <a:ea typeface="Noto Sans JP" pitchFamily="34" charset="-122"/>
                 <a:cs typeface="Noto Sans JP" pitchFamily="34" charset="-120"/>
               </a:rPr>
-              <a:t>知見を提供する。</a:t>
+              <a:t>に知見を提供する。</a:t>
             </a:r>
             <a:endParaRPr lang="en-US" sz="620" dirty="0"/>
           </a:p>

</xml_diff>

<commit_message>
台割 案3 v2改: full-width hairline band at timeline, show 01 numeral clearly
Co-Authored-By: Claude Opus 5.5 <noreply@anthropic.com>
Claude-Session: https://claude.ai/code/session_01RaAHJjFzQLBQzv3hdCW4ED
</commit_message>
<xml_diff>
--- a/cover-proposals/v13_1007_case3_v2plus/台割案3_v2改_P02-11_編集用.pptx
+++ b/cover-proposals/v13_1007_case3_v2plus/台割案3_v2改_P02-11_編集用.pptx
@@ -4047,27 +4047,27 @@
         </p:nvSpPr>
         <p:spPr>
           <a:xfrm>
-            <a:off x="3811665" y="101644"/>
-            <a:ext cx="2821585" cy="2337821"/>
-          </a:xfrm>
-          <a:prstGeom prst="rect">
-            <a:avLst/>
-          </a:prstGeom>
-          <a:noFill/>
-          <a:ln/>
-        </p:spPr>
-        <p:txBody>
-          <a:bodyPr wrap="none" lIns="0" tIns="0" rIns="0" bIns="0" rtlCol="0" anchor="t"/>
-          <a:lstStyle/>
-          <a:p>
-            <a:pPr algn="l" indent="0" marL="0">
-              <a:lnSpc>
-                <a:spcPts val="18400"/>
-              </a:lnSpc>
-              <a:buNone/>
-            </a:pPr>
-            <a:r>
-              <a:rPr lang="en-US" sz="23000" spc="-920" kern="0" dirty="0">
+            <a:off x="3811665" y="0"/>
+            <a:ext cx="2339628" cy="1931244"/>
+          </a:xfrm>
+          <a:prstGeom prst="rect">
+            <a:avLst/>
+          </a:prstGeom>
+          <a:noFill/>
+          <a:ln/>
+        </p:spPr>
+        <p:txBody>
+          <a:bodyPr wrap="none" lIns="0" tIns="0" rIns="0" bIns="0" rtlCol="0" anchor="t"/>
+          <a:lstStyle/>
+          <a:p>
+            <a:pPr algn="l" indent="0" marL="0">
+              <a:lnSpc>
+                <a:spcPts val="15200"/>
+              </a:lnSpc>
+              <a:buNone/>
+            </a:pPr>
+            <a:r>
+              <a:rPr lang="en-US" sz="19000" spc="-760" kern="0" dirty="0">
                 <a:solidFill>
                   <a:srgbClr val="000000">
                     <a:alpha val="0"/>
@@ -4079,7 +4079,7 @@
               </a:rPr>
               <a:t>01</a:t>
             </a:r>
-            <a:endParaRPr lang="en-US" sz="23000" dirty="0"/>
+            <a:endParaRPr lang="en-US" sz="19000" dirty="0"/>
           </a:p>
         </p:txBody>
       </p:sp>
@@ -4091,27 +4091,27 @@
         </p:nvSpPr>
         <p:spPr>
           <a:xfrm>
-            <a:off x="11434995" y="101644"/>
-            <a:ext cx="3529344" cy="2337821"/>
-          </a:xfrm>
-          <a:prstGeom prst="rect">
-            <a:avLst/>
-          </a:prstGeom>
-          <a:noFill/>
-          <a:ln/>
-        </p:spPr>
-        <p:txBody>
-          <a:bodyPr wrap="none" lIns="0" tIns="0" rIns="0" bIns="0" rtlCol="0" anchor="t"/>
-          <a:lstStyle/>
-          <a:p>
-            <a:pPr algn="l" indent="0" marL="0">
-              <a:lnSpc>
-                <a:spcPts val="18400"/>
-              </a:lnSpc>
-              <a:buNone/>
-            </a:pPr>
-            <a:r>
-              <a:rPr lang="en-US" sz="23000" spc="-920" kern="0" dirty="0">
+            <a:off x="11434995" y="0"/>
+            <a:ext cx="2924440" cy="1931244"/>
+          </a:xfrm>
+          <a:prstGeom prst="rect">
+            <a:avLst/>
+          </a:prstGeom>
+          <a:noFill/>
+          <a:ln/>
+        </p:spPr>
+        <p:txBody>
+          <a:bodyPr wrap="none" lIns="0" tIns="0" rIns="0" bIns="0" rtlCol="0" anchor="t"/>
+          <a:lstStyle/>
+          <a:p>
+            <a:pPr algn="l" indent="0" marL="0">
+              <a:lnSpc>
+                <a:spcPts val="15200"/>
+              </a:lnSpc>
+              <a:buNone/>
+            </a:pPr>
+            <a:r>
+              <a:rPr lang="en-US" sz="19000" spc="-760" kern="0" dirty="0">
                 <a:solidFill>
                   <a:srgbClr val="000000">
                     <a:alpha val="0"/>
@@ -4123,7 +4123,7 @@
               </a:rPr>
               <a:t>02</a:t>
             </a:r>
-            <a:endParaRPr lang="en-US" sz="23000" dirty="0"/>
+            <a:endParaRPr lang="en-US" sz="19000" dirty="0"/>
           </a:p>
         </p:txBody>
       </p:sp>
@@ -4425,7 +4425,7 @@
         </p:nvSpPr>
         <p:spPr>
           <a:xfrm>
-            <a:off x="4116598" y="1396022"/>
+            <a:off x="4116598" y="1777189"/>
             <a:ext cx="1143360" cy="101644"/>
           </a:xfrm>
           <a:prstGeom prst="rect">
@@ -4467,7 +4467,7 @@
         </p:nvSpPr>
         <p:spPr>
           <a:xfrm>
-            <a:off x="4116598" y="1592704"/>
+            <a:off x="4116598" y="1973871"/>
             <a:ext cx="3021836" cy="573274"/>
           </a:xfrm>
           <a:prstGeom prst="rect">
@@ -4549,7 +4549,7 @@
         </p:nvSpPr>
         <p:spPr>
           <a:xfrm>
-            <a:off x="4116598" y="2330388"/>
+            <a:off x="4116598" y="2711555"/>
             <a:ext cx="2877271" cy="252078"/>
           </a:xfrm>
           <a:prstGeom prst="rect">
@@ -11918,26 +11918,26 @@
         <p:spPr>
           <a:xfrm>
             <a:off x="4192831" y="101644"/>
-            <a:ext cx="3587432" cy="2337821"/>
-          </a:xfrm>
-          <a:prstGeom prst="rect">
-            <a:avLst/>
-          </a:prstGeom>
-          <a:noFill/>
-          <a:ln/>
-        </p:spPr>
-        <p:txBody>
-          <a:bodyPr wrap="none" lIns="0" tIns="0" rIns="0" bIns="0" rtlCol="0" anchor="t"/>
-          <a:lstStyle/>
-          <a:p>
-            <a:pPr algn="l" indent="0" marL="0">
-              <a:lnSpc>
-                <a:spcPts val="18400"/>
-              </a:lnSpc>
-              <a:buNone/>
-            </a:pPr>
-            <a:r>
-              <a:rPr lang="en-US" sz="23000" spc="-920" kern="0" dirty="0">
+            <a:ext cx="2972483" cy="1931244"/>
+          </a:xfrm>
+          <a:prstGeom prst="rect">
+            <a:avLst/>
+          </a:prstGeom>
+          <a:noFill/>
+          <a:ln/>
+        </p:spPr>
+        <p:txBody>
+          <a:bodyPr wrap="none" lIns="0" tIns="0" rIns="0" bIns="0" rtlCol="0" anchor="t"/>
+          <a:lstStyle/>
+          <a:p>
+            <a:pPr algn="l" indent="0" marL="0">
+              <a:lnSpc>
+                <a:spcPts val="15200"/>
+              </a:lnSpc>
+              <a:buNone/>
+            </a:pPr>
+            <a:r>
+              <a:rPr lang="en-US" sz="19000" spc="-760" kern="0" dirty="0">
                 <a:solidFill>
                   <a:srgbClr val="000000">
                     <a:alpha val="0"/>
@@ -11949,7 +11949,7 @@
               </a:rPr>
               <a:t>03</a:t>
             </a:r>
-            <a:endParaRPr lang="en-US" sz="23000" dirty="0"/>
+            <a:endParaRPr lang="en-US" sz="19000" dirty="0"/>
           </a:p>
         </p:txBody>
       </p:sp>
@@ -11962,26 +11962,26 @@
         <p:spPr>
           <a:xfrm>
             <a:off x="11816161" y="101644"/>
-            <a:ext cx="3578042" cy="2337821"/>
-          </a:xfrm>
-          <a:prstGeom prst="rect">
-            <a:avLst/>
-          </a:prstGeom>
-          <a:noFill/>
-          <a:ln/>
-        </p:spPr>
-        <p:txBody>
-          <a:bodyPr wrap="none" lIns="0" tIns="0" rIns="0" bIns="0" rtlCol="0" anchor="t"/>
-          <a:lstStyle/>
-          <a:p>
-            <a:pPr algn="l" indent="0" marL="0">
-              <a:lnSpc>
-                <a:spcPts val="18400"/>
-              </a:lnSpc>
-              <a:buNone/>
-            </a:pPr>
-            <a:r>
-              <a:rPr lang="en-US" sz="23000" spc="-920" kern="0" dirty="0">
+            <a:ext cx="2964622" cy="1931244"/>
+          </a:xfrm>
+          <a:prstGeom prst="rect">
+            <a:avLst/>
+          </a:prstGeom>
+          <a:noFill/>
+          <a:ln/>
+        </p:spPr>
+        <p:txBody>
+          <a:bodyPr wrap="none" lIns="0" tIns="0" rIns="0" bIns="0" rtlCol="0" anchor="t"/>
+          <a:lstStyle/>
+          <a:p>
+            <a:pPr algn="l" indent="0" marL="0">
+              <a:lnSpc>
+                <a:spcPts val="15200"/>
+              </a:lnSpc>
+              <a:buNone/>
+            </a:pPr>
+            <a:r>
+              <a:rPr lang="en-US" sz="19000" spc="-760" kern="0" dirty="0">
                 <a:solidFill>
                   <a:srgbClr val="000000">
                     <a:alpha val="0"/>
@@ -11993,7 +11993,7 @@
               </a:rPr>
               <a:t>04</a:t>
             </a:r>
-            <a:endParaRPr lang="en-US" sz="23000" dirty="0"/>
+            <a:endParaRPr lang="en-US" sz="19000" dirty="0"/>
           </a:p>
         </p:txBody>
       </p:sp>
@@ -16817,26 +16817,26 @@
         <p:spPr>
           <a:xfrm>
             <a:off x="10926773" y="101644"/>
-            <a:ext cx="3460337" cy="2337821"/>
-          </a:xfrm>
-          <a:prstGeom prst="rect">
-            <a:avLst/>
-          </a:prstGeom>
-          <a:noFill/>
-          <a:ln/>
-        </p:spPr>
-        <p:txBody>
-          <a:bodyPr wrap="none" lIns="0" tIns="0" rIns="0" bIns="0" rtlCol="0" anchor="t"/>
-          <a:lstStyle/>
-          <a:p>
-            <a:pPr algn="l" indent="0" marL="0">
-              <a:lnSpc>
-                <a:spcPts val="18400"/>
-              </a:lnSpc>
-              <a:buNone/>
-            </a:pPr>
-            <a:r>
-              <a:rPr lang="en-US" sz="23000" spc="-920" kern="0" dirty="0">
+            <a:ext cx="2867444" cy="1931244"/>
+          </a:xfrm>
+          <a:prstGeom prst="rect">
+            <a:avLst/>
+          </a:prstGeom>
+          <a:noFill/>
+          <a:ln/>
+        </p:spPr>
+        <p:txBody>
+          <a:bodyPr wrap="none" lIns="0" tIns="0" rIns="0" bIns="0" rtlCol="0" anchor="t"/>
+          <a:lstStyle/>
+          <a:p>
+            <a:pPr algn="l" indent="0" marL="0">
+              <a:lnSpc>
+                <a:spcPts val="15200"/>
+              </a:lnSpc>
+              <a:buNone/>
+            </a:pPr>
+            <a:r>
+              <a:rPr lang="en-US" sz="19000" spc="-760" kern="0" dirty="0">
                 <a:solidFill>
                   <a:srgbClr val="000000">
                     <a:alpha val="0"/>
@@ -16848,7 +16848,7 @@
               </a:rPr>
               <a:t>05</a:t>
             </a:r>
-            <a:endParaRPr lang="en-US" sz="23000" dirty="0"/>
+            <a:endParaRPr lang="en-US" sz="19000" dirty="0"/>
           </a:p>
         </p:txBody>
       </p:sp>

</xml_diff>

<commit_message>
Copper headline: 'The partner the copper industry calls first.' (case 2 & 3), proposal text updated
Co-Authored-By: Claude Opus 5.5 <noreply@anthropic.com>
Claude-Session: https://claude.ai/code/session_01RaAHJjFzQLBQzv3hdCW4ED
</commit_message>
<xml_diff>
--- a/cover-proposals/v13_1007_case3_v2plus/台割案3_v2改_P02-11_編集用.pptx
+++ b/cover-proposals/v13_1007_case3_v2plus/台割案3_v2改_P02-11_編集用.pptx
@@ -9335,7 +9335,7 @@
         <p:spPr>
           <a:xfrm>
             <a:off x="8068024" y="4468542"/>
-            <a:ext cx="5779060" cy="777580"/>
+            <a:ext cx="4184692" cy="777580"/>
           </a:xfrm>
           <a:prstGeom prst="rect">
             <a:avLst/>
@@ -9362,7 +9362,7 @@
                 <a:ea typeface="Inter Tight SemiBold" pitchFamily="34" charset="-122"/>
                 <a:cs typeface="Inter Tight SemiBold" pitchFamily="34" charset="-120"/>
               </a:rPr>
-              <a:t>The world's largest</a:t>
+              <a:t>The partner the copper</a:t>
             </a:r>
             <a:endParaRPr lang="en-US" sz="3000" dirty="0"/>
           </a:p>
@@ -9382,7 +9382,7 @@
                 <a:ea typeface="Inter Tight SemiBold" pitchFamily="34" charset="-122"/>
                 <a:cs typeface="Inter Tight SemiBold" pitchFamily="34" charset="-120"/>
               </a:rPr>
-              <a:t>non-operating copper producer.</a:t>
+              <a:t>industry calls first.</a:t>
             </a:r>
             <a:endParaRPr lang="en-US" sz="3000" dirty="0"/>
           </a:p>

</xml_diff>

<commit_message>
台割 案2/案3: fix RtM founding timing in journey, remove on-page design notes, tighten copy
Co-Authored-By: Claude Opus 5.5 <noreply@anthropic.com>
Claude-Session: https://claude.ai/code/session_01RaAHJjFzQLBQzv3hdCW4ED
</commit_message>
<xml_diff>
--- a/cover-proposals/v13_1007_case3_v2plus/台割案3_v2改_P02-11_編集用.pptx
+++ b/cover-proposals/v13_1007_case3_v2plus/台割案3_v2改_P02-11_編集用.pptx
@@ -2396,27 +2396,69 @@
         </p:nvSpPr>
         <p:spPr>
           <a:xfrm>
-            <a:off x="4319887" y="8000430"/>
-            <a:ext cx="955120" cy="109776"/>
-          </a:xfrm>
-          <a:prstGeom prst="rect">
-            <a:avLst/>
-          </a:prstGeom>
-          <a:noFill/>
-          <a:ln/>
-        </p:spPr>
-        <p:txBody>
-          <a:bodyPr wrap="none" lIns="0" tIns="0" rIns="0" bIns="0" rtlCol="0" anchor="t"/>
-          <a:lstStyle/>
-          <a:p>
-            <a:pPr algn="l" indent="0" marL="0">
-              <a:lnSpc>
-                <a:spcPts val="864"/>
-              </a:lnSpc>
-              <a:buNone/>
-            </a:pPr>
-            <a:r>
-              <a:rPr lang="en-US" sz="540" dirty="0">
+            <a:off x="6162192" y="8156963"/>
+            <a:ext cx="432108" cy="101644"/>
+          </a:xfrm>
+          <a:prstGeom prst="rect">
+            <a:avLst/>
+          </a:prstGeom>
+          <a:noFill/>
+          <a:ln/>
+        </p:spPr>
+        <p:txBody>
+          <a:bodyPr wrap="none" lIns="0" tIns="0" rIns="0" bIns="0" rtlCol="0" anchor="t"/>
+          <a:lstStyle/>
+          <a:p>
+            <a:pPr algn="l" indent="0" marL="0">
+              <a:lnSpc>
+                <a:spcPts val="800"/>
+              </a:lnSpc>
+              <a:buNone/>
+            </a:pPr>
+            <a:r>
+              <a:rPr lang="en-US" sz="640" spc="30" kern="0" dirty="0">
+                <a:solidFill>
+                  <a:srgbClr val="121519"/>
+                </a:solidFill>
+                <a:latin typeface="Inter Medium" pitchFamily="34" charset="0"/>
+                <a:ea typeface="Inter Medium" pitchFamily="34" charset="-122"/>
+                <a:cs typeface="Inter Medium" pitchFamily="34" charset="-120"/>
+              </a:rPr>
+              <a:t>Demand</a:t>
+            </a:r>
+            <a:endParaRPr lang="en-US" sz="640" dirty="0"/>
+          </a:p>
+        </p:txBody>
+      </p:sp>
+      <p:sp>
+        <p:nvSpPr>
+          <p:cNvPr id="28" name="Text 26"/>
+          <p:cNvSpPr/>
+          <p:nvPr/>
+        </p:nvSpPr>
+        <p:spPr>
+          <a:xfrm>
+            <a:off x="6162192" y="8265214"/>
+            <a:ext cx="520114" cy="113842"/>
+          </a:xfrm>
+          <a:prstGeom prst="rect">
+            <a:avLst/>
+          </a:prstGeom>
+          <a:noFill/>
+          <a:ln/>
+        </p:spPr>
+        <p:txBody>
+          <a:bodyPr wrap="none" lIns="0" tIns="0" rIns="0" bIns="0" rtlCol="0" anchor="t"/>
+          <a:lstStyle/>
+          <a:p>
+            <a:pPr algn="l" indent="0" marL="0">
+              <a:lnSpc>
+                <a:spcPts val="896"/>
+              </a:lnSpc>
+              <a:buNone/>
+            </a:pPr>
+            <a:r>
+              <a:rPr lang="en-US" sz="560" dirty="0">
                 <a:solidFill>
                   <a:srgbClr val="7D838A"/>
                 </a:solidFill>
@@ -2424,22 +2466,22 @@
                 <a:ea typeface="Noto Sans JP" pitchFamily="34" charset="-122"/>
                 <a:cs typeface="Noto Sans JP" pitchFamily="34" charset="-120"/>
               </a:rPr>
-              <a:t>概念図（数値は入れない）</a:t>
-            </a:r>
-            <a:endParaRPr lang="en-US" sz="540" dirty="0"/>
-          </a:p>
-        </p:txBody>
-      </p:sp>
-      <p:sp>
-        <p:nvSpPr>
-          <p:cNvPr id="28" name="Text 26"/>
-          <p:cNvSpPr/>
-          <p:nvPr/>
-        </p:nvSpPr>
-        <p:spPr>
-          <a:xfrm>
-            <a:off x="6162192" y="8156963"/>
-            <a:ext cx="432108" cy="101644"/>
+              <a:t>人口増・電化</a:t>
+            </a:r>
+            <a:endParaRPr lang="en-US" sz="560" dirty="0"/>
+          </a:p>
+        </p:txBody>
+      </p:sp>
+      <p:sp>
+        <p:nvSpPr>
+          <p:cNvPr id="29" name="Text 27"/>
+          <p:cNvSpPr/>
+          <p:nvPr/>
+        </p:nvSpPr>
+        <p:spPr>
+          <a:xfrm>
+            <a:off x="6263836" y="8817651"/>
+            <a:ext cx="372491" cy="101644"/>
           </a:xfrm>
           <a:prstGeom prst="rect">
             <a:avLst/>
@@ -2460,13 +2502,13 @@
             <a:r>
               <a:rPr lang="en-US" sz="640" spc="30" kern="0" dirty="0">
                 <a:solidFill>
-                  <a:srgbClr val="121519"/>
+                  <a:srgbClr val="7D838A"/>
                 </a:solidFill>
                 <a:latin typeface="Inter Medium" pitchFamily="34" charset="0"/>
                 <a:ea typeface="Inter Medium" pitchFamily="34" charset="-122"/>
                 <a:cs typeface="Inter Medium" pitchFamily="34" charset="-120"/>
               </a:rPr>
-              <a:t>Demand</a:t>
+              <a:t>Supply</a:t>
             </a:r>
             <a:endParaRPr lang="en-US" sz="640" dirty="0"/>
           </a:p>
@@ -2474,14 +2516,14 @@
       </p:sp>
       <p:sp>
         <p:nvSpPr>
-          <p:cNvPr id="29" name="Text 27"/>
-          <p:cNvSpPr/>
-          <p:nvPr/>
-        </p:nvSpPr>
-        <p:spPr>
-          <a:xfrm>
-            <a:off x="6162192" y="8265214"/>
-            <a:ext cx="520114" cy="113842"/>
+          <p:cNvPr id="30" name="Text 28"/>
+          <p:cNvSpPr/>
+          <p:nvPr/>
+        </p:nvSpPr>
+        <p:spPr>
+          <a:xfrm>
+            <a:off x="6263836" y="8925903"/>
+            <a:ext cx="676471" cy="113842"/>
           </a:xfrm>
           <a:prstGeom prst="rect">
             <a:avLst/>
@@ -2508,7 +2550,7 @@
                 <a:ea typeface="Noto Sans JP" pitchFamily="34" charset="-122"/>
                 <a:cs typeface="Noto Sans JP" pitchFamily="34" charset="-120"/>
               </a:rPr>
-              <a:t>人口増・電化</a:t>
+              <a:t>供給制約・地政学</a:t>
             </a:r>
             <a:endParaRPr lang="en-US" sz="560" dirty="0"/>
           </a:p>
@@ -2516,14 +2558,14 @@
       </p:sp>
       <p:sp>
         <p:nvSpPr>
-          <p:cNvPr id="30" name="Text 28"/>
-          <p:cNvSpPr/>
-          <p:nvPr/>
-        </p:nvSpPr>
-        <p:spPr>
-          <a:xfrm>
-            <a:off x="6263836" y="8817651"/>
-            <a:ext cx="372491" cy="101644"/>
+          <p:cNvPr id="31" name="Text 29"/>
+          <p:cNvSpPr/>
+          <p:nvPr/>
+        </p:nvSpPr>
+        <p:spPr>
+          <a:xfrm>
+            <a:off x="5730203" y="8716007"/>
+            <a:ext cx="323575" cy="101644"/>
           </a:xfrm>
           <a:prstGeom prst="rect">
             <a:avLst/>
@@ -2542,15 +2584,493 @@
               <a:buNone/>
             </a:pPr>
             <a:r>
+              <a:rPr lang="en-US" sz="660" spc="190" kern="0" dirty="0">
+                <a:solidFill>
+                  <a:srgbClr val="9C7442"/>
+                </a:solidFill>
+                <a:latin typeface="Inter SemiBold" pitchFamily="34" charset="0"/>
+                <a:ea typeface="Inter SemiBold" pitchFamily="34" charset="-122"/>
+                <a:cs typeface="Inter SemiBold" pitchFamily="34" charset="-120"/>
+              </a:rPr>
+              <a:t>GAP</a:t>
+            </a:r>
+            <a:endParaRPr lang="en-US" sz="660" dirty="0"/>
+          </a:p>
+        </p:txBody>
+      </p:sp>
+      <p:sp>
+        <p:nvSpPr>
+          <p:cNvPr id="32" name="Text 30"/>
+          <p:cNvSpPr/>
+          <p:nvPr/>
+        </p:nvSpPr>
+        <p:spPr>
+          <a:xfrm>
+            <a:off x="4396120" y="9372630"/>
+            <a:ext cx="264395" cy="109776"/>
+          </a:xfrm>
+          <a:prstGeom prst="rect">
+            <a:avLst/>
+          </a:prstGeom>
+          <a:noFill/>
+          <a:ln/>
+        </p:spPr>
+        <p:txBody>
+          <a:bodyPr wrap="none" lIns="0" tIns="0" rIns="0" bIns="0" rtlCol="0" anchor="t"/>
+          <a:lstStyle/>
+          <a:p>
+            <a:pPr algn="l" indent="0" marL="0">
+              <a:lnSpc>
+                <a:spcPts val="864"/>
+              </a:lnSpc>
+              <a:buNone/>
+            </a:pPr>
+            <a:r>
+              <a:rPr lang="en-US" sz="540" dirty="0">
+                <a:solidFill>
+                  <a:srgbClr val="7D838A"/>
+                </a:solidFill>
+                <a:latin typeface="Noto Sans JP" pitchFamily="34" charset="0"/>
+                <a:ea typeface="Noto Sans JP" pitchFamily="34" charset="-122"/>
+                <a:cs typeface="Noto Sans JP" pitchFamily="34" charset="-120"/>
+              </a:rPr>
+              <a:t>Today</a:t>
+            </a:r>
+            <a:endParaRPr lang="en-US" sz="540" dirty="0"/>
+          </a:p>
+        </p:txBody>
+      </p:sp>
+      <p:sp>
+        <p:nvSpPr>
+          <p:cNvPr id="33" name="Text 31"/>
+          <p:cNvSpPr/>
+          <p:nvPr/>
+        </p:nvSpPr>
+        <p:spPr>
+          <a:xfrm>
+            <a:off x="6543358" y="9372630"/>
+            <a:ext cx="280773" cy="109776"/>
+          </a:xfrm>
+          <a:prstGeom prst="rect">
+            <a:avLst/>
+          </a:prstGeom>
+          <a:noFill/>
+          <a:ln/>
+        </p:spPr>
+        <p:txBody>
+          <a:bodyPr wrap="none" lIns="0" tIns="0" rIns="0" bIns="0" rtlCol="0" anchor="t"/>
+          <a:lstStyle/>
+          <a:p>
+            <a:pPr algn="l" indent="0" marL="0">
+              <a:lnSpc>
+                <a:spcPts val="864"/>
+              </a:lnSpc>
+              <a:buNone/>
+            </a:pPr>
+            <a:r>
+              <a:rPr lang="en-US" sz="540" dirty="0">
+                <a:solidFill>
+                  <a:srgbClr val="7D838A"/>
+                </a:solidFill>
+                <a:latin typeface="Noto Sans JP" pitchFamily="34" charset="0"/>
+                <a:ea typeface="Noto Sans JP" pitchFamily="34" charset="-122"/>
+                <a:cs typeface="Noto Sans JP" pitchFamily="34" charset="-120"/>
+              </a:rPr>
+              <a:t>Future</a:t>
+            </a:r>
+            <a:endParaRPr lang="en-US" sz="540" dirty="0"/>
+          </a:p>
+        </p:txBody>
+      </p:sp>
+      <p:sp>
+        <p:nvSpPr>
+          <p:cNvPr id="34" name="Text 32"/>
+          <p:cNvSpPr/>
+          <p:nvPr/>
+        </p:nvSpPr>
+        <p:spPr>
+          <a:xfrm>
+            <a:off x="8068024" y="5565031"/>
+            <a:ext cx="1095318" cy="101644"/>
+          </a:xfrm>
+          <a:prstGeom prst="rect">
+            <a:avLst/>
+          </a:prstGeom>
+          <a:noFill/>
+          <a:ln/>
+        </p:spPr>
+        <p:txBody>
+          <a:bodyPr wrap="none" lIns="0" tIns="0" rIns="0" bIns="0" rtlCol="0" anchor="t"/>
+          <a:lstStyle/>
+          <a:p>
+            <a:pPr algn="l" indent="0" marL="0">
+              <a:lnSpc>
+                <a:spcPts val="800"/>
+              </a:lnSpc>
+              <a:buNone/>
+            </a:pPr>
+            <a:r>
+              <a:rPr lang="en-US" sz="660" spc="190" kern="0" dirty="0">
+                <a:solidFill>
+                  <a:srgbClr val="9C7442"/>
+                </a:solidFill>
+                <a:latin typeface="Inter SemiBold" pitchFamily="34" charset="0"/>
+                <a:ea typeface="Inter SemiBold" pitchFamily="34" charset="-122"/>
+                <a:cs typeface="Inter SemiBold" pitchFamily="34" charset="-120"/>
+              </a:rPr>
+              <a:t>CORE MESSAGE</a:t>
+            </a:r>
+            <a:endParaRPr lang="en-US" sz="660" dirty="0"/>
+          </a:p>
+        </p:txBody>
+      </p:sp>
+      <p:sp>
+        <p:nvSpPr>
+          <p:cNvPr id="35" name="Text 33"/>
+          <p:cNvSpPr/>
+          <p:nvPr/>
+        </p:nvSpPr>
+        <p:spPr>
+          <a:xfrm>
+            <a:off x="8068024" y="5704792"/>
+            <a:ext cx="748317" cy="127055"/>
+          </a:xfrm>
+          <a:prstGeom prst="rect">
+            <a:avLst/>
+          </a:prstGeom>
+          <a:noFill/>
+          <a:ln/>
+        </p:spPr>
+        <p:txBody>
+          <a:bodyPr wrap="none" lIns="0" tIns="0" rIns="0" bIns="0" rtlCol="0" anchor="t"/>
+          <a:lstStyle/>
+          <a:p>
+            <a:pPr algn="l" indent="0" marL="0">
+              <a:lnSpc>
+                <a:spcPts val="1000"/>
+              </a:lnSpc>
+              <a:buNone/>
+            </a:pPr>
+            <a:r>
+              <a:rPr lang="en-US" sz="660" spc="60" kern="0" dirty="0">
+                <a:solidFill>
+                  <a:srgbClr val="7D838A"/>
+                </a:solidFill>
+                <a:latin typeface="Noto Sans JP" pitchFamily="34" charset="0"/>
+                <a:ea typeface="Noto Sans JP" pitchFamily="34" charset="-122"/>
+                <a:cs typeface="Noto Sans JP" pitchFamily="34" charset="-120"/>
+              </a:rPr>
+              <a:t>コアメッセージ</a:t>
+            </a:r>
+            <a:endParaRPr lang="en-US" sz="660" dirty="0"/>
+          </a:p>
+        </p:txBody>
+      </p:sp>
+      <p:sp>
+        <p:nvSpPr>
+          <p:cNvPr id="36" name="Text 34"/>
+          <p:cNvSpPr/>
+          <p:nvPr/>
+        </p:nvSpPr>
+        <p:spPr>
+          <a:xfrm>
+            <a:off x="8068024" y="5964620"/>
+            <a:ext cx="4628652" cy="1120629"/>
+          </a:xfrm>
+          <a:prstGeom prst="rect">
+            <a:avLst/>
+          </a:prstGeom>
+          <a:noFill/>
+          <a:ln/>
+        </p:spPr>
+        <p:txBody>
+          <a:bodyPr wrap="none" lIns="0" tIns="0" rIns="0" bIns="0" rtlCol="0" anchor="t"/>
+          <a:lstStyle/>
+          <a:p>
+            <a:pPr algn="l" indent="0" marL="0">
+              <a:lnSpc>
+                <a:spcPts val="4410"/>
+              </a:lnSpc>
+              <a:buNone/>
+            </a:pPr>
+            <a:r>
+              <a:rPr lang="en-US" sz="4200" spc="-84" kern="0" dirty="0">
+                <a:solidFill>
+                  <a:srgbClr val="121519"/>
+                </a:solidFill>
+                <a:latin typeface="Inter Tight Light" pitchFamily="34" charset="0"/>
+                <a:ea typeface="Inter Tight Light" pitchFamily="34" charset="-122"/>
+                <a:cs typeface="Inter Tight Light" pitchFamily="34" charset="-120"/>
+              </a:rPr>
+              <a:t>Strength to Hold.</a:t>
+            </a:r>
+            <a:endParaRPr lang="en-US" sz="4200" dirty="0"/>
+          </a:p>
+          <a:p>
+            <a:pPr algn="l" indent="0" marL="0">
+              <a:lnSpc>
+                <a:spcPts val="4410"/>
+              </a:lnSpc>
+              <a:buNone/>
+            </a:pPr>
+            <a:r>
+              <a:rPr lang="en-US" sz="4200" spc="-84" kern="0" dirty="0">
+                <a:solidFill>
+                  <a:srgbClr val="121519"/>
+                </a:solidFill>
+                <a:latin typeface="Inter Tight Light" pitchFamily="34" charset="0"/>
+                <a:ea typeface="Inter Tight Light" pitchFamily="34" charset="-122"/>
+                <a:cs typeface="Inter Tight Light" pitchFamily="34" charset="-120"/>
+              </a:rPr>
+              <a:t>Power to Connect.</a:t>
+            </a:r>
+            <a:endParaRPr lang="en-US" sz="4200" dirty="0"/>
+          </a:p>
+        </p:txBody>
+      </p:sp>
+      <p:sp>
+        <p:nvSpPr>
+          <p:cNvPr id="37" name="Text 35"/>
+          <p:cNvSpPr/>
+          <p:nvPr/>
+        </p:nvSpPr>
+        <p:spPr>
+          <a:xfrm>
+            <a:off x="8068024" y="7188165"/>
+            <a:ext cx="1930390" cy="247758"/>
+          </a:xfrm>
+          <a:prstGeom prst="rect">
+            <a:avLst/>
+          </a:prstGeom>
+          <a:noFill/>
+          <a:ln/>
+        </p:spPr>
+        <p:txBody>
+          <a:bodyPr wrap="none" lIns="0" tIns="0" rIns="0" bIns="0" rtlCol="0" anchor="t"/>
+          <a:lstStyle/>
+          <a:p>
+            <a:pPr algn="l" indent="0" marL="0">
+              <a:lnSpc>
+                <a:spcPts val="1950"/>
+              </a:lnSpc>
+              <a:buNone/>
+            </a:pPr>
+            <a:r>
+              <a:rPr lang="en-US" sz="1300" spc="50" kern="0" dirty="0">
+                <a:solidFill>
+                  <a:srgbClr val="121519"/>
+                </a:solidFill>
+                <a:latin typeface="Noto Sans JP Medium" pitchFamily="34" charset="0"/>
+                <a:ea typeface="Noto Sans JP Medium" pitchFamily="34" charset="-122"/>
+                <a:cs typeface="Noto Sans JP Medium" pitchFamily="34" charset="-120"/>
+              </a:rPr>
+              <a:t>持つ力と、つなぐ力。</a:t>
+            </a:r>
+            <a:endParaRPr lang="en-US" sz="1300" dirty="0"/>
+          </a:p>
+        </p:txBody>
+      </p:sp>
+      <p:sp>
+        <p:nvSpPr>
+          <p:cNvPr id="38" name="Text 36"/>
+          <p:cNvSpPr/>
+          <p:nvPr/>
+        </p:nvSpPr>
+        <p:spPr>
+          <a:xfrm>
+            <a:off x="8068024" y="7488365"/>
+            <a:ext cx="4243654" cy="904953"/>
+          </a:xfrm>
+          <a:prstGeom prst="rect">
+            <a:avLst/>
+          </a:prstGeom>
+          <a:noFill/>
+          <a:ln/>
+        </p:spPr>
+        <p:txBody>
+          <a:bodyPr wrap="none" lIns="0" tIns="0" rIns="0" bIns="0" rtlCol="0" anchor="t"/>
+          <a:lstStyle/>
+          <a:p>
+            <a:pPr algn="l" indent="0" marL="0">
+              <a:lnSpc>
+                <a:spcPts val="1425"/>
+              </a:lnSpc>
+              <a:buNone/>
+            </a:pPr>
+            <a:r>
+              <a:rPr lang="en-US" sz="770" spc="20" kern="0" dirty="0">
+                <a:solidFill>
+                  <a:srgbClr val="3D4249"/>
+                </a:solidFill>
+                <a:latin typeface="Noto Sans JP" pitchFamily="34" charset="0"/>
+                <a:ea typeface="Noto Sans JP" pitchFamily="34" charset="-122"/>
+                <a:cs typeface="Noto Sans JP" pitchFamily="34" charset="-120"/>
+              </a:rPr>
+              <a:t>資源は、そこに「ある」だけでは、まだ価値ではありません。誰かが見出し、育て、</a:t>
+            </a:r>
+            <a:endParaRPr lang="en-US" sz="770" dirty="0"/>
+          </a:p>
+          <a:p>
+            <a:pPr algn="l" indent="0" marL="0">
+              <a:lnSpc>
+                <a:spcPts val="1425"/>
+              </a:lnSpc>
+              <a:buNone/>
+            </a:pPr>
+            <a:r>
+              <a:rPr lang="en-US" sz="770" spc="20" kern="0" dirty="0">
+                <a:solidFill>
+                  <a:srgbClr val="3D4249"/>
+                </a:solidFill>
+                <a:latin typeface="Noto Sans JP" pitchFamily="34" charset="0"/>
+                <a:ea typeface="Noto Sans JP" pitchFamily="34" charset="-122"/>
+                <a:cs typeface="Noto Sans JP" pitchFamily="34" charset="-120"/>
+              </a:rPr>
+              <a:t>必要とする場所へ届けて、はじめて力になる。私たちは、世界有数の資産に関わり、</a:t>
+            </a:r>
+            <a:endParaRPr lang="en-US" sz="770" dirty="0"/>
+          </a:p>
+          <a:p>
+            <a:pPr algn="l" indent="0" marL="0">
+              <a:lnSpc>
+                <a:spcPts val="1425"/>
+              </a:lnSpc>
+              <a:buNone/>
+            </a:pPr>
+            <a:r>
+              <a:rPr lang="en-US" sz="770" spc="20" kern="0" dirty="0">
+                <a:solidFill>
+                  <a:srgbClr val="3D4249"/>
+                </a:solidFill>
+                <a:latin typeface="Noto Sans JP" pitchFamily="34" charset="0"/>
+                <a:ea typeface="Noto Sans JP" pitchFamily="34" charset="-122"/>
+                <a:cs typeface="Noto Sans JP" pitchFamily="34" charset="-120"/>
+              </a:rPr>
+              <a:t>投資とトレーディングの両輪で川上から川下までをつなぎます。フェアな立場だから</a:t>
+            </a:r>
+            <a:endParaRPr lang="en-US" sz="770" dirty="0"/>
+          </a:p>
+          <a:p>
+            <a:pPr algn="l" indent="0" marL="0">
+              <a:lnSpc>
+                <a:spcPts val="1425"/>
+              </a:lnSpc>
+              <a:buNone/>
+            </a:pPr>
+            <a:r>
+              <a:rPr lang="en-US" sz="770" spc="20" kern="0" dirty="0">
+                <a:solidFill>
+                  <a:srgbClr val="3D4249"/>
+                </a:solidFill>
+                <a:latin typeface="Noto Sans JP" pitchFamily="34" charset="0"/>
+                <a:ea typeface="Noto Sans JP" pitchFamily="34" charset="-122"/>
+                <a:cs typeface="Noto Sans JP" pitchFamily="34" charset="-120"/>
+              </a:rPr>
+              <a:t>こそ、埋められる隙間がある。多様なパートナーと使い手の間に立ち、その時々の最</a:t>
+            </a:r>
+            <a:endParaRPr lang="en-US" sz="770" dirty="0"/>
+          </a:p>
+          <a:p>
+            <a:pPr algn="l" indent="0" marL="0">
+              <a:lnSpc>
+                <a:spcPts val="1425"/>
+              </a:lnSpc>
+              <a:buNone/>
+            </a:pPr>
+            <a:r>
+              <a:rPr lang="en-US" sz="770" spc="20" kern="0" dirty="0">
+                <a:solidFill>
+                  <a:srgbClr val="3D4249"/>
+                </a:solidFill>
+                <a:latin typeface="Noto Sans JP" pitchFamily="34" charset="0"/>
+                <a:ea typeface="Noto Sans JP" pitchFamily="34" charset="-122"/>
+                <a:cs typeface="Noto Sans JP" pitchFamily="34" charset="-120"/>
+              </a:rPr>
+              <a:t>適解を導く。世界に眠る価値を、社会の力へ。</a:t>
+            </a:r>
+            <a:endParaRPr lang="en-US" sz="770" dirty="0"/>
+          </a:p>
+        </p:txBody>
+      </p:sp>
+      <p:sp>
+        <p:nvSpPr>
+          <p:cNvPr id="39" name="Text 37"/>
+          <p:cNvSpPr/>
+          <p:nvPr/>
+        </p:nvSpPr>
+        <p:spPr>
+          <a:xfrm>
+            <a:off x="12260855" y="7496274"/>
+            <a:ext cx="779108" cy="101644"/>
+          </a:xfrm>
+          <a:prstGeom prst="rect">
+            <a:avLst/>
+          </a:prstGeom>
+          <a:noFill/>
+          <a:ln/>
+        </p:spPr>
+        <p:txBody>
+          <a:bodyPr wrap="none" lIns="0" tIns="0" rIns="0" bIns="0" rtlCol="0" anchor="t"/>
+          <a:lstStyle/>
+          <a:p>
+            <a:pPr algn="l" indent="0" marL="0">
+              <a:lnSpc>
+                <a:spcPts val="800"/>
+              </a:lnSpc>
+              <a:buNone/>
+            </a:pPr>
+            <a:r>
+              <a:rPr lang="en-US" sz="660" spc="190" kern="0" dirty="0">
+                <a:solidFill>
+                  <a:srgbClr val="9C7442"/>
+                </a:solidFill>
+                <a:latin typeface="Inter SemiBold" pitchFamily="34" charset="0"/>
+                <a:ea typeface="Inter SemiBold" pitchFamily="34" charset="-122"/>
+                <a:cs typeface="Inter SemiBold" pitchFamily="34" charset="-120"/>
+              </a:rPr>
+              <a:t>CONTENTS</a:t>
+            </a:r>
+            <a:endParaRPr lang="en-US" sz="660" dirty="0"/>
+          </a:p>
+        </p:txBody>
+      </p:sp>
+      <p:sp>
+        <p:nvSpPr>
+          <p:cNvPr id="40" name="Text 38"/>
+          <p:cNvSpPr/>
+          <p:nvPr/>
+        </p:nvSpPr>
+        <p:spPr>
+          <a:xfrm>
+            <a:off x="12260855" y="7775796"/>
+            <a:ext cx="154114" cy="101644"/>
+          </a:xfrm>
+          <a:prstGeom prst="rect">
+            <a:avLst/>
+          </a:prstGeom>
+          <a:noFill/>
+          <a:ln/>
+        </p:spPr>
+        <p:txBody>
+          <a:bodyPr wrap="none" lIns="0" tIns="0" rIns="0" bIns="0" rtlCol="0" anchor="t"/>
+          <a:lstStyle/>
+          <a:p>
+            <a:pPr algn="l" indent="0" marL="0">
+              <a:lnSpc>
+                <a:spcPts val="800"/>
+              </a:lnSpc>
+              <a:buNone/>
+            </a:pPr>
+            <a:r>
               <a:rPr lang="en-US" sz="640" spc="30" kern="0" dirty="0">
                 <a:solidFill>
-                  <a:srgbClr val="7D838A"/>
+                  <a:srgbClr val="9C7442"/>
                 </a:solidFill>
                 <a:latin typeface="Inter Medium" pitchFamily="34" charset="0"/>
                 <a:ea typeface="Inter Medium" pitchFamily="34" charset="-122"/>
                 <a:cs typeface="Inter Medium" pitchFamily="34" charset="-120"/>
               </a:rPr>
-              <a:t>Supply</a:t>
+              <a:t>01</a:t>
             </a:r>
             <a:endParaRPr lang="en-US" sz="640" dirty="0"/>
           </a:p>
@@ -2558,125 +3078,839 @@
       </p:sp>
       <p:sp>
         <p:nvSpPr>
-          <p:cNvPr id="31" name="Text 29"/>
-          <p:cNvSpPr/>
-          <p:nvPr/>
-        </p:nvSpPr>
-        <p:spPr>
-          <a:xfrm>
-            <a:off x="6263836" y="8925903"/>
-            <a:ext cx="676471" cy="113842"/>
-          </a:xfrm>
-          <a:prstGeom prst="rect">
-            <a:avLst/>
-          </a:prstGeom>
-          <a:noFill/>
-          <a:ln/>
-        </p:spPr>
-        <p:txBody>
-          <a:bodyPr wrap="none" lIns="0" tIns="0" rIns="0" bIns="0" rtlCol="0" anchor="t"/>
-          <a:lstStyle/>
-          <a:p>
-            <a:pPr algn="l" indent="0" marL="0">
-              <a:lnSpc>
-                <a:spcPts val="896"/>
-              </a:lnSpc>
-              <a:buNone/>
-            </a:pPr>
-            <a:r>
-              <a:rPr lang="en-US" sz="560" dirty="0">
+          <p:cNvPr id="41" name="Text 39"/>
+          <p:cNvSpPr/>
+          <p:nvPr/>
+        </p:nvSpPr>
+        <p:spPr>
+          <a:xfrm>
+            <a:off x="12514966" y="7775796"/>
+            <a:ext cx="623842" cy="101644"/>
+          </a:xfrm>
+          <a:prstGeom prst="rect">
+            <a:avLst/>
+          </a:prstGeom>
+          <a:noFill/>
+          <a:ln/>
+        </p:spPr>
+        <p:txBody>
+          <a:bodyPr wrap="none" lIns="0" tIns="0" rIns="0" bIns="0" rtlCol="0" anchor="t"/>
+          <a:lstStyle/>
+          <a:p>
+            <a:pPr algn="l" indent="0" marL="0">
+              <a:lnSpc>
+                <a:spcPts val="800"/>
+              </a:lnSpc>
+              <a:buNone/>
+            </a:pPr>
+            <a:r>
+              <a:rPr lang="en-US" sz="640" spc="30" kern="0" dirty="0">
+                <a:solidFill>
+                  <a:srgbClr val="121519"/>
+                </a:solidFill>
+                <a:latin typeface="Inter Medium" pitchFamily="34" charset="0"/>
+                <a:ea typeface="Inter Medium" pitchFamily="34" charset="-122"/>
+                <a:cs typeface="Inter Medium" pitchFamily="34" charset="-120"/>
+              </a:rPr>
+              <a:t>Who We Are</a:t>
+            </a:r>
+            <a:endParaRPr lang="en-US" sz="640" dirty="0"/>
+          </a:p>
+        </p:txBody>
+      </p:sp>
+      <p:sp>
+        <p:nvSpPr>
+          <p:cNvPr id="42" name="Text 40"/>
+          <p:cNvSpPr/>
+          <p:nvPr/>
+        </p:nvSpPr>
+        <p:spPr>
+          <a:xfrm>
+            <a:off x="14357271" y="7775796"/>
+            <a:ext cx="305013" cy="76233"/>
+          </a:xfrm>
+          <a:prstGeom prst="rect">
+            <a:avLst/>
+          </a:prstGeom>
+          <a:noFill/>
+          <a:ln/>
+        </p:spPr>
+        <p:txBody>
+          <a:bodyPr wrap="none" lIns="0" tIns="0" rIns="0" bIns="0" rtlCol="0" anchor="t"/>
+          <a:lstStyle/>
+          <a:p>
+            <a:pPr algn="l" indent="0" marL="0">
+              <a:lnSpc>
+                <a:spcPts val="600"/>
+              </a:lnSpc>
+              <a:buNone/>
+            </a:pPr>
+            <a:r>
+              <a:rPr lang="en-US" sz="540" spc="160" kern="0" dirty="0">
                 <a:solidFill>
                   <a:srgbClr val="7D838A"/>
+                </a:solidFill>
+                <a:latin typeface="Inter Medium" pitchFamily="34" charset="0"/>
+                <a:ea typeface="Inter Medium" pitchFamily="34" charset="-122"/>
+                <a:cs typeface="Inter Medium" pitchFamily="34" charset="-120"/>
+              </a:rPr>
+              <a:t>P.04</a:t>
+            </a:r>
+            <a:endParaRPr lang="en-US" sz="540" dirty="0"/>
+          </a:p>
+        </p:txBody>
+      </p:sp>
+      <p:sp>
+        <p:nvSpPr>
+          <p:cNvPr id="43" name="Text 41"/>
+          <p:cNvSpPr/>
+          <p:nvPr/>
+        </p:nvSpPr>
+        <p:spPr>
+          <a:xfrm>
+            <a:off x="12260855" y="8042613"/>
+            <a:ext cx="172021" cy="101644"/>
+          </a:xfrm>
+          <a:prstGeom prst="rect">
+            <a:avLst/>
+          </a:prstGeom>
+          <a:noFill/>
+          <a:ln/>
+        </p:spPr>
+        <p:txBody>
+          <a:bodyPr wrap="none" lIns="0" tIns="0" rIns="0" bIns="0" rtlCol="0" anchor="t"/>
+          <a:lstStyle/>
+          <a:p>
+            <a:pPr algn="l" indent="0" marL="0">
+              <a:lnSpc>
+                <a:spcPts val="800"/>
+              </a:lnSpc>
+              <a:buNone/>
+            </a:pPr>
+            <a:r>
+              <a:rPr lang="en-US" sz="640" spc="30" kern="0" dirty="0">
+                <a:solidFill>
+                  <a:srgbClr val="9C7442"/>
+                </a:solidFill>
+                <a:latin typeface="Inter Medium" pitchFamily="34" charset="0"/>
+                <a:ea typeface="Inter Medium" pitchFamily="34" charset="-122"/>
+                <a:cs typeface="Inter Medium" pitchFamily="34" charset="-120"/>
+              </a:rPr>
+              <a:t>02</a:t>
+            </a:r>
+            <a:endParaRPr lang="en-US" sz="640" dirty="0"/>
+          </a:p>
+        </p:txBody>
+      </p:sp>
+      <p:sp>
+        <p:nvSpPr>
+          <p:cNvPr id="44" name="Text 42"/>
+          <p:cNvSpPr/>
+          <p:nvPr/>
+        </p:nvSpPr>
+        <p:spPr>
+          <a:xfrm>
+            <a:off x="12514966" y="8042613"/>
+            <a:ext cx="700711" cy="101644"/>
+          </a:xfrm>
+          <a:prstGeom prst="rect">
+            <a:avLst/>
+          </a:prstGeom>
+          <a:noFill/>
+          <a:ln/>
+        </p:spPr>
+        <p:txBody>
+          <a:bodyPr wrap="none" lIns="0" tIns="0" rIns="0" bIns="0" rtlCol="0" anchor="t"/>
+          <a:lstStyle/>
+          <a:p>
+            <a:pPr algn="l" indent="0" marL="0">
+              <a:lnSpc>
+                <a:spcPts val="800"/>
+              </a:lnSpc>
+              <a:buNone/>
+            </a:pPr>
+            <a:r>
+              <a:rPr lang="en-US" sz="640" spc="30" kern="0" dirty="0">
+                <a:solidFill>
+                  <a:srgbClr val="121519"/>
+                </a:solidFill>
+                <a:latin typeface="Inter Medium" pitchFamily="34" charset="0"/>
+                <a:ea typeface="Inter Medium" pitchFamily="34" charset="-122"/>
+                <a:cs typeface="Inter Medium" pitchFamily="34" charset="-120"/>
+              </a:rPr>
+              <a:t>Our Strengths</a:t>
+            </a:r>
+            <a:endParaRPr lang="en-US" sz="640" dirty="0"/>
+          </a:p>
+        </p:txBody>
+      </p:sp>
+      <p:sp>
+        <p:nvSpPr>
+          <p:cNvPr id="45" name="Text 43"/>
+          <p:cNvSpPr/>
+          <p:nvPr/>
+        </p:nvSpPr>
+        <p:spPr>
+          <a:xfrm>
+            <a:off x="14357271" y="8042613"/>
+            <a:ext cx="301082" cy="76233"/>
+          </a:xfrm>
+          <a:prstGeom prst="rect">
+            <a:avLst/>
+          </a:prstGeom>
+          <a:noFill/>
+          <a:ln/>
+        </p:spPr>
+        <p:txBody>
+          <a:bodyPr wrap="none" lIns="0" tIns="0" rIns="0" bIns="0" rtlCol="0" anchor="t"/>
+          <a:lstStyle/>
+          <a:p>
+            <a:pPr algn="l" indent="0" marL="0">
+              <a:lnSpc>
+                <a:spcPts val="600"/>
+              </a:lnSpc>
+              <a:buNone/>
+            </a:pPr>
+            <a:r>
+              <a:rPr lang="en-US" sz="540" spc="160" kern="0" dirty="0">
+                <a:solidFill>
+                  <a:srgbClr val="7D838A"/>
+                </a:solidFill>
+                <a:latin typeface="Inter Medium" pitchFamily="34" charset="0"/>
+                <a:ea typeface="Inter Medium" pitchFamily="34" charset="-122"/>
+                <a:cs typeface="Inter Medium" pitchFamily="34" charset="-120"/>
+              </a:rPr>
+              <a:t>P.05</a:t>
+            </a:r>
+            <a:endParaRPr lang="en-US" sz="540" dirty="0"/>
+          </a:p>
+        </p:txBody>
+      </p:sp>
+      <p:sp>
+        <p:nvSpPr>
+          <p:cNvPr id="46" name="Text 44"/>
+          <p:cNvSpPr/>
+          <p:nvPr/>
+        </p:nvSpPr>
+        <p:spPr>
+          <a:xfrm>
+            <a:off x="12260855" y="8309429"/>
+            <a:ext cx="172895" cy="101644"/>
+          </a:xfrm>
+          <a:prstGeom prst="rect">
+            <a:avLst/>
+          </a:prstGeom>
+          <a:noFill/>
+          <a:ln/>
+        </p:spPr>
+        <p:txBody>
+          <a:bodyPr wrap="none" lIns="0" tIns="0" rIns="0" bIns="0" rtlCol="0" anchor="t"/>
+          <a:lstStyle/>
+          <a:p>
+            <a:pPr algn="l" indent="0" marL="0">
+              <a:lnSpc>
+                <a:spcPts val="800"/>
+              </a:lnSpc>
+              <a:buNone/>
+            </a:pPr>
+            <a:r>
+              <a:rPr lang="en-US" sz="640" spc="30" kern="0" dirty="0">
+                <a:solidFill>
+                  <a:srgbClr val="9C7442"/>
+                </a:solidFill>
+                <a:latin typeface="Inter Medium" pitchFamily="34" charset="0"/>
+                <a:ea typeface="Inter Medium" pitchFamily="34" charset="-122"/>
+                <a:cs typeface="Inter Medium" pitchFamily="34" charset="-120"/>
+              </a:rPr>
+              <a:t>03</a:t>
+            </a:r>
+            <a:endParaRPr lang="en-US" sz="640" dirty="0"/>
+          </a:p>
+        </p:txBody>
+      </p:sp>
+      <p:sp>
+        <p:nvSpPr>
+          <p:cNvPr id="47" name="Text 45"/>
+          <p:cNvSpPr/>
+          <p:nvPr/>
+        </p:nvSpPr>
+        <p:spPr>
+          <a:xfrm>
+            <a:off x="12514966" y="8309429"/>
+            <a:ext cx="721894" cy="101644"/>
+          </a:xfrm>
+          <a:prstGeom prst="rect">
+            <a:avLst/>
+          </a:prstGeom>
+          <a:noFill/>
+          <a:ln/>
+        </p:spPr>
+        <p:txBody>
+          <a:bodyPr wrap="none" lIns="0" tIns="0" rIns="0" bIns="0" rtlCol="0" anchor="t"/>
+          <a:lstStyle/>
+          <a:p>
+            <a:pPr algn="l" indent="0" marL="0">
+              <a:lnSpc>
+                <a:spcPts val="800"/>
+              </a:lnSpc>
+              <a:buNone/>
+            </a:pPr>
+            <a:r>
+              <a:rPr lang="en-US" sz="640" spc="30" kern="0" dirty="0">
+                <a:solidFill>
+                  <a:srgbClr val="121519"/>
+                </a:solidFill>
+                <a:latin typeface="Inter Medium" pitchFamily="34" charset="0"/>
+                <a:ea typeface="Inter Medium" pitchFamily="34" charset="-122"/>
+                <a:cs typeface="Inter Medium" pitchFamily="34" charset="-120"/>
+              </a:rPr>
+              <a:t>Coal &amp; Copper</a:t>
+            </a:r>
+            <a:endParaRPr lang="en-US" sz="640" dirty="0"/>
+          </a:p>
+        </p:txBody>
+      </p:sp>
+      <p:sp>
+        <p:nvSpPr>
+          <p:cNvPr id="48" name="Text 46"/>
+          <p:cNvSpPr/>
+          <p:nvPr/>
+        </p:nvSpPr>
+        <p:spPr>
+          <a:xfrm>
+            <a:off x="14357271" y="8309429"/>
+            <a:ext cx="303047" cy="76233"/>
+          </a:xfrm>
+          <a:prstGeom prst="rect">
+            <a:avLst/>
+          </a:prstGeom>
+          <a:noFill/>
+          <a:ln/>
+        </p:spPr>
+        <p:txBody>
+          <a:bodyPr wrap="none" lIns="0" tIns="0" rIns="0" bIns="0" rtlCol="0" anchor="t"/>
+          <a:lstStyle/>
+          <a:p>
+            <a:pPr algn="l" indent="0" marL="0">
+              <a:lnSpc>
+                <a:spcPts val="600"/>
+              </a:lnSpc>
+              <a:buNone/>
+            </a:pPr>
+            <a:r>
+              <a:rPr lang="en-US" sz="540" spc="160" kern="0" dirty="0">
+                <a:solidFill>
+                  <a:srgbClr val="7D838A"/>
+                </a:solidFill>
+                <a:latin typeface="Inter Medium" pitchFamily="34" charset="0"/>
+                <a:ea typeface="Inter Medium" pitchFamily="34" charset="-122"/>
+                <a:cs typeface="Inter Medium" pitchFamily="34" charset="-120"/>
+              </a:rPr>
+              <a:t>P.06</a:t>
+            </a:r>
+            <a:endParaRPr lang="en-US" sz="540" dirty="0"/>
+          </a:p>
+        </p:txBody>
+      </p:sp>
+      <p:sp>
+        <p:nvSpPr>
+          <p:cNvPr id="49" name="Text 47"/>
+          <p:cNvSpPr/>
+          <p:nvPr/>
+        </p:nvSpPr>
+        <p:spPr>
+          <a:xfrm>
+            <a:off x="12260855" y="8576246"/>
+            <a:ext cx="175515" cy="101644"/>
+          </a:xfrm>
+          <a:prstGeom prst="rect">
+            <a:avLst/>
+          </a:prstGeom>
+          <a:noFill/>
+          <a:ln/>
+        </p:spPr>
+        <p:txBody>
+          <a:bodyPr wrap="none" lIns="0" tIns="0" rIns="0" bIns="0" rtlCol="0" anchor="t"/>
+          <a:lstStyle/>
+          <a:p>
+            <a:pPr algn="l" indent="0" marL="0">
+              <a:lnSpc>
+                <a:spcPts val="800"/>
+              </a:lnSpc>
+              <a:buNone/>
+            </a:pPr>
+            <a:r>
+              <a:rPr lang="en-US" sz="640" spc="30" kern="0" dirty="0">
+                <a:solidFill>
+                  <a:srgbClr val="9C7442"/>
+                </a:solidFill>
+                <a:latin typeface="Inter Medium" pitchFamily="34" charset="0"/>
+                <a:ea typeface="Inter Medium" pitchFamily="34" charset="-122"/>
+                <a:cs typeface="Inter Medium" pitchFamily="34" charset="-120"/>
+              </a:rPr>
+              <a:t>04</a:t>
+            </a:r>
+            <a:endParaRPr lang="en-US" sz="640" dirty="0"/>
+          </a:p>
+        </p:txBody>
+      </p:sp>
+      <p:sp>
+        <p:nvSpPr>
+          <p:cNvPr id="50" name="Text 48"/>
+          <p:cNvSpPr/>
+          <p:nvPr/>
+        </p:nvSpPr>
+        <p:spPr>
+          <a:xfrm>
+            <a:off x="12514966" y="8576246"/>
+            <a:ext cx="945293" cy="101644"/>
+          </a:xfrm>
+          <a:prstGeom prst="rect">
+            <a:avLst/>
+          </a:prstGeom>
+          <a:noFill/>
+          <a:ln/>
+        </p:spPr>
+        <p:txBody>
+          <a:bodyPr wrap="none" lIns="0" tIns="0" rIns="0" bIns="0" rtlCol="0" anchor="t"/>
+          <a:lstStyle/>
+          <a:p>
+            <a:pPr algn="l" indent="0" marL="0">
+              <a:lnSpc>
+                <a:spcPts val="800"/>
+              </a:lnSpc>
+              <a:buNone/>
+            </a:pPr>
+            <a:r>
+              <a:rPr lang="en-US" sz="640" spc="30" kern="0" dirty="0">
+                <a:solidFill>
+                  <a:srgbClr val="121519"/>
+                </a:solidFill>
+                <a:latin typeface="Inter Medium" pitchFamily="34" charset="0"/>
+                <a:ea typeface="Inter Medium" pitchFamily="34" charset="-122"/>
+                <a:cs typeface="Inter Medium" pitchFamily="34" charset="-120"/>
+              </a:rPr>
+              <a:t>Resources to Value</a:t>
+            </a:r>
+            <a:endParaRPr lang="en-US" sz="640" dirty="0"/>
+          </a:p>
+        </p:txBody>
+      </p:sp>
+      <p:sp>
+        <p:nvSpPr>
+          <p:cNvPr id="51" name="Text 49"/>
+          <p:cNvSpPr/>
+          <p:nvPr/>
+        </p:nvSpPr>
+        <p:spPr>
+          <a:xfrm>
+            <a:off x="14357271" y="8576246"/>
+            <a:ext cx="303047" cy="76233"/>
+          </a:xfrm>
+          <a:prstGeom prst="rect">
+            <a:avLst/>
+          </a:prstGeom>
+          <a:noFill/>
+          <a:ln/>
+        </p:spPr>
+        <p:txBody>
+          <a:bodyPr wrap="none" lIns="0" tIns="0" rIns="0" bIns="0" rtlCol="0" anchor="t"/>
+          <a:lstStyle/>
+          <a:p>
+            <a:pPr algn="l" indent="0" marL="0">
+              <a:lnSpc>
+                <a:spcPts val="600"/>
+              </a:lnSpc>
+              <a:buNone/>
+            </a:pPr>
+            <a:r>
+              <a:rPr lang="en-US" sz="540" spc="160" kern="0" dirty="0">
+                <a:solidFill>
+                  <a:srgbClr val="7D838A"/>
+                </a:solidFill>
+                <a:latin typeface="Inter Medium" pitchFamily="34" charset="0"/>
+                <a:ea typeface="Inter Medium" pitchFamily="34" charset="-122"/>
+                <a:cs typeface="Inter Medium" pitchFamily="34" charset="-120"/>
+              </a:rPr>
+              <a:t>P.08</a:t>
+            </a:r>
+            <a:endParaRPr lang="en-US" sz="540" dirty="0"/>
+          </a:p>
+        </p:txBody>
+      </p:sp>
+      <p:sp>
+        <p:nvSpPr>
+          <p:cNvPr id="52" name="Text 50"/>
+          <p:cNvSpPr/>
+          <p:nvPr/>
+        </p:nvSpPr>
+        <p:spPr>
+          <a:xfrm>
+            <a:off x="12260855" y="8843063"/>
+            <a:ext cx="170929" cy="101644"/>
+          </a:xfrm>
+          <a:prstGeom prst="rect">
+            <a:avLst/>
+          </a:prstGeom>
+          <a:noFill/>
+          <a:ln/>
+        </p:spPr>
+        <p:txBody>
+          <a:bodyPr wrap="none" lIns="0" tIns="0" rIns="0" bIns="0" rtlCol="0" anchor="t"/>
+          <a:lstStyle/>
+          <a:p>
+            <a:pPr algn="l" indent="0" marL="0">
+              <a:lnSpc>
+                <a:spcPts val="800"/>
+              </a:lnSpc>
+              <a:buNone/>
+            </a:pPr>
+            <a:r>
+              <a:rPr lang="en-US" sz="640" spc="30" kern="0" dirty="0">
+                <a:solidFill>
+                  <a:srgbClr val="9C7442"/>
+                </a:solidFill>
+                <a:latin typeface="Inter Medium" pitchFamily="34" charset="0"/>
+                <a:ea typeface="Inter Medium" pitchFamily="34" charset="-122"/>
+                <a:cs typeface="Inter Medium" pitchFamily="34" charset="-120"/>
+              </a:rPr>
+              <a:t>05</a:t>
+            </a:r>
+            <a:endParaRPr lang="en-US" sz="640" dirty="0"/>
+          </a:p>
+        </p:txBody>
+      </p:sp>
+      <p:sp>
+        <p:nvSpPr>
+          <p:cNvPr id="53" name="Text 51"/>
+          <p:cNvSpPr/>
+          <p:nvPr/>
+        </p:nvSpPr>
+        <p:spPr>
+          <a:xfrm>
+            <a:off x="12514966" y="8843063"/>
+            <a:ext cx="643715" cy="101644"/>
+          </a:xfrm>
+          <a:prstGeom prst="rect">
+            <a:avLst/>
+          </a:prstGeom>
+          <a:noFill/>
+          <a:ln/>
+        </p:spPr>
+        <p:txBody>
+          <a:bodyPr wrap="none" lIns="0" tIns="0" rIns="0" bIns="0" rtlCol="0" anchor="t"/>
+          <a:lstStyle/>
+          <a:p>
+            <a:pPr algn="l" indent="0" marL="0">
+              <a:lnSpc>
+                <a:spcPts val="800"/>
+              </a:lnSpc>
+              <a:buNone/>
+            </a:pPr>
+            <a:r>
+              <a:rPr lang="en-US" sz="640" spc="30" kern="0" dirty="0">
+                <a:solidFill>
+                  <a:srgbClr val="121519"/>
+                </a:solidFill>
+                <a:latin typeface="Inter Medium" pitchFamily="34" charset="0"/>
+                <a:ea typeface="Inter Medium" pitchFamily="34" charset="-122"/>
+                <a:cs typeface="Inter Medium" pitchFamily="34" charset="-120"/>
+              </a:rPr>
+              <a:t>Partnerships</a:t>
+            </a:r>
+            <a:endParaRPr lang="en-US" sz="640" dirty="0"/>
+          </a:p>
+        </p:txBody>
+      </p:sp>
+      <p:sp>
+        <p:nvSpPr>
+          <p:cNvPr id="54" name="Text 52"/>
+          <p:cNvSpPr/>
+          <p:nvPr/>
+        </p:nvSpPr>
+        <p:spPr>
+          <a:xfrm>
+            <a:off x="14357271" y="8843063"/>
+            <a:ext cx="303047" cy="76233"/>
+          </a:xfrm>
+          <a:prstGeom prst="rect">
+            <a:avLst/>
+          </a:prstGeom>
+          <a:noFill/>
+          <a:ln/>
+        </p:spPr>
+        <p:txBody>
+          <a:bodyPr wrap="none" lIns="0" tIns="0" rIns="0" bIns="0" rtlCol="0" anchor="t"/>
+          <a:lstStyle/>
+          <a:p>
+            <a:pPr algn="l" indent="0" marL="0">
+              <a:lnSpc>
+                <a:spcPts val="600"/>
+              </a:lnSpc>
+              <a:buNone/>
+            </a:pPr>
+            <a:r>
+              <a:rPr lang="en-US" sz="540" spc="160" kern="0" dirty="0">
+                <a:solidFill>
+                  <a:srgbClr val="7D838A"/>
+                </a:solidFill>
+                <a:latin typeface="Inter Medium" pitchFamily="34" charset="0"/>
+                <a:ea typeface="Inter Medium" pitchFamily="34" charset="-122"/>
+                <a:cs typeface="Inter Medium" pitchFamily="34" charset="-120"/>
+              </a:rPr>
+              <a:t>P.09</a:t>
+            </a:r>
+            <a:endParaRPr lang="en-US" sz="540" dirty="0"/>
+          </a:p>
+        </p:txBody>
+      </p:sp>
+      <p:sp>
+        <p:nvSpPr>
+          <p:cNvPr id="55" name="Text 53"/>
+          <p:cNvSpPr/>
+          <p:nvPr/>
+        </p:nvSpPr>
+        <p:spPr>
+          <a:xfrm>
+            <a:off x="12260855" y="9109879"/>
+            <a:ext cx="173331" cy="101644"/>
+          </a:xfrm>
+          <a:prstGeom prst="rect">
+            <a:avLst/>
+          </a:prstGeom>
+          <a:noFill/>
+          <a:ln/>
+        </p:spPr>
+        <p:txBody>
+          <a:bodyPr wrap="none" lIns="0" tIns="0" rIns="0" bIns="0" rtlCol="0" anchor="t"/>
+          <a:lstStyle/>
+          <a:p>
+            <a:pPr algn="l" indent="0" marL="0">
+              <a:lnSpc>
+                <a:spcPts val="800"/>
+              </a:lnSpc>
+              <a:buNone/>
+            </a:pPr>
+            <a:r>
+              <a:rPr lang="en-US" sz="640" spc="30" kern="0" dirty="0">
+                <a:solidFill>
+                  <a:srgbClr val="9C7442"/>
+                </a:solidFill>
+                <a:latin typeface="Inter Medium" pitchFamily="34" charset="0"/>
+                <a:ea typeface="Inter Medium" pitchFamily="34" charset="-122"/>
+                <a:cs typeface="Inter Medium" pitchFamily="34" charset="-120"/>
+              </a:rPr>
+              <a:t>06</a:t>
+            </a:r>
+            <a:endParaRPr lang="en-US" sz="640" dirty="0"/>
+          </a:p>
+        </p:txBody>
+      </p:sp>
+      <p:sp>
+        <p:nvSpPr>
+          <p:cNvPr id="56" name="Text 54"/>
+          <p:cNvSpPr/>
+          <p:nvPr/>
+        </p:nvSpPr>
+        <p:spPr>
+          <a:xfrm>
+            <a:off x="12514966" y="9109879"/>
+            <a:ext cx="605062" cy="101644"/>
+          </a:xfrm>
+          <a:prstGeom prst="rect">
+            <a:avLst/>
+          </a:prstGeom>
+          <a:noFill/>
+          <a:ln/>
+        </p:spPr>
+        <p:txBody>
+          <a:bodyPr wrap="none" lIns="0" tIns="0" rIns="0" bIns="0" rtlCol="0" anchor="t"/>
+          <a:lstStyle/>
+          <a:p>
+            <a:pPr algn="l" indent="0" marL="0">
+              <a:lnSpc>
+                <a:spcPts val="800"/>
+              </a:lnSpc>
+              <a:buNone/>
+            </a:pPr>
+            <a:r>
+              <a:rPr lang="en-US" sz="640" spc="30" kern="0" dirty="0">
+                <a:solidFill>
+                  <a:srgbClr val="121519"/>
+                </a:solidFill>
+                <a:latin typeface="Inter Medium" pitchFamily="34" charset="0"/>
+                <a:ea typeface="Inter Medium" pitchFamily="34" charset="-122"/>
+                <a:cs typeface="Inter Medium" pitchFamily="34" charset="-120"/>
+              </a:rPr>
+              <a:t>Value Chain</a:t>
+            </a:r>
+            <a:endParaRPr lang="en-US" sz="640" dirty="0"/>
+          </a:p>
+        </p:txBody>
+      </p:sp>
+      <p:sp>
+        <p:nvSpPr>
+          <p:cNvPr id="57" name="Text 55"/>
+          <p:cNvSpPr/>
+          <p:nvPr/>
+        </p:nvSpPr>
+        <p:spPr>
+          <a:xfrm>
+            <a:off x="14357271" y="9109879"/>
+            <a:ext cx="282301" cy="76233"/>
+          </a:xfrm>
+          <a:prstGeom prst="rect">
+            <a:avLst/>
+          </a:prstGeom>
+          <a:noFill/>
+          <a:ln/>
+        </p:spPr>
+        <p:txBody>
+          <a:bodyPr wrap="none" lIns="0" tIns="0" rIns="0" bIns="0" rtlCol="0" anchor="t"/>
+          <a:lstStyle/>
+          <a:p>
+            <a:pPr algn="l" indent="0" marL="0">
+              <a:lnSpc>
+                <a:spcPts val="600"/>
+              </a:lnSpc>
+              <a:buNone/>
+            </a:pPr>
+            <a:r>
+              <a:rPr lang="en-US" sz="540" spc="160" kern="0" dirty="0">
+                <a:solidFill>
+                  <a:srgbClr val="7D838A"/>
+                </a:solidFill>
+                <a:latin typeface="Inter Medium" pitchFamily="34" charset="0"/>
+                <a:ea typeface="Inter Medium" pitchFamily="34" charset="-122"/>
+                <a:cs typeface="Inter Medium" pitchFamily="34" charset="-120"/>
+              </a:rPr>
+              <a:t>P.10</a:t>
+            </a:r>
+            <a:endParaRPr lang="en-US" sz="540" dirty="0"/>
+          </a:p>
+        </p:txBody>
+      </p:sp>
+      <p:sp>
+        <p:nvSpPr>
+          <p:cNvPr id="58" name="Text 56"/>
+          <p:cNvSpPr/>
+          <p:nvPr/>
+        </p:nvSpPr>
+        <p:spPr>
+          <a:xfrm>
+            <a:off x="508222" y="10316906"/>
+            <a:ext cx="201502" cy="88939"/>
+          </a:xfrm>
+          <a:prstGeom prst="rect">
+            <a:avLst/>
+          </a:prstGeom>
+          <a:noFill/>
+          <a:ln/>
+        </p:spPr>
+        <p:txBody>
+          <a:bodyPr wrap="none" lIns="0" tIns="0" rIns="0" bIns="0" rtlCol="0" anchor="t"/>
+          <a:lstStyle/>
+          <a:p>
+            <a:pPr algn="l" indent="0" marL="0">
+              <a:lnSpc>
+                <a:spcPts val="700"/>
+              </a:lnSpc>
+              <a:buNone/>
+            </a:pPr>
+            <a:r>
+              <a:rPr lang="en-US" sz="600" spc="160" kern="0" dirty="0">
+                <a:solidFill>
+                  <a:srgbClr val="7D838A"/>
+                </a:solidFill>
+                <a:latin typeface="Inter Medium" pitchFamily="34" charset="0"/>
+                <a:ea typeface="Inter Medium" pitchFamily="34" charset="-122"/>
+                <a:cs typeface="Inter Medium" pitchFamily="34" charset="-120"/>
+              </a:rPr>
+              <a:t>02</a:t>
+            </a:r>
+            <a:endParaRPr lang="en-US" sz="600" dirty="0"/>
+          </a:p>
+        </p:txBody>
+      </p:sp>
+      <p:sp>
+        <p:nvSpPr>
+          <p:cNvPr id="59" name="Text 57"/>
+          <p:cNvSpPr/>
+          <p:nvPr/>
+        </p:nvSpPr>
+        <p:spPr>
+          <a:xfrm>
+            <a:off x="14458915" y="10316906"/>
+            <a:ext cx="202376" cy="88939"/>
+          </a:xfrm>
+          <a:prstGeom prst="rect">
+            <a:avLst/>
+          </a:prstGeom>
+          <a:noFill/>
+          <a:ln/>
+        </p:spPr>
+        <p:txBody>
+          <a:bodyPr wrap="none" lIns="0" tIns="0" rIns="0" bIns="0" rtlCol="0" anchor="t"/>
+          <a:lstStyle/>
+          <a:p>
+            <a:pPr algn="l" indent="0" marL="0">
+              <a:lnSpc>
+                <a:spcPts val="700"/>
+              </a:lnSpc>
+              <a:buNone/>
+            </a:pPr>
+            <a:r>
+              <a:rPr lang="en-US" sz="600" spc="160" kern="0" dirty="0">
+                <a:solidFill>
+                  <a:srgbClr val="7D838A"/>
+                </a:solidFill>
+                <a:latin typeface="Inter Medium" pitchFamily="34" charset="0"/>
+                <a:ea typeface="Inter Medium" pitchFamily="34" charset="-122"/>
+                <a:cs typeface="Inter Medium" pitchFamily="34" charset="-120"/>
+              </a:rPr>
+              <a:t>03</a:t>
+            </a:r>
+            <a:endParaRPr lang="en-US" sz="600" dirty="0"/>
+          </a:p>
+        </p:txBody>
+      </p:sp>
+      <p:sp>
+        <p:nvSpPr>
+          <p:cNvPr id="60" name="Text 58"/>
+          <p:cNvSpPr/>
+          <p:nvPr/>
+        </p:nvSpPr>
+        <p:spPr>
+          <a:xfrm>
+            <a:off x="876683" y="10328977"/>
+            <a:ext cx="6501450" cy="102915"/>
+          </a:xfrm>
+          <a:prstGeom prst="rect">
+            <a:avLst/>
+          </a:prstGeom>
+          <a:noFill/>
+          <a:ln/>
+        </p:spPr>
+        <p:txBody>
+          <a:bodyPr wrap="none" lIns="0" tIns="0" rIns="0" bIns="0" rtlCol="0" anchor="t"/>
+          <a:lstStyle/>
+          <a:p>
+            <a:pPr algn="l" indent="0" marL="0">
+              <a:lnSpc>
+                <a:spcPts val="810"/>
+              </a:lnSpc>
+              <a:buNone/>
+            </a:pPr>
+            <a:r>
+              <a:rPr lang="en-US" sz="540" dirty="0">
+                <a:solidFill>
+                  <a:srgbClr val="A3A8AE"/>
                 </a:solidFill>
                 <a:latin typeface="Noto Sans JP" pitchFamily="34" charset="0"/>
                 <a:ea typeface="Noto Sans JP" pitchFamily="34" charset="-122"/>
                 <a:cs typeface="Noto Sans JP" pitchFamily="34" charset="-120"/>
               </a:rPr>
-              <a:t>供給制約・地政学</a:t>
-            </a:r>
-            <a:endParaRPr lang="en-US" sz="560" dirty="0"/>
-          </a:p>
-        </p:txBody>
-      </p:sp>
-      <p:sp>
-        <p:nvSpPr>
-          <p:cNvPr id="32" name="Text 30"/>
-          <p:cNvSpPr/>
-          <p:nvPr/>
-        </p:nvSpPr>
-        <p:spPr>
-          <a:xfrm>
-            <a:off x="5730203" y="8716007"/>
-            <a:ext cx="323575" cy="101644"/>
-          </a:xfrm>
-          <a:prstGeom prst="rect">
-            <a:avLst/>
-          </a:prstGeom>
-          <a:noFill/>
-          <a:ln/>
-        </p:spPr>
-        <p:txBody>
-          <a:bodyPr wrap="none" lIns="0" tIns="0" rIns="0" bIns="0" rtlCol="0" anchor="t"/>
-          <a:lstStyle/>
-          <a:p>
-            <a:pPr algn="l" indent="0" marL="0">
-              <a:lnSpc>
-                <a:spcPts val="800"/>
-              </a:lnSpc>
-              <a:buNone/>
-            </a:pPr>
-            <a:r>
-              <a:rPr lang="en-US" sz="660" spc="190" kern="0" dirty="0">
-                <a:solidFill>
-                  <a:srgbClr val="9C7442"/>
-                </a:solidFill>
-                <a:latin typeface="Inter SemiBold" pitchFamily="34" charset="0"/>
-                <a:ea typeface="Inter SemiBold" pitchFamily="34" charset="-122"/>
-                <a:cs typeface="Inter SemiBold" pitchFamily="34" charset="-120"/>
-              </a:rPr>
-              <a:t>GAP</a:t>
-            </a:r>
-            <a:endParaRPr lang="en-US" sz="660" dirty="0"/>
-          </a:p>
-        </p:txBody>
-      </p:sp>
-      <p:sp>
-        <p:nvSpPr>
-          <p:cNvPr id="33" name="Text 31"/>
-          <p:cNvSpPr/>
-          <p:nvPr/>
-        </p:nvSpPr>
-        <p:spPr>
-          <a:xfrm>
-            <a:off x="4396120" y="9372630"/>
-            <a:ext cx="264395" cy="109776"/>
-          </a:xfrm>
-          <a:prstGeom prst="rect">
-            <a:avLst/>
-          </a:prstGeom>
-          <a:noFill/>
-          <a:ln/>
-        </p:spPr>
-        <p:txBody>
-          <a:bodyPr wrap="none" lIns="0" tIns="0" rIns="0" bIns="0" rtlCol="0" anchor="t"/>
-          <a:lstStyle/>
-          <a:p>
-            <a:pPr algn="l" indent="0" marL="0">
-              <a:lnSpc>
-                <a:spcPts val="864"/>
-              </a:lnSpc>
-              <a:buNone/>
-            </a:pPr>
-            <a:r>
-              <a:rPr lang="en-US" sz="540" dirty="0">
-                <a:solidFill>
-                  <a:srgbClr val="7D838A"/>
-                </a:solidFill>
-                <a:latin typeface="Noto Sans JP" pitchFamily="34" charset="0"/>
-                <a:ea typeface="Noto Sans JP" pitchFamily="34" charset="-122"/>
-                <a:cs typeface="Noto Sans JP" pitchFamily="34" charset="-120"/>
-              </a:rPr>
-              <a:t>Today</a:t>
+              <a:t>台割メモ｜動画01 OPENING。地球儀は使わず、暮らしと金属の写真を見開きで1枚のモザイクに（左＝暮らし、右＝それを支える金属）。キャッチコピー＋需要と供給のギャップを概念図で。</a:t>
             </a:r>
             <a:endParaRPr lang="en-US" sz="540" dirty="0"/>
           </a:p>
@@ -2684,1283 +3918,7 @@
       </p:sp>
       <p:sp>
         <p:nvSpPr>
-          <p:cNvPr id="34" name="Text 32"/>
-          <p:cNvSpPr/>
-          <p:nvPr/>
-        </p:nvSpPr>
-        <p:spPr>
-          <a:xfrm>
-            <a:off x="6543358" y="9372630"/>
-            <a:ext cx="280773" cy="109776"/>
-          </a:xfrm>
-          <a:prstGeom prst="rect">
-            <a:avLst/>
-          </a:prstGeom>
-          <a:noFill/>
-          <a:ln/>
-        </p:spPr>
-        <p:txBody>
-          <a:bodyPr wrap="none" lIns="0" tIns="0" rIns="0" bIns="0" rtlCol="0" anchor="t"/>
-          <a:lstStyle/>
-          <a:p>
-            <a:pPr algn="l" indent="0" marL="0">
-              <a:lnSpc>
-                <a:spcPts val="864"/>
-              </a:lnSpc>
-              <a:buNone/>
-            </a:pPr>
-            <a:r>
-              <a:rPr lang="en-US" sz="540" dirty="0">
-                <a:solidFill>
-                  <a:srgbClr val="7D838A"/>
-                </a:solidFill>
-                <a:latin typeface="Noto Sans JP" pitchFamily="34" charset="0"/>
-                <a:ea typeface="Noto Sans JP" pitchFamily="34" charset="-122"/>
-                <a:cs typeface="Noto Sans JP" pitchFamily="34" charset="-120"/>
-              </a:rPr>
-              <a:t>Future</a:t>
-            </a:r>
-            <a:endParaRPr lang="en-US" sz="540" dirty="0"/>
-          </a:p>
-        </p:txBody>
-      </p:sp>
-      <p:sp>
-        <p:nvSpPr>
-          <p:cNvPr id="35" name="Text 33"/>
-          <p:cNvSpPr/>
-          <p:nvPr/>
-        </p:nvSpPr>
-        <p:spPr>
-          <a:xfrm>
-            <a:off x="8068024" y="5565031"/>
-            <a:ext cx="1095318" cy="101644"/>
-          </a:xfrm>
-          <a:prstGeom prst="rect">
-            <a:avLst/>
-          </a:prstGeom>
-          <a:noFill/>
-          <a:ln/>
-        </p:spPr>
-        <p:txBody>
-          <a:bodyPr wrap="none" lIns="0" tIns="0" rIns="0" bIns="0" rtlCol="0" anchor="t"/>
-          <a:lstStyle/>
-          <a:p>
-            <a:pPr algn="l" indent="0" marL="0">
-              <a:lnSpc>
-                <a:spcPts val="800"/>
-              </a:lnSpc>
-              <a:buNone/>
-            </a:pPr>
-            <a:r>
-              <a:rPr lang="en-US" sz="660" spc="190" kern="0" dirty="0">
-                <a:solidFill>
-                  <a:srgbClr val="9C7442"/>
-                </a:solidFill>
-                <a:latin typeface="Inter SemiBold" pitchFamily="34" charset="0"/>
-                <a:ea typeface="Inter SemiBold" pitchFamily="34" charset="-122"/>
-                <a:cs typeface="Inter SemiBold" pitchFamily="34" charset="-120"/>
-              </a:rPr>
-              <a:t>CORE MESSAGE</a:t>
-            </a:r>
-            <a:endParaRPr lang="en-US" sz="660" dirty="0"/>
-          </a:p>
-        </p:txBody>
-      </p:sp>
-      <p:sp>
-        <p:nvSpPr>
-          <p:cNvPr id="36" name="Text 34"/>
-          <p:cNvSpPr/>
-          <p:nvPr/>
-        </p:nvSpPr>
-        <p:spPr>
-          <a:xfrm>
-            <a:off x="8068024" y="5704792"/>
-            <a:ext cx="748317" cy="127055"/>
-          </a:xfrm>
-          <a:prstGeom prst="rect">
-            <a:avLst/>
-          </a:prstGeom>
-          <a:noFill/>
-          <a:ln/>
-        </p:spPr>
-        <p:txBody>
-          <a:bodyPr wrap="none" lIns="0" tIns="0" rIns="0" bIns="0" rtlCol="0" anchor="t"/>
-          <a:lstStyle/>
-          <a:p>
-            <a:pPr algn="l" indent="0" marL="0">
-              <a:lnSpc>
-                <a:spcPts val="1000"/>
-              </a:lnSpc>
-              <a:buNone/>
-            </a:pPr>
-            <a:r>
-              <a:rPr lang="en-US" sz="660" spc="60" kern="0" dirty="0">
-                <a:solidFill>
-                  <a:srgbClr val="7D838A"/>
-                </a:solidFill>
-                <a:latin typeface="Noto Sans JP" pitchFamily="34" charset="0"/>
-                <a:ea typeface="Noto Sans JP" pitchFamily="34" charset="-122"/>
-                <a:cs typeface="Noto Sans JP" pitchFamily="34" charset="-120"/>
-              </a:rPr>
-              <a:t>コアメッセージ</a:t>
-            </a:r>
-            <a:endParaRPr lang="en-US" sz="660" dirty="0"/>
-          </a:p>
-        </p:txBody>
-      </p:sp>
-      <p:sp>
-        <p:nvSpPr>
-          <p:cNvPr id="37" name="Text 35"/>
-          <p:cNvSpPr/>
-          <p:nvPr/>
-        </p:nvSpPr>
-        <p:spPr>
-          <a:xfrm>
-            <a:off x="8068024" y="5964620"/>
-            <a:ext cx="4628652" cy="1120629"/>
-          </a:xfrm>
-          <a:prstGeom prst="rect">
-            <a:avLst/>
-          </a:prstGeom>
-          <a:noFill/>
-          <a:ln/>
-        </p:spPr>
-        <p:txBody>
-          <a:bodyPr wrap="none" lIns="0" tIns="0" rIns="0" bIns="0" rtlCol="0" anchor="t"/>
-          <a:lstStyle/>
-          <a:p>
-            <a:pPr algn="l" indent="0" marL="0">
-              <a:lnSpc>
-                <a:spcPts val="4410"/>
-              </a:lnSpc>
-              <a:buNone/>
-            </a:pPr>
-            <a:r>
-              <a:rPr lang="en-US" sz="4200" spc="-84" kern="0" dirty="0">
-                <a:solidFill>
-                  <a:srgbClr val="121519"/>
-                </a:solidFill>
-                <a:latin typeface="Inter Tight Light" pitchFamily="34" charset="0"/>
-                <a:ea typeface="Inter Tight Light" pitchFamily="34" charset="-122"/>
-                <a:cs typeface="Inter Tight Light" pitchFamily="34" charset="-120"/>
-              </a:rPr>
-              <a:t>Strength to Hold.</a:t>
-            </a:r>
-            <a:endParaRPr lang="en-US" sz="4200" dirty="0"/>
-          </a:p>
-          <a:p>
-            <a:pPr algn="l" indent="0" marL="0">
-              <a:lnSpc>
-                <a:spcPts val="4410"/>
-              </a:lnSpc>
-              <a:buNone/>
-            </a:pPr>
-            <a:r>
-              <a:rPr lang="en-US" sz="4200" spc="-84" kern="0" dirty="0">
-                <a:solidFill>
-                  <a:srgbClr val="121519"/>
-                </a:solidFill>
-                <a:latin typeface="Inter Tight Light" pitchFamily="34" charset="0"/>
-                <a:ea typeface="Inter Tight Light" pitchFamily="34" charset="-122"/>
-                <a:cs typeface="Inter Tight Light" pitchFamily="34" charset="-120"/>
-              </a:rPr>
-              <a:t>Power to Connect.</a:t>
-            </a:r>
-            <a:endParaRPr lang="en-US" sz="4200" dirty="0"/>
-          </a:p>
-        </p:txBody>
-      </p:sp>
-      <p:sp>
-        <p:nvSpPr>
-          <p:cNvPr id="38" name="Text 36"/>
-          <p:cNvSpPr/>
-          <p:nvPr/>
-        </p:nvSpPr>
-        <p:spPr>
-          <a:xfrm>
-            <a:off x="8068024" y="7188165"/>
-            <a:ext cx="1930390" cy="247758"/>
-          </a:xfrm>
-          <a:prstGeom prst="rect">
-            <a:avLst/>
-          </a:prstGeom>
-          <a:noFill/>
-          <a:ln/>
-        </p:spPr>
-        <p:txBody>
-          <a:bodyPr wrap="none" lIns="0" tIns="0" rIns="0" bIns="0" rtlCol="0" anchor="t"/>
-          <a:lstStyle/>
-          <a:p>
-            <a:pPr algn="l" indent="0" marL="0">
-              <a:lnSpc>
-                <a:spcPts val="1950"/>
-              </a:lnSpc>
-              <a:buNone/>
-            </a:pPr>
-            <a:r>
-              <a:rPr lang="en-US" sz="1300" spc="50" kern="0" dirty="0">
-                <a:solidFill>
-                  <a:srgbClr val="121519"/>
-                </a:solidFill>
-                <a:latin typeface="Noto Sans JP Medium" pitchFamily="34" charset="0"/>
-                <a:ea typeface="Noto Sans JP Medium" pitchFamily="34" charset="-122"/>
-                <a:cs typeface="Noto Sans JP Medium" pitchFamily="34" charset="-120"/>
-              </a:rPr>
-              <a:t>持つ力と、つなぐ力。</a:t>
-            </a:r>
-            <a:endParaRPr lang="en-US" sz="1300" dirty="0"/>
-          </a:p>
-        </p:txBody>
-      </p:sp>
-      <p:sp>
-        <p:nvSpPr>
-          <p:cNvPr id="39" name="Text 37"/>
-          <p:cNvSpPr/>
-          <p:nvPr/>
-        </p:nvSpPr>
-        <p:spPr>
-          <a:xfrm>
-            <a:off x="8068024" y="7488365"/>
-            <a:ext cx="4243654" cy="904953"/>
-          </a:xfrm>
-          <a:prstGeom prst="rect">
-            <a:avLst/>
-          </a:prstGeom>
-          <a:noFill/>
-          <a:ln/>
-        </p:spPr>
-        <p:txBody>
-          <a:bodyPr wrap="none" lIns="0" tIns="0" rIns="0" bIns="0" rtlCol="0" anchor="t"/>
-          <a:lstStyle/>
-          <a:p>
-            <a:pPr algn="l" indent="0" marL="0">
-              <a:lnSpc>
-                <a:spcPts val="1425"/>
-              </a:lnSpc>
-              <a:buNone/>
-            </a:pPr>
-            <a:r>
-              <a:rPr lang="en-US" sz="770" spc="20" kern="0" dirty="0">
-                <a:solidFill>
-                  <a:srgbClr val="3D4249"/>
-                </a:solidFill>
-                <a:latin typeface="Noto Sans JP" pitchFamily="34" charset="0"/>
-                <a:ea typeface="Noto Sans JP" pitchFamily="34" charset="-122"/>
-                <a:cs typeface="Noto Sans JP" pitchFamily="34" charset="-120"/>
-              </a:rPr>
-              <a:t>資源は、そこに「ある」だけでは、まだ価値ではありません。誰かが見出し、育て、</a:t>
-            </a:r>
-            <a:endParaRPr lang="en-US" sz="770" dirty="0"/>
-          </a:p>
-          <a:p>
-            <a:pPr algn="l" indent="0" marL="0">
-              <a:lnSpc>
-                <a:spcPts val="1425"/>
-              </a:lnSpc>
-              <a:buNone/>
-            </a:pPr>
-            <a:r>
-              <a:rPr lang="en-US" sz="770" spc="20" kern="0" dirty="0">
-                <a:solidFill>
-                  <a:srgbClr val="3D4249"/>
-                </a:solidFill>
-                <a:latin typeface="Noto Sans JP" pitchFamily="34" charset="0"/>
-                <a:ea typeface="Noto Sans JP" pitchFamily="34" charset="-122"/>
-                <a:cs typeface="Noto Sans JP" pitchFamily="34" charset="-120"/>
-              </a:rPr>
-              <a:t>必要とする場所へ届けて、はじめて力になる。私たちは、世界有数の資産に関わり、</a:t>
-            </a:r>
-            <a:endParaRPr lang="en-US" sz="770" dirty="0"/>
-          </a:p>
-          <a:p>
-            <a:pPr algn="l" indent="0" marL="0">
-              <a:lnSpc>
-                <a:spcPts val="1425"/>
-              </a:lnSpc>
-              <a:buNone/>
-            </a:pPr>
-            <a:r>
-              <a:rPr lang="en-US" sz="770" spc="20" kern="0" dirty="0">
-                <a:solidFill>
-                  <a:srgbClr val="3D4249"/>
-                </a:solidFill>
-                <a:latin typeface="Noto Sans JP" pitchFamily="34" charset="0"/>
-                <a:ea typeface="Noto Sans JP" pitchFamily="34" charset="-122"/>
-                <a:cs typeface="Noto Sans JP" pitchFamily="34" charset="-120"/>
-              </a:rPr>
-              <a:t>投資とトレーディングの両輪で川上から川下までをつなぎます。フェアな立場だから</a:t>
-            </a:r>
-            <a:endParaRPr lang="en-US" sz="770" dirty="0"/>
-          </a:p>
-          <a:p>
-            <a:pPr algn="l" indent="0" marL="0">
-              <a:lnSpc>
-                <a:spcPts val="1425"/>
-              </a:lnSpc>
-              <a:buNone/>
-            </a:pPr>
-            <a:r>
-              <a:rPr lang="en-US" sz="770" spc="20" kern="0" dirty="0">
-                <a:solidFill>
-                  <a:srgbClr val="3D4249"/>
-                </a:solidFill>
-                <a:latin typeface="Noto Sans JP" pitchFamily="34" charset="0"/>
-                <a:ea typeface="Noto Sans JP" pitchFamily="34" charset="-122"/>
-                <a:cs typeface="Noto Sans JP" pitchFamily="34" charset="-120"/>
-              </a:rPr>
-              <a:t>こそ、埋められる隙間がある。多様なパートナーと使い手の間に立ち、その時々の最</a:t>
-            </a:r>
-            <a:endParaRPr lang="en-US" sz="770" dirty="0"/>
-          </a:p>
-          <a:p>
-            <a:pPr algn="l" indent="0" marL="0">
-              <a:lnSpc>
-                <a:spcPts val="1425"/>
-              </a:lnSpc>
-              <a:buNone/>
-            </a:pPr>
-            <a:r>
-              <a:rPr lang="en-US" sz="770" spc="20" kern="0" dirty="0">
-                <a:solidFill>
-                  <a:srgbClr val="3D4249"/>
-                </a:solidFill>
-                <a:latin typeface="Noto Sans JP" pitchFamily="34" charset="0"/>
-                <a:ea typeface="Noto Sans JP" pitchFamily="34" charset="-122"/>
-                <a:cs typeface="Noto Sans JP" pitchFamily="34" charset="-120"/>
-              </a:rPr>
-              <a:t>適解を導く。世界に眠る価値を、社会の力へ。</a:t>
-            </a:r>
-            <a:endParaRPr lang="en-US" sz="770" dirty="0"/>
-          </a:p>
-        </p:txBody>
-      </p:sp>
-      <p:sp>
-        <p:nvSpPr>
-          <p:cNvPr id="40" name="Text 38"/>
-          <p:cNvSpPr/>
-          <p:nvPr/>
-        </p:nvSpPr>
-        <p:spPr>
-          <a:xfrm>
-            <a:off x="12260855" y="7496274"/>
-            <a:ext cx="779108" cy="101644"/>
-          </a:xfrm>
-          <a:prstGeom prst="rect">
-            <a:avLst/>
-          </a:prstGeom>
-          <a:noFill/>
-          <a:ln/>
-        </p:spPr>
-        <p:txBody>
-          <a:bodyPr wrap="none" lIns="0" tIns="0" rIns="0" bIns="0" rtlCol="0" anchor="t"/>
-          <a:lstStyle/>
-          <a:p>
-            <a:pPr algn="l" indent="0" marL="0">
-              <a:lnSpc>
-                <a:spcPts val="800"/>
-              </a:lnSpc>
-              <a:buNone/>
-            </a:pPr>
-            <a:r>
-              <a:rPr lang="en-US" sz="660" spc="190" kern="0" dirty="0">
-                <a:solidFill>
-                  <a:srgbClr val="9C7442"/>
-                </a:solidFill>
-                <a:latin typeface="Inter SemiBold" pitchFamily="34" charset="0"/>
-                <a:ea typeface="Inter SemiBold" pitchFamily="34" charset="-122"/>
-                <a:cs typeface="Inter SemiBold" pitchFamily="34" charset="-120"/>
-              </a:rPr>
-              <a:t>CONTENTS</a:t>
-            </a:r>
-            <a:endParaRPr lang="en-US" sz="660" dirty="0"/>
-          </a:p>
-        </p:txBody>
-      </p:sp>
-      <p:sp>
-        <p:nvSpPr>
-          <p:cNvPr id="41" name="Text 39"/>
-          <p:cNvSpPr/>
-          <p:nvPr/>
-        </p:nvSpPr>
-        <p:spPr>
-          <a:xfrm>
-            <a:off x="12260855" y="7775796"/>
-            <a:ext cx="154114" cy="101644"/>
-          </a:xfrm>
-          <a:prstGeom prst="rect">
-            <a:avLst/>
-          </a:prstGeom>
-          <a:noFill/>
-          <a:ln/>
-        </p:spPr>
-        <p:txBody>
-          <a:bodyPr wrap="none" lIns="0" tIns="0" rIns="0" bIns="0" rtlCol="0" anchor="t"/>
-          <a:lstStyle/>
-          <a:p>
-            <a:pPr algn="l" indent="0" marL="0">
-              <a:lnSpc>
-                <a:spcPts val="800"/>
-              </a:lnSpc>
-              <a:buNone/>
-            </a:pPr>
-            <a:r>
-              <a:rPr lang="en-US" sz="640" spc="30" kern="0" dirty="0">
-                <a:solidFill>
-                  <a:srgbClr val="9C7442"/>
-                </a:solidFill>
-                <a:latin typeface="Inter Medium" pitchFamily="34" charset="0"/>
-                <a:ea typeface="Inter Medium" pitchFamily="34" charset="-122"/>
-                <a:cs typeface="Inter Medium" pitchFamily="34" charset="-120"/>
-              </a:rPr>
-              <a:t>01</a:t>
-            </a:r>
-            <a:endParaRPr lang="en-US" sz="640" dirty="0"/>
-          </a:p>
-        </p:txBody>
-      </p:sp>
-      <p:sp>
-        <p:nvSpPr>
-          <p:cNvPr id="42" name="Text 40"/>
-          <p:cNvSpPr/>
-          <p:nvPr/>
-        </p:nvSpPr>
-        <p:spPr>
-          <a:xfrm>
-            <a:off x="12514966" y="7775796"/>
-            <a:ext cx="623842" cy="101644"/>
-          </a:xfrm>
-          <a:prstGeom prst="rect">
-            <a:avLst/>
-          </a:prstGeom>
-          <a:noFill/>
-          <a:ln/>
-        </p:spPr>
-        <p:txBody>
-          <a:bodyPr wrap="none" lIns="0" tIns="0" rIns="0" bIns="0" rtlCol="0" anchor="t"/>
-          <a:lstStyle/>
-          <a:p>
-            <a:pPr algn="l" indent="0" marL="0">
-              <a:lnSpc>
-                <a:spcPts val="800"/>
-              </a:lnSpc>
-              <a:buNone/>
-            </a:pPr>
-            <a:r>
-              <a:rPr lang="en-US" sz="640" spc="30" kern="0" dirty="0">
-                <a:solidFill>
-                  <a:srgbClr val="121519"/>
-                </a:solidFill>
-                <a:latin typeface="Inter Medium" pitchFamily="34" charset="0"/>
-                <a:ea typeface="Inter Medium" pitchFamily="34" charset="-122"/>
-                <a:cs typeface="Inter Medium" pitchFamily="34" charset="-120"/>
-              </a:rPr>
-              <a:t>Who We Are</a:t>
-            </a:r>
-            <a:endParaRPr lang="en-US" sz="640" dirty="0"/>
-          </a:p>
-        </p:txBody>
-      </p:sp>
-      <p:sp>
-        <p:nvSpPr>
-          <p:cNvPr id="43" name="Text 41"/>
-          <p:cNvSpPr/>
-          <p:nvPr/>
-        </p:nvSpPr>
-        <p:spPr>
-          <a:xfrm>
-            <a:off x="14357271" y="7775796"/>
-            <a:ext cx="305013" cy="76233"/>
-          </a:xfrm>
-          <a:prstGeom prst="rect">
-            <a:avLst/>
-          </a:prstGeom>
-          <a:noFill/>
-          <a:ln/>
-        </p:spPr>
-        <p:txBody>
-          <a:bodyPr wrap="none" lIns="0" tIns="0" rIns="0" bIns="0" rtlCol="0" anchor="t"/>
-          <a:lstStyle/>
-          <a:p>
-            <a:pPr algn="l" indent="0" marL="0">
-              <a:lnSpc>
-                <a:spcPts val="600"/>
-              </a:lnSpc>
-              <a:buNone/>
-            </a:pPr>
-            <a:r>
-              <a:rPr lang="en-US" sz="540" spc="160" kern="0" dirty="0">
-                <a:solidFill>
-                  <a:srgbClr val="7D838A"/>
-                </a:solidFill>
-                <a:latin typeface="Inter Medium" pitchFamily="34" charset="0"/>
-                <a:ea typeface="Inter Medium" pitchFamily="34" charset="-122"/>
-                <a:cs typeface="Inter Medium" pitchFamily="34" charset="-120"/>
-              </a:rPr>
-              <a:t>P.04</a:t>
-            </a:r>
-            <a:endParaRPr lang="en-US" sz="540" dirty="0"/>
-          </a:p>
-        </p:txBody>
-      </p:sp>
-      <p:sp>
-        <p:nvSpPr>
-          <p:cNvPr id="44" name="Text 42"/>
-          <p:cNvSpPr/>
-          <p:nvPr/>
-        </p:nvSpPr>
-        <p:spPr>
-          <a:xfrm>
-            <a:off x="12260855" y="8042613"/>
-            <a:ext cx="172021" cy="101644"/>
-          </a:xfrm>
-          <a:prstGeom prst="rect">
-            <a:avLst/>
-          </a:prstGeom>
-          <a:noFill/>
-          <a:ln/>
-        </p:spPr>
-        <p:txBody>
-          <a:bodyPr wrap="none" lIns="0" tIns="0" rIns="0" bIns="0" rtlCol="0" anchor="t"/>
-          <a:lstStyle/>
-          <a:p>
-            <a:pPr algn="l" indent="0" marL="0">
-              <a:lnSpc>
-                <a:spcPts val="800"/>
-              </a:lnSpc>
-              <a:buNone/>
-            </a:pPr>
-            <a:r>
-              <a:rPr lang="en-US" sz="640" spc="30" kern="0" dirty="0">
-                <a:solidFill>
-                  <a:srgbClr val="9C7442"/>
-                </a:solidFill>
-                <a:latin typeface="Inter Medium" pitchFamily="34" charset="0"/>
-                <a:ea typeface="Inter Medium" pitchFamily="34" charset="-122"/>
-                <a:cs typeface="Inter Medium" pitchFamily="34" charset="-120"/>
-              </a:rPr>
-              <a:t>02</a:t>
-            </a:r>
-            <a:endParaRPr lang="en-US" sz="640" dirty="0"/>
-          </a:p>
-        </p:txBody>
-      </p:sp>
-      <p:sp>
-        <p:nvSpPr>
-          <p:cNvPr id="45" name="Text 43"/>
-          <p:cNvSpPr/>
-          <p:nvPr/>
-        </p:nvSpPr>
-        <p:spPr>
-          <a:xfrm>
-            <a:off x="12514966" y="8042613"/>
-            <a:ext cx="700711" cy="101644"/>
-          </a:xfrm>
-          <a:prstGeom prst="rect">
-            <a:avLst/>
-          </a:prstGeom>
-          <a:noFill/>
-          <a:ln/>
-        </p:spPr>
-        <p:txBody>
-          <a:bodyPr wrap="none" lIns="0" tIns="0" rIns="0" bIns="0" rtlCol="0" anchor="t"/>
-          <a:lstStyle/>
-          <a:p>
-            <a:pPr algn="l" indent="0" marL="0">
-              <a:lnSpc>
-                <a:spcPts val="800"/>
-              </a:lnSpc>
-              <a:buNone/>
-            </a:pPr>
-            <a:r>
-              <a:rPr lang="en-US" sz="640" spc="30" kern="0" dirty="0">
-                <a:solidFill>
-                  <a:srgbClr val="121519"/>
-                </a:solidFill>
-                <a:latin typeface="Inter Medium" pitchFamily="34" charset="0"/>
-                <a:ea typeface="Inter Medium" pitchFamily="34" charset="-122"/>
-                <a:cs typeface="Inter Medium" pitchFamily="34" charset="-120"/>
-              </a:rPr>
-              <a:t>Our Strengths</a:t>
-            </a:r>
-            <a:endParaRPr lang="en-US" sz="640" dirty="0"/>
-          </a:p>
-        </p:txBody>
-      </p:sp>
-      <p:sp>
-        <p:nvSpPr>
-          <p:cNvPr id="46" name="Text 44"/>
-          <p:cNvSpPr/>
-          <p:nvPr/>
-        </p:nvSpPr>
-        <p:spPr>
-          <a:xfrm>
-            <a:off x="14357271" y="8042613"/>
-            <a:ext cx="301082" cy="76233"/>
-          </a:xfrm>
-          <a:prstGeom prst="rect">
-            <a:avLst/>
-          </a:prstGeom>
-          <a:noFill/>
-          <a:ln/>
-        </p:spPr>
-        <p:txBody>
-          <a:bodyPr wrap="none" lIns="0" tIns="0" rIns="0" bIns="0" rtlCol="0" anchor="t"/>
-          <a:lstStyle/>
-          <a:p>
-            <a:pPr algn="l" indent="0" marL="0">
-              <a:lnSpc>
-                <a:spcPts val="600"/>
-              </a:lnSpc>
-              <a:buNone/>
-            </a:pPr>
-            <a:r>
-              <a:rPr lang="en-US" sz="540" spc="160" kern="0" dirty="0">
-                <a:solidFill>
-                  <a:srgbClr val="7D838A"/>
-                </a:solidFill>
-                <a:latin typeface="Inter Medium" pitchFamily="34" charset="0"/>
-                <a:ea typeface="Inter Medium" pitchFamily="34" charset="-122"/>
-                <a:cs typeface="Inter Medium" pitchFamily="34" charset="-120"/>
-              </a:rPr>
-              <a:t>P.05</a:t>
-            </a:r>
-            <a:endParaRPr lang="en-US" sz="540" dirty="0"/>
-          </a:p>
-        </p:txBody>
-      </p:sp>
-      <p:sp>
-        <p:nvSpPr>
-          <p:cNvPr id="47" name="Text 45"/>
-          <p:cNvSpPr/>
-          <p:nvPr/>
-        </p:nvSpPr>
-        <p:spPr>
-          <a:xfrm>
-            <a:off x="12260855" y="8309429"/>
-            <a:ext cx="172895" cy="101644"/>
-          </a:xfrm>
-          <a:prstGeom prst="rect">
-            <a:avLst/>
-          </a:prstGeom>
-          <a:noFill/>
-          <a:ln/>
-        </p:spPr>
-        <p:txBody>
-          <a:bodyPr wrap="none" lIns="0" tIns="0" rIns="0" bIns="0" rtlCol="0" anchor="t"/>
-          <a:lstStyle/>
-          <a:p>
-            <a:pPr algn="l" indent="0" marL="0">
-              <a:lnSpc>
-                <a:spcPts val="800"/>
-              </a:lnSpc>
-              <a:buNone/>
-            </a:pPr>
-            <a:r>
-              <a:rPr lang="en-US" sz="640" spc="30" kern="0" dirty="0">
-                <a:solidFill>
-                  <a:srgbClr val="9C7442"/>
-                </a:solidFill>
-                <a:latin typeface="Inter Medium" pitchFamily="34" charset="0"/>
-                <a:ea typeface="Inter Medium" pitchFamily="34" charset="-122"/>
-                <a:cs typeface="Inter Medium" pitchFamily="34" charset="-120"/>
-              </a:rPr>
-              <a:t>03</a:t>
-            </a:r>
-            <a:endParaRPr lang="en-US" sz="640" dirty="0"/>
-          </a:p>
-        </p:txBody>
-      </p:sp>
-      <p:sp>
-        <p:nvSpPr>
-          <p:cNvPr id="48" name="Text 46"/>
-          <p:cNvSpPr/>
-          <p:nvPr/>
-        </p:nvSpPr>
-        <p:spPr>
-          <a:xfrm>
-            <a:off x="12514966" y="8309429"/>
-            <a:ext cx="721894" cy="101644"/>
-          </a:xfrm>
-          <a:prstGeom prst="rect">
-            <a:avLst/>
-          </a:prstGeom>
-          <a:noFill/>
-          <a:ln/>
-        </p:spPr>
-        <p:txBody>
-          <a:bodyPr wrap="none" lIns="0" tIns="0" rIns="0" bIns="0" rtlCol="0" anchor="t"/>
-          <a:lstStyle/>
-          <a:p>
-            <a:pPr algn="l" indent="0" marL="0">
-              <a:lnSpc>
-                <a:spcPts val="800"/>
-              </a:lnSpc>
-              <a:buNone/>
-            </a:pPr>
-            <a:r>
-              <a:rPr lang="en-US" sz="640" spc="30" kern="0" dirty="0">
-                <a:solidFill>
-                  <a:srgbClr val="121519"/>
-                </a:solidFill>
-                <a:latin typeface="Inter Medium" pitchFamily="34" charset="0"/>
-                <a:ea typeface="Inter Medium" pitchFamily="34" charset="-122"/>
-                <a:cs typeface="Inter Medium" pitchFamily="34" charset="-120"/>
-              </a:rPr>
-              <a:t>Coal &amp; Copper</a:t>
-            </a:r>
-            <a:endParaRPr lang="en-US" sz="640" dirty="0"/>
-          </a:p>
-        </p:txBody>
-      </p:sp>
-      <p:sp>
-        <p:nvSpPr>
-          <p:cNvPr id="49" name="Text 47"/>
-          <p:cNvSpPr/>
-          <p:nvPr/>
-        </p:nvSpPr>
-        <p:spPr>
-          <a:xfrm>
-            <a:off x="14357271" y="8309429"/>
-            <a:ext cx="303047" cy="76233"/>
-          </a:xfrm>
-          <a:prstGeom prst="rect">
-            <a:avLst/>
-          </a:prstGeom>
-          <a:noFill/>
-          <a:ln/>
-        </p:spPr>
-        <p:txBody>
-          <a:bodyPr wrap="none" lIns="0" tIns="0" rIns="0" bIns="0" rtlCol="0" anchor="t"/>
-          <a:lstStyle/>
-          <a:p>
-            <a:pPr algn="l" indent="0" marL="0">
-              <a:lnSpc>
-                <a:spcPts val="600"/>
-              </a:lnSpc>
-              <a:buNone/>
-            </a:pPr>
-            <a:r>
-              <a:rPr lang="en-US" sz="540" spc="160" kern="0" dirty="0">
-                <a:solidFill>
-                  <a:srgbClr val="7D838A"/>
-                </a:solidFill>
-                <a:latin typeface="Inter Medium" pitchFamily="34" charset="0"/>
-                <a:ea typeface="Inter Medium" pitchFamily="34" charset="-122"/>
-                <a:cs typeface="Inter Medium" pitchFamily="34" charset="-120"/>
-              </a:rPr>
-              <a:t>P.06</a:t>
-            </a:r>
-            <a:endParaRPr lang="en-US" sz="540" dirty="0"/>
-          </a:p>
-        </p:txBody>
-      </p:sp>
-      <p:sp>
-        <p:nvSpPr>
-          <p:cNvPr id="50" name="Text 48"/>
-          <p:cNvSpPr/>
-          <p:nvPr/>
-        </p:nvSpPr>
-        <p:spPr>
-          <a:xfrm>
-            <a:off x="12260855" y="8576246"/>
-            <a:ext cx="175515" cy="101644"/>
-          </a:xfrm>
-          <a:prstGeom prst="rect">
-            <a:avLst/>
-          </a:prstGeom>
-          <a:noFill/>
-          <a:ln/>
-        </p:spPr>
-        <p:txBody>
-          <a:bodyPr wrap="none" lIns="0" tIns="0" rIns="0" bIns="0" rtlCol="0" anchor="t"/>
-          <a:lstStyle/>
-          <a:p>
-            <a:pPr algn="l" indent="0" marL="0">
-              <a:lnSpc>
-                <a:spcPts val="800"/>
-              </a:lnSpc>
-              <a:buNone/>
-            </a:pPr>
-            <a:r>
-              <a:rPr lang="en-US" sz="640" spc="30" kern="0" dirty="0">
-                <a:solidFill>
-                  <a:srgbClr val="9C7442"/>
-                </a:solidFill>
-                <a:latin typeface="Inter Medium" pitchFamily="34" charset="0"/>
-                <a:ea typeface="Inter Medium" pitchFamily="34" charset="-122"/>
-                <a:cs typeface="Inter Medium" pitchFamily="34" charset="-120"/>
-              </a:rPr>
-              <a:t>04</a:t>
-            </a:r>
-            <a:endParaRPr lang="en-US" sz="640" dirty="0"/>
-          </a:p>
-        </p:txBody>
-      </p:sp>
-      <p:sp>
-        <p:nvSpPr>
-          <p:cNvPr id="51" name="Text 49"/>
-          <p:cNvSpPr/>
-          <p:nvPr/>
-        </p:nvSpPr>
-        <p:spPr>
-          <a:xfrm>
-            <a:off x="12514966" y="8576246"/>
-            <a:ext cx="945293" cy="101644"/>
-          </a:xfrm>
-          <a:prstGeom prst="rect">
-            <a:avLst/>
-          </a:prstGeom>
-          <a:noFill/>
-          <a:ln/>
-        </p:spPr>
-        <p:txBody>
-          <a:bodyPr wrap="none" lIns="0" tIns="0" rIns="0" bIns="0" rtlCol="0" anchor="t"/>
-          <a:lstStyle/>
-          <a:p>
-            <a:pPr algn="l" indent="0" marL="0">
-              <a:lnSpc>
-                <a:spcPts val="800"/>
-              </a:lnSpc>
-              <a:buNone/>
-            </a:pPr>
-            <a:r>
-              <a:rPr lang="en-US" sz="640" spc="30" kern="0" dirty="0">
-                <a:solidFill>
-                  <a:srgbClr val="121519"/>
-                </a:solidFill>
-                <a:latin typeface="Inter Medium" pitchFamily="34" charset="0"/>
-                <a:ea typeface="Inter Medium" pitchFamily="34" charset="-122"/>
-                <a:cs typeface="Inter Medium" pitchFamily="34" charset="-120"/>
-              </a:rPr>
-              <a:t>Resources to Value</a:t>
-            </a:r>
-            <a:endParaRPr lang="en-US" sz="640" dirty="0"/>
-          </a:p>
-        </p:txBody>
-      </p:sp>
-      <p:sp>
-        <p:nvSpPr>
-          <p:cNvPr id="52" name="Text 50"/>
-          <p:cNvSpPr/>
-          <p:nvPr/>
-        </p:nvSpPr>
-        <p:spPr>
-          <a:xfrm>
-            <a:off x="14357271" y="8576246"/>
-            <a:ext cx="303047" cy="76233"/>
-          </a:xfrm>
-          <a:prstGeom prst="rect">
-            <a:avLst/>
-          </a:prstGeom>
-          <a:noFill/>
-          <a:ln/>
-        </p:spPr>
-        <p:txBody>
-          <a:bodyPr wrap="none" lIns="0" tIns="0" rIns="0" bIns="0" rtlCol="0" anchor="t"/>
-          <a:lstStyle/>
-          <a:p>
-            <a:pPr algn="l" indent="0" marL="0">
-              <a:lnSpc>
-                <a:spcPts val="600"/>
-              </a:lnSpc>
-              <a:buNone/>
-            </a:pPr>
-            <a:r>
-              <a:rPr lang="en-US" sz="540" spc="160" kern="0" dirty="0">
-                <a:solidFill>
-                  <a:srgbClr val="7D838A"/>
-                </a:solidFill>
-                <a:latin typeface="Inter Medium" pitchFamily="34" charset="0"/>
-                <a:ea typeface="Inter Medium" pitchFamily="34" charset="-122"/>
-                <a:cs typeface="Inter Medium" pitchFamily="34" charset="-120"/>
-              </a:rPr>
-              <a:t>P.08</a:t>
-            </a:r>
-            <a:endParaRPr lang="en-US" sz="540" dirty="0"/>
-          </a:p>
-        </p:txBody>
-      </p:sp>
-      <p:sp>
-        <p:nvSpPr>
-          <p:cNvPr id="53" name="Text 51"/>
-          <p:cNvSpPr/>
-          <p:nvPr/>
-        </p:nvSpPr>
-        <p:spPr>
-          <a:xfrm>
-            <a:off x="12260855" y="8843063"/>
-            <a:ext cx="170929" cy="101644"/>
-          </a:xfrm>
-          <a:prstGeom prst="rect">
-            <a:avLst/>
-          </a:prstGeom>
-          <a:noFill/>
-          <a:ln/>
-        </p:spPr>
-        <p:txBody>
-          <a:bodyPr wrap="none" lIns="0" tIns="0" rIns="0" bIns="0" rtlCol="0" anchor="t"/>
-          <a:lstStyle/>
-          <a:p>
-            <a:pPr algn="l" indent="0" marL="0">
-              <a:lnSpc>
-                <a:spcPts val="800"/>
-              </a:lnSpc>
-              <a:buNone/>
-            </a:pPr>
-            <a:r>
-              <a:rPr lang="en-US" sz="640" spc="30" kern="0" dirty="0">
-                <a:solidFill>
-                  <a:srgbClr val="9C7442"/>
-                </a:solidFill>
-                <a:latin typeface="Inter Medium" pitchFamily="34" charset="0"/>
-                <a:ea typeface="Inter Medium" pitchFamily="34" charset="-122"/>
-                <a:cs typeface="Inter Medium" pitchFamily="34" charset="-120"/>
-              </a:rPr>
-              <a:t>05</a:t>
-            </a:r>
-            <a:endParaRPr lang="en-US" sz="640" dirty="0"/>
-          </a:p>
-        </p:txBody>
-      </p:sp>
-      <p:sp>
-        <p:nvSpPr>
-          <p:cNvPr id="54" name="Text 52"/>
-          <p:cNvSpPr/>
-          <p:nvPr/>
-        </p:nvSpPr>
-        <p:spPr>
-          <a:xfrm>
-            <a:off x="12514966" y="8843063"/>
-            <a:ext cx="643715" cy="101644"/>
-          </a:xfrm>
-          <a:prstGeom prst="rect">
-            <a:avLst/>
-          </a:prstGeom>
-          <a:noFill/>
-          <a:ln/>
-        </p:spPr>
-        <p:txBody>
-          <a:bodyPr wrap="none" lIns="0" tIns="0" rIns="0" bIns="0" rtlCol="0" anchor="t"/>
-          <a:lstStyle/>
-          <a:p>
-            <a:pPr algn="l" indent="0" marL="0">
-              <a:lnSpc>
-                <a:spcPts val="800"/>
-              </a:lnSpc>
-              <a:buNone/>
-            </a:pPr>
-            <a:r>
-              <a:rPr lang="en-US" sz="640" spc="30" kern="0" dirty="0">
-                <a:solidFill>
-                  <a:srgbClr val="121519"/>
-                </a:solidFill>
-                <a:latin typeface="Inter Medium" pitchFamily="34" charset="0"/>
-                <a:ea typeface="Inter Medium" pitchFamily="34" charset="-122"/>
-                <a:cs typeface="Inter Medium" pitchFamily="34" charset="-120"/>
-              </a:rPr>
-              <a:t>Partnerships</a:t>
-            </a:r>
-            <a:endParaRPr lang="en-US" sz="640" dirty="0"/>
-          </a:p>
-        </p:txBody>
-      </p:sp>
-      <p:sp>
-        <p:nvSpPr>
-          <p:cNvPr id="55" name="Text 53"/>
-          <p:cNvSpPr/>
-          <p:nvPr/>
-        </p:nvSpPr>
-        <p:spPr>
-          <a:xfrm>
-            <a:off x="14357271" y="8843063"/>
-            <a:ext cx="303047" cy="76233"/>
-          </a:xfrm>
-          <a:prstGeom prst="rect">
-            <a:avLst/>
-          </a:prstGeom>
-          <a:noFill/>
-          <a:ln/>
-        </p:spPr>
-        <p:txBody>
-          <a:bodyPr wrap="none" lIns="0" tIns="0" rIns="0" bIns="0" rtlCol="0" anchor="t"/>
-          <a:lstStyle/>
-          <a:p>
-            <a:pPr algn="l" indent="0" marL="0">
-              <a:lnSpc>
-                <a:spcPts val="600"/>
-              </a:lnSpc>
-              <a:buNone/>
-            </a:pPr>
-            <a:r>
-              <a:rPr lang="en-US" sz="540" spc="160" kern="0" dirty="0">
-                <a:solidFill>
-                  <a:srgbClr val="7D838A"/>
-                </a:solidFill>
-                <a:latin typeface="Inter Medium" pitchFamily="34" charset="0"/>
-                <a:ea typeface="Inter Medium" pitchFamily="34" charset="-122"/>
-                <a:cs typeface="Inter Medium" pitchFamily="34" charset="-120"/>
-              </a:rPr>
-              <a:t>P.09</a:t>
-            </a:r>
-            <a:endParaRPr lang="en-US" sz="540" dirty="0"/>
-          </a:p>
-        </p:txBody>
-      </p:sp>
-      <p:sp>
-        <p:nvSpPr>
-          <p:cNvPr id="56" name="Text 54"/>
-          <p:cNvSpPr/>
-          <p:nvPr/>
-        </p:nvSpPr>
-        <p:spPr>
-          <a:xfrm>
-            <a:off x="12260855" y="9109879"/>
-            <a:ext cx="173331" cy="101644"/>
-          </a:xfrm>
-          <a:prstGeom prst="rect">
-            <a:avLst/>
-          </a:prstGeom>
-          <a:noFill/>
-          <a:ln/>
-        </p:spPr>
-        <p:txBody>
-          <a:bodyPr wrap="none" lIns="0" tIns="0" rIns="0" bIns="0" rtlCol="0" anchor="t"/>
-          <a:lstStyle/>
-          <a:p>
-            <a:pPr algn="l" indent="0" marL="0">
-              <a:lnSpc>
-                <a:spcPts val="800"/>
-              </a:lnSpc>
-              <a:buNone/>
-            </a:pPr>
-            <a:r>
-              <a:rPr lang="en-US" sz="640" spc="30" kern="0" dirty="0">
-                <a:solidFill>
-                  <a:srgbClr val="9C7442"/>
-                </a:solidFill>
-                <a:latin typeface="Inter Medium" pitchFamily="34" charset="0"/>
-                <a:ea typeface="Inter Medium" pitchFamily="34" charset="-122"/>
-                <a:cs typeface="Inter Medium" pitchFamily="34" charset="-120"/>
-              </a:rPr>
-              <a:t>06</a:t>
-            </a:r>
-            <a:endParaRPr lang="en-US" sz="640" dirty="0"/>
-          </a:p>
-        </p:txBody>
-      </p:sp>
-      <p:sp>
-        <p:nvSpPr>
-          <p:cNvPr id="57" name="Text 55"/>
-          <p:cNvSpPr/>
-          <p:nvPr/>
-        </p:nvSpPr>
-        <p:spPr>
-          <a:xfrm>
-            <a:off x="12514966" y="9109879"/>
-            <a:ext cx="605062" cy="101644"/>
-          </a:xfrm>
-          <a:prstGeom prst="rect">
-            <a:avLst/>
-          </a:prstGeom>
-          <a:noFill/>
-          <a:ln/>
-        </p:spPr>
-        <p:txBody>
-          <a:bodyPr wrap="none" lIns="0" tIns="0" rIns="0" bIns="0" rtlCol="0" anchor="t"/>
-          <a:lstStyle/>
-          <a:p>
-            <a:pPr algn="l" indent="0" marL="0">
-              <a:lnSpc>
-                <a:spcPts val="800"/>
-              </a:lnSpc>
-              <a:buNone/>
-            </a:pPr>
-            <a:r>
-              <a:rPr lang="en-US" sz="640" spc="30" kern="0" dirty="0">
-                <a:solidFill>
-                  <a:srgbClr val="121519"/>
-                </a:solidFill>
-                <a:latin typeface="Inter Medium" pitchFamily="34" charset="0"/>
-                <a:ea typeface="Inter Medium" pitchFamily="34" charset="-122"/>
-                <a:cs typeface="Inter Medium" pitchFamily="34" charset="-120"/>
-              </a:rPr>
-              <a:t>Value Chain</a:t>
-            </a:r>
-            <a:endParaRPr lang="en-US" sz="640" dirty="0"/>
-          </a:p>
-        </p:txBody>
-      </p:sp>
-      <p:sp>
-        <p:nvSpPr>
-          <p:cNvPr id="58" name="Text 56"/>
-          <p:cNvSpPr/>
-          <p:nvPr/>
-        </p:nvSpPr>
-        <p:spPr>
-          <a:xfrm>
-            <a:off x="14357271" y="9109879"/>
-            <a:ext cx="282301" cy="76233"/>
-          </a:xfrm>
-          <a:prstGeom prst="rect">
-            <a:avLst/>
-          </a:prstGeom>
-          <a:noFill/>
-          <a:ln/>
-        </p:spPr>
-        <p:txBody>
-          <a:bodyPr wrap="none" lIns="0" tIns="0" rIns="0" bIns="0" rtlCol="0" anchor="t"/>
-          <a:lstStyle/>
-          <a:p>
-            <a:pPr algn="l" indent="0" marL="0">
-              <a:lnSpc>
-                <a:spcPts val="600"/>
-              </a:lnSpc>
-              <a:buNone/>
-            </a:pPr>
-            <a:r>
-              <a:rPr lang="en-US" sz="540" spc="160" kern="0" dirty="0">
-                <a:solidFill>
-                  <a:srgbClr val="7D838A"/>
-                </a:solidFill>
-                <a:latin typeface="Inter Medium" pitchFamily="34" charset="0"/>
-                <a:ea typeface="Inter Medium" pitchFamily="34" charset="-122"/>
-                <a:cs typeface="Inter Medium" pitchFamily="34" charset="-120"/>
-              </a:rPr>
-              <a:t>P.10</a:t>
-            </a:r>
-            <a:endParaRPr lang="en-US" sz="540" dirty="0"/>
-          </a:p>
-        </p:txBody>
-      </p:sp>
-      <p:sp>
-        <p:nvSpPr>
-          <p:cNvPr id="59" name="Text 57"/>
-          <p:cNvSpPr/>
-          <p:nvPr/>
-        </p:nvSpPr>
-        <p:spPr>
-          <a:xfrm>
-            <a:off x="508222" y="10316906"/>
-            <a:ext cx="201502" cy="88939"/>
-          </a:xfrm>
-          <a:prstGeom prst="rect">
-            <a:avLst/>
-          </a:prstGeom>
-          <a:noFill/>
-          <a:ln/>
-        </p:spPr>
-        <p:txBody>
-          <a:bodyPr wrap="none" lIns="0" tIns="0" rIns="0" bIns="0" rtlCol="0" anchor="t"/>
-          <a:lstStyle/>
-          <a:p>
-            <a:pPr algn="l" indent="0" marL="0">
-              <a:lnSpc>
-                <a:spcPts val="700"/>
-              </a:lnSpc>
-              <a:buNone/>
-            </a:pPr>
-            <a:r>
-              <a:rPr lang="en-US" sz="600" spc="160" kern="0" dirty="0">
-                <a:solidFill>
-                  <a:srgbClr val="7D838A"/>
-                </a:solidFill>
-                <a:latin typeface="Inter Medium" pitchFamily="34" charset="0"/>
-                <a:ea typeface="Inter Medium" pitchFamily="34" charset="-122"/>
-                <a:cs typeface="Inter Medium" pitchFamily="34" charset="-120"/>
-              </a:rPr>
-              <a:t>02</a:t>
-            </a:r>
-            <a:endParaRPr lang="en-US" sz="600" dirty="0"/>
-          </a:p>
-        </p:txBody>
-      </p:sp>
-      <p:sp>
-        <p:nvSpPr>
-          <p:cNvPr id="60" name="Text 58"/>
-          <p:cNvSpPr/>
-          <p:nvPr/>
-        </p:nvSpPr>
-        <p:spPr>
-          <a:xfrm>
-            <a:off x="14458915" y="10316906"/>
-            <a:ext cx="202376" cy="88939"/>
-          </a:xfrm>
-          <a:prstGeom prst="rect">
-            <a:avLst/>
-          </a:prstGeom>
-          <a:noFill/>
-          <a:ln/>
-        </p:spPr>
-        <p:txBody>
-          <a:bodyPr wrap="none" lIns="0" tIns="0" rIns="0" bIns="0" rtlCol="0" anchor="t"/>
-          <a:lstStyle/>
-          <a:p>
-            <a:pPr algn="l" indent="0" marL="0">
-              <a:lnSpc>
-                <a:spcPts val="700"/>
-              </a:lnSpc>
-              <a:buNone/>
-            </a:pPr>
-            <a:r>
-              <a:rPr lang="en-US" sz="600" spc="160" kern="0" dirty="0">
-                <a:solidFill>
-                  <a:srgbClr val="7D838A"/>
-                </a:solidFill>
-                <a:latin typeface="Inter Medium" pitchFamily="34" charset="0"/>
-                <a:ea typeface="Inter Medium" pitchFamily="34" charset="-122"/>
-                <a:cs typeface="Inter Medium" pitchFamily="34" charset="-120"/>
-              </a:rPr>
-              <a:t>03</a:t>
-            </a:r>
-            <a:endParaRPr lang="en-US" sz="600" dirty="0"/>
-          </a:p>
-        </p:txBody>
-      </p:sp>
-      <p:sp>
-        <p:nvSpPr>
           <p:cNvPr id="61" name="Text 59"/>
-          <p:cNvSpPr/>
-          <p:nvPr/>
-        </p:nvSpPr>
-        <p:spPr>
-          <a:xfrm>
-            <a:off x="876683" y="10328977"/>
-            <a:ext cx="6501450" cy="102915"/>
-          </a:xfrm>
-          <a:prstGeom prst="rect">
-            <a:avLst/>
-          </a:prstGeom>
-          <a:noFill/>
-          <a:ln/>
-        </p:spPr>
-        <p:txBody>
-          <a:bodyPr wrap="none" lIns="0" tIns="0" rIns="0" bIns="0" rtlCol="0" anchor="t"/>
-          <a:lstStyle/>
-          <a:p>
-            <a:pPr algn="l" indent="0" marL="0">
-              <a:lnSpc>
-                <a:spcPts val="810"/>
-              </a:lnSpc>
-              <a:buNone/>
-            </a:pPr>
-            <a:r>
-              <a:rPr lang="en-US" sz="540" dirty="0">
-                <a:solidFill>
-                  <a:srgbClr val="A3A8AE"/>
-                </a:solidFill>
-                <a:latin typeface="Noto Sans JP" pitchFamily="34" charset="0"/>
-                <a:ea typeface="Noto Sans JP" pitchFamily="34" charset="-122"/>
-                <a:cs typeface="Noto Sans JP" pitchFamily="34" charset="-120"/>
-              </a:rPr>
-              <a:t>台割メモ｜動画01 OPENING。地球儀は使わず、暮らしと金属の写真を見開きで1枚のモザイクに（左＝暮らし、右＝それを支える金属）。キャッチコピー＋需要と供給のギャップを概念図で。</a:t>
-            </a:r>
-            <a:endParaRPr lang="en-US" sz="540" dirty="0"/>
-          </a:p>
-        </p:txBody>
-      </p:sp>
-      <p:sp>
-        <p:nvSpPr>
-          <p:cNvPr id="62" name="Text 60"/>
           <p:cNvSpPr/>
           <p:nvPr/>
         </p:nvSpPr>
@@ -7290,7 +7248,7 @@
         <p:spPr>
           <a:xfrm>
             <a:off x="9122585" y="9064012"/>
-            <a:ext cx="2915924" cy="285113"/>
+            <a:ext cx="2915924" cy="427669"/>
           </a:xfrm>
           <a:prstGeom prst="rect">
             <a:avLst/>
@@ -7337,7 +7295,27 @@
                 <a:ea typeface="Noto Sans JP" pitchFamily="34" charset="-122"/>
                 <a:cs typeface="Noto Sans JP" pitchFamily="34" charset="-120"/>
               </a:rPr>
-              <a:t>と組みQuellavecoなど大型化。</a:t>
+              <a:t>と組みQuellavecoなど大型化。2012年にRtMを設立し、マーケテ</a:t>
+            </a:r>
+            <a:endParaRPr lang="en-US" sz="660" dirty="0"/>
+          </a:p>
+          <a:p>
+            <a:pPr algn="l" indent="0" marL="0">
+              <a:lnSpc>
+                <a:spcPts val="1122"/>
+              </a:lnSpc>
+              <a:buNone/>
+            </a:pPr>
+            <a:r>
+              <a:rPr lang="en-US" sz="660" spc="20" kern="0" dirty="0">
+                <a:solidFill>
+                  <a:srgbClr val="3D4249"/>
+                </a:solidFill>
+                <a:latin typeface="Noto Sans JP" pitchFamily="34" charset="0"/>
+                <a:ea typeface="Noto Sans JP" pitchFamily="34" charset="-122"/>
+                <a:cs typeface="Noto Sans JP" pitchFamily="34" charset="-120"/>
+              </a:rPr>
+              <a:t>ィングを集約。</a:t>
             </a:r>
             <a:endParaRPr lang="en-US" sz="660" dirty="0"/>
           </a:p>
@@ -7463,7 +7441,7 @@
                 <a:ea typeface="Noto Sans JP" pitchFamily="34" charset="-122"/>
                 <a:cs typeface="Noto Sans JP" pitchFamily="34" charset="-120"/>
               </a:rPr>
-              <a:t>各地のマーケティングをRtMとしてシンガポールに集約。地域特化</a:t>
+              <a:t>地域に特化したトレーディングから、世界の市場を相手にするグロ</a:t>
             </a:r>
             <a:endParaRPr lang="en-US" sz="660" dirty="0"/>
           </a:p>
@@ -7483,7 +7461,7 @@
                 <a:ea typeface="Noto Sans JP" pitchFamily="34" charset="-122"/>
                 <a:cs typeface="Noto Sans JP" pitchFamily="34" charset="-120"/>
               </a:rPr>
-              <a:t>から世界の市場へ。</a:t>
+              <a:t>ーバルなトレーダーへ。</a:t>
             </a:r>
             <a:endParaRPr lang="en-US" sz="660" dirty="0"/>
           </a:p>
@@ -16125,27 +16103,69 @@
         </p:nvSpPr>
         <p:spPr>
           <a:xfrm>
-            <a:off x="12794488" y="7738863"/>
-            <a:ext cx="892009" cy="272407"/>
-          </a:xfrm>
-          <a:prstGeom prst="rect">
-            <a:avLst/>
-          </a:prstGeom>
-          <a:noFill/>
-          <a:ln/>
-        </p:spPr>
-        <p:txBody>
-          <a:bodyPr wrap="none" lIns="0" tIns="0" rIns="0" bIns="0" rtlCol="0" anchor="t"/>
-          <a:lstStyle/>
-          <a:p>
-            <a:pPr algn="l" indent="0" marL="0">
-              <a:lnSpc>
-                <a:spcPts val="1072"/>
-              </a:lnSpc>
-              <a:buNone/>
-            </a:pPr>
-            <a:r>
-              <a:rPr lang="en-US" sz="670" dirty="0">
+            <a:off x="8068024" y="8302481"/>
+            <a:ext cx="1823167" cy="101644"/>
+          </a:xfrm>
+          <a:prstGeom prst="rect">
+            <a:avLst/>
+          </a:prstGeom>
+          <a:noFill/>
+          <a:ln/>
+        </p:spPr>
+        <p:txBody>
+          <a:bodyPr wrap="none" lIns="0" tIns="0" rIns="0" bIns="0" rtlCol="0" anchor="t"/>
+          <a:lstStyle/>
+          <a:p>
+            <a:pPr algn="l" indent="0" marL="0">
+              <a:lnSpc>
+                <a:spcPts val="800"/>
+              </a:lnSpc>
+              <a:buNone/>
+            </a:pPr>
+            <a:r>
+              <a:rPr lang="en-US" sz="660" spc="190" kern="0" dirty="0">
+                <a:solidFill>
+                  <a:srgbClr val="9C7442"/>
+                </a:solidFill>
+                <a:latin typeface="Inter SemiBold" pitchFamily="34" charset="0"/>
+                <a:ea typeface="Inter SemiBold" pitchFamily="34" charset="-122"/>
+                <a:cs typeface="Inter SemiBold" pitchFamily="34" charset="-120"/>
+              </a:rPr>
+              <a:t>WHY PARTNERS VALUE US</a:t>
+            </a:r>
+            <a:endParaRPr lang="en-US" sz="660" dirty="0"/>
+          </a:p>
+        </p:txBody>
+      </p:sp>
+      <p:sp>
+        <p:nvSpPr>
+          <p:cNvPr id="95" name="Text 93"/>
+          <p:cNvSpPr/>
+          <p:nvPr/>
+        </p:nvSpPr>
+        <p:spPr>
+          <a:xfrm>
+            <a:off x="9846801" y="8302481"/>
+            <a:ext cx="1358025" cy="127055"/>
+          </a:xfrm>
+          <a:prstGeom prst="rect">
+            <a:avLst/>
+          </a:prstGeom>
+          <a:noFill/>
+          <a:ln/>
+        </p:spPr>
+        <p:txBody>
+          <a:bodyPr wrap="none" lIns="0" tIns="0" rIns="0" bIns="0" rtlCol="0" anchor="t"/>
+          <a:lstStyle/>
+          <a:p>
+            <a:pPr algn="l" indent="0" marL="0">
+              <a:lnSpc>
+                <a:spcPts val="1000"/>
+              </a:lnSpc>
+              <a:buNone/>
+            </a:pPr>
+            <a:r>
+              <a:rPr lang="en-US" sz="660" spc="60" kern="0" dirty="0">
                 <a:solidFill>
                   <a:srgbClr val="7D838A"/>
                 </a:solidFill>
@@ -16153,10 +16173,116 @@
                 <a:ea typeface="Noto Sans JP" pitchFamily="34" charset="-122"/>
                 <a:cs typeface="Noto Sans JP" pitchFamily="34" charset="-120"/>
               </a:rPr>
-              <a:t>他社ロゴは使用せず</a:t>
-            </a:r>
-            <a:endParaRPr lang="en-US" sz="670" dirty="0"/>
-          </a:p>
+              <a:t>パートナーに評価される理由</a:t>
+            </a:r>
+            <a:endParaRPr lang="en-US" sz="660" dirty="0"/>
+          </a:p>
+        </p:txBody>
+      </p:sp>
+      <p:sp>
+        <p:nvSpPr>
+          <p:cNvPr id="96" name="Text 94"/>
+          <p:cNvSpPr/>
+          <p:nvPr/>
+        </p:nvSpPr>
+        <p:spPr>
+          <a:xfrm>
+            <a:off x="8220491" y="8632825"/>
+            <a:ext cx="983509" cy="76233"/>
+          </a:xfrm>
+          <a:prstGeom prst="rect">
+            <a:avLst/>
+          </a:prstGeom>
+          <a:noFill/>
+          <a:ln/>
+        </p:spPr>
+        <p:txBody>
+          <a:bodyPr wrap="none" lIns="0" tIns="0" rIns="0" bIns="0" rtlCol="0" anchor="t"/>
+          <a:lstStyle/>
+          <a:p>
+            <a:pPr algn="l" indent="0" marL="0">
+              <a:lnSpc>
+                <a:spcPts val="600"/>
+              </a:lnSpc>
+              <a:buNone/>
+            </a:pPr>
+            <a:r>
+              <a:rPr lang="en-US" sz="560" spc="120" kern="0" dirty="0">
+                <a:solidFill>
+                  <a:srgbClr val="9C7442"/>
+                </a:solidFill>
+                <a:latin typeface="Inter SemiBold" pitchFamily="34" charset="0"/>
+                <a:ea typeface="Inter SemiBold" pitchFamily="34" charset="-122"/>
+                <a:cs typeface="Inter SemiBold" pitchFamily="34" charset="-120"/>
+              </a:rPr>
+              <a:t>LONG-TERM VIEW</a:t>
+            </a:r>
+            <a:endParaRPr lang="en-US" sz="560" dirty="0"/>
+          </a:p>
+        </p:txBody>
+      </p:sp>
+      <p:sp>
+        <p:nvSpPr>
+          <p:cNvPr id="97" name="Text 95"/>
+          <p:cNvSpPr/>
+          <p:nvPr/>
+        </p:nvSpPr>
+        <p:spPr>
+          <a:xfrm>
+            <a:off x="8220491" y="8726021"/>
+            <a:ext cx="921053" cy="169365"/>
+          </a:xfrm>
+          <a:prstGeom prst="rect">
+            <a:avLst/>
+          </a:prstGeom>
+          <a:noFill/>
+          <a:ln/>
+        </p:spPr>
+        <p:txBody>
+          <a:bodyPr wrap="none" lIns="0" tIns="0" rIns="0" bIns="0" rtlCol="0" anchor="t"/>
+          <a:lstStyle/>
+          <a:p>
+            <a:pPr algn="l" indent="0" marL="0">
+              <a:lnSpc>
+                <a:spcPts val="1333"/>
+              </a:lnSpc>
+              <a:buNone/>
+            </a:pPr>
+            <a:r>
+              <a:rPr lang="en-US" sz="860" spc="30" kern="0" dirty="0">
+                <a:solidFill>
+                  <a:srgbClr val="121519"/>
+                </a:solidFill>
+                <a:latin typeface="Noto Sans JP Medium" pitchFamily="34" charset="0"/>
+                <a:ea typeface="Noto Sans JP Medium" pitchFamily="34" charset="-122"/>
+                <a:cs typeface="Noto Sans JP Medium" pitchFamily="34" charset="-120"/>
+              </a:rPr>
+              <a:t>中長期的な視座</a:t>
+            </a:r>
+            <a:endParaRPr lang="en-US" sz="860" dirty="0"/>
+          </a:p>
+        </p:txBody>
+      </p:sp>
+      <p:sp>
+        <p:nvSpPr>
+          <p:cNvPr id="98" name="Text 96"/>
+          <p:cNvSpPr/>
+          <p:nvPr/>
+        </p:nvSpPr>
+        <p:spPr>
+          <a:xfrm>
+            <a:off x="8220491" y="8937155"/>
+            <a:ext cx="1915540" cy="272407"/>
+          </a:xfrm>
+          <a:prstGeom prst="rect">
+            <a:avLst/>
+          </a:prstGeom>
+          <a:noFill/>
+          <a:ln/>
+        </p:spPr>
+        <p:txBody>
+          <a:bodyPr wrap="none" lIns="0" tIns="0" rIns="0" bIns="0" rtlCol="0" anchor="t"/>
+          <a:lstStyle/>
           <a:p>
             <a:pPr algn="l" indent="0" marL="0">
               <a:lnSpc>
@@ -16173,41 +16299,61 @@
                 <a:ea typeface="Noto Sans JP" pitchFamily="34" charset="-122"/>
                 <a:cs typeface="Noto Sans JP" pitchFamily="34" charset="-120"/>
               </a:rPr>
-              <a:t>社名テキストで表記</a:t>
+              <a:t>資源事業は長期にわたる。短期的リターンを</a:t>
             </a:r>
             <a:endParaRPr lang="en-US" sz="670" dirty="0"/>
           </a:p>
-        </p:txBody>
-      </p:sp>
-      <p:sp>
-        <p:nvSpPr>
-          <p:cNvPr id="95" name="Text 93"/>
-          <p:cNvSpPr/>
-          <p:nvPr/>
-        </p:nvSpPr>
-        <p:spPr>
-          <a:xfrm>
-            <a:off x="8068024" y="8302481"/>
-            <a:ext cx="1823167" cy="101644"/>
-          </a:xfrm>
-          <a:prstGeom prst="rect">
-            <a:avLst/>
-          </a:prstGeom>
-          <a:noFill/>
-          <a:ln/>
-        </p:spPr>
-        <p:txBody>
-          <a:bodyPr wrap="none" lIns="0" tIns="0" rIns="0" bIns="0" rtlCol="0" anchor="t"/>
-          <a:lstStyle/>
-          <a:p>
-            <a:pPr algn="l" indent="0" marL="0">
-              <a:lnSpc>
-                <a:spcPts val="800"/>
-              </a:lnSpc>
-              <a:buNone/>
-            </a:pPr>
-            <a:r>
-              <a:rPr lang="en-US" sz="660" spc="190" kern="0" dirty="0">
+          <a:p>
+            <a:pPr algn="l" indent="0" marL="0">
+              <a:lnSpc>
+                <a:spcPts val="1072"/>
+              </a:lnSpc>
+              <a:buNone/>
+            </a:pPr>
+            <a:r>
+              <a:rPr lang="en-US" sz="670" dirty="0">
+                <a:solidFill>
+                  <a:srgbClr val="7D838A"/>
+                </a:solidFill>
+                <a:latin typeface="Noto Sans JP" pitchFamily="34" charset="0"/>
+                <a:ea typeface="Noto Sans JP" pitchFamily="34" charset="-122"/>
+                <a:cs typeface="Noto Sans JP" pitchFamily="34" charset="-120"/>
+              </a:rPr>
+              <a:t>求める投資家とは一線を画す。</a:t>
+            </a:r>
+            <a:endParaRPr lang="en-US" sz="670" dirty="0"/>
+          </a:p>
+        </p:txBody>
+      </p:sp>
+      <p:sp>
+        <p:nvSpPr>
+          <p:cNvPr id="99" name="Text 97"/>
+          <p:cNvSpPr/>
+          <p:nvPr/>
+        </p:nvSpPr>
+        <p:spPr>
+          <a:xfrm>
+            <a:off x="10456667" y="8632825"/>
+            <a:ext cx="806842" cy="76233"/>
+          </a:xfrm>
+          <a:prstGeom prst="rect">
+            <a:avLst/>
+          </a:prstGeom>
+          <a:noFill/>
+          <a:ln/>
+        </p:spPr>
+        <p:txBody>
+          <a:bodyPr wrap="none" lIns="0" tIns="0" rIns="0" bIns="0" rtlCol="0" anchor="t"/>
+          <a:lstStyle/>
+          <a:p>
+            <a:pPr algn="l" indent="0" marL="0">
+              <a:lnSpc>
+                <a:spcPts val="600"/>
+              </a:lnSpc>
+              <a:buNone/>
+            </a:pPr>
+            <a:r>
+              <a:rPr lang="en-US" sz="560" spc="120" kern="0" dirty="0">
                 <a:solidFill>
                   <a:srgbClr val="9C7442"/>
                 </a:solidFill>
@@ -16215,41 +16361,83 @@
                 <a:ea typeface="Inter SemiBold" pitchFamily="34" charset="-122"/>
                 <a:cs typeface="Inter SemiBold" pitchFamily="34" charset="-120"/>
               </a:rPr>
-              <a:t>WHY PARTNERS VALUE US</a:t>
-            </a:r>
-            <a:endParaRPr lang="en-US" sz="660" dirty="0"/>
-          </a:p>
-        </p:txBody>
-      </p:sp>
-      <p:sp>
-        <p:nvSpPr>
-          <p:cNvPr id="96" name="Text 94"/>
-          <p:cNvSpPr/>
-          <p:nvPr/>
-        </p:nvSpPr>
-        <p:spPr>
-          <a:xfrm>
-            <a:off x="9846801" y="8302481"/>
-            <a:ext cx="1358025" cy="127055"/>
-          </a:xfrm>
-          <a:prstGeom prst="rect">
-            <a:avLst/>
-          </a:prstGeom>
-          <a:noFill/>
-          <a:ln/>
-        </p:spPr>
-        <p:txBody>
-          <a:bodyPr wrap="none" lIns="0" tIns="0" rIns="0" bIns="0" rtlCol="0" anchor="t"/>
-          <a:lstStyle/>
-          <a:p>
-            <a:pPr algn="l" indent="0" marL="0">
-              <a:lnSpc>
-                <a:spcPts val="1000"/>
-              </a:lnSpc>
-              <a:buNone/>
-            </a:pPr>
-            <a:r>
-              <a:rPr lang="en-US" sz="660" spc="60" kern="0" dirty="0">
+              <a:t>RISK SHARING</a:t>
+            </a:r>
+            <a:endParaRPr lang="en-US" sz="560" dirty="0"/>
+          </a:p>
+        </p:txBody>
+      </p:sp>
+      <p:sp>
+        <p:nvSpPr>
+          <p:cNvPr id="100" name="Text 98"/>
+          <p:cNvSpPr/>
+          <p:nvPr/>
+        </p:nvSpPr>
+        <p:spPr>
+          <a:xfrm>
+            <a:off x="10456667" y="8726021"/>
+            <a:ext cx="1169566" cy="169365"/>
+          </a:xfrm>
+          <a:prstGeom prst="rect">
+            <a:avLst/>
+          </a:prstGeom>
+          <a:noFill/>
+          <a:ln/>
+        </p:spPr>
+        <p:txBody>
+          <a:bodyPr wrap="none" lIns="0" tIns="0" rIns="0" bIns="0" rtlCol="0" anchor="t"/>
+          <a:lstStyle/>
+          <a:p>
+            <a:pPr algn="l" indent="0" marL="0">
+              <a:lnSpc>
+                <a:spcPts val="1333"/>
+              </a:lnSpc>
+              <a:buNone/>
+            </a:pPr>
+            <a:r>
+              <a:rPr lang="en-US" sz="860" spc="30" kern="0" dirty="0">
+                <a:solidFill>
+                  <a:srgbClr val="121519"/>
+                </a:solidFill>
+                <a:latin typeface="Noto Sans JP Medium" pitchFamily="34" charset="0"/>
+                <a:ea typeface="Noto Sans JP Medium" pitchFamily="34" charset="-122"/>
+                <a:cs typeface="Noto Sans JP Medium" pitchFamily="34" charset="-120"/>
+              </a:rPr>
+              <a:t>リスクシェアリング</a:t>
+            </a:r>
+            <a:endParaRPr lang="en-US" sz="860" dirty="0"/>
+          </a:p>
+        </p:txBody>
+      </p:sp>
+      <p:sp>
+        <p:nvSpPr>
+          <p:cNvPr id="101" name="Text 99"/>
+          <p:cNvSpPr/>
+          <p:nvPr/>
+        </p:nvSpPr>
+        <p:spPr>
+          <a:xfrm>
+            <a:off x="10456667" y="8937155"/>
+            <a:ext cx="1915540" cy="272407"/>
+          </a:xfrm>
+          <a:prstGeom prst="rect">
+            <a:avLst/>
+          </a:prstGeom>
+          <a:noFill/>
+          <a:ln/>
+        </p:spPr>
+        <p:txBody>
+          <a:bodyPr wrap="none" lIns="0" tIns="0" rIns="0" bIns="0" rtlCol="0" anchor="t"/>
+          <a:lstStyle/>
+          <a:p>
+            <a:pPr algn="l" indent="0" marL="0">
+              <a:lnSpc>
+                <a:spcPts val="1072"/>
+              </a:lnSpc>
+              <a:buNone/>
+            </a:pPr>
+            <a:r>
+              <a:rPr lang="en-US" sz="670" dirty="0">
                 <a:solidFill>
                   <a:srgbClr val="7D838A"/>
                 </a:solidFill>
@@ -16257,22 +16445,42 @@
                 <a:ea typeface="Noto Sans JP" pitchFamily="34" charset="-122"/>
                 <a:cs typeface="Noto Sans JP" pitchFamily="34" charset="-120"/>
               </a:rPr>
-              <a:t>パートナーに評価される理由</a:t>
-            </a:r>
-            <a:endParaRPr lang="en-US" sz="660" dirty="0"/>
-          </a:p>
-        </p:txBody>
-      </p:sp>
-      <p:sp>
-        <p:nvSpPr>
-          <p:cNvPr id="97" name="Text 95"/>
-          <p:cNvSpPr/>
-          <p:nvPr/>
-        </p:nvSpPr>
-        <p:spPr>
-          <a:xfrm>
-            <a:off x="8220491" y="8632825"/>
-            <a:ext cx="983509" cy="76233"/>
+              <a:t>リスクの高い案件ほど、資金面の分担を担保</a:t>
+            </a:r>
+            <a:endParaRPr lang="en-US" sz="670" dirty="0"/>
+          </a:p>
+          <a:p>
+            <a:pPr algn="l" indent="0" marL="0">
+              <a:lnSpc>
+                <a:spcPts val="1072"/>
+              </a:lnSpc>
+              <a:buNone/>
+            </a:pPr>
+            <a:r>
+              <a:rPr lang="en-US" sz="670" dirty="0">
+                <a:solidFill>
+                  <a:srgbClr val="7D838A"/>
+                </a:solidFill>
+                <a:latin typeface="Noto Sans JP" pitchFamily="34" charset="0"/>
+                <a:ea typeface="Noto Sans JP" pitchFamily="34" charset="-122"/>
+                <a:cs typeface="Noto Sans JP" pitchFamily="34" charset="-120"/>
+              </a:rPr>
+              <a:t>する。</a:t>
+            </a:r>
+            <a:endParaRPr lang="en-US" sz="670" dirty="0"/>
+          </a:p>
+        </p:txBody>
+      </p:sp>
+      <p:sp>
+        <p:nvSpPr>
+          <p:cNvPr id="102" name="Text 100"/>
+          <p:cNvSpPr/>
+          <p:nvPr/>
+        </p:nvSpPr>
+        <p:spPr>
+          <a:xfrm>
+            <a:off x="12692844" y="8632825"/>
+            <a:ext cx="1309982" cy="76233"/>
           </a:xfrm>
           <a:prstGeom prst="rect">
             <a:avLst/>
@@ -16299,7 +16507,7 @@
                 <a:ea typeface="Inter SemiBold" pitchFamily="34" charset="-122"/>
                 <a:cs typeface="Inter SemiBold" pitchFamily="34" charset="-120"/>
               </a:rPr>
-              <a:t>LONG-TERM VIEW</a:t>
+              <a:t>INTEGRATED STRENGTH</a:t>
             </a:r>
             <a:endParaRPr lang="en-US" sz="560" dirty="0"/>
           </a:p>
@@ -16307,14 +16515,14 @@
       </p:sp>
       <p:sp>
         <p:nvSpPr>
-          <p:cNvPr id="98" name="Text 96"/>
-          <p:cNvSpPr/>
-          <p:nvPr/>
-        </p:nvSpPr>
-        <p:spPr>
-          <a:xfrm>
-            <a:off x="8220491" y="8726021"/>
-            <a:ext cx="921053" cy="169365"/>
+          <p:cNvPr id="103" name="Text 101"/>
+          <p:cNvSpPr/>
+          <p:nvPr/>
+        </p:nvSpPr>
+        <p:spPr>
+          <a:xfrm>
+            <a:off x="12692844" y="8726021"/>
+            <a:ext cx="423809" cy="169365"/>
           </a:xfrm>
           <a:prstGeom prst="rect">
             <a:avLst/>
@@ -16341,7 +16549,7 @@
                 <a:ea typeface="Noto Sans JP Medium" pitchFamily="34" charset="-122"/>
                 <a:cs typeface="Noto Sans JP Medium" pitchFamily="34" charset="-120"/>
               </a:rPr>
-              <a:t>中長期的な視座</a:t>
+              <a:t>総合力</a:t>
             </a:r>
             <a:endParaRPr lang="en-US" sz="860" dirty="0"/>
           </a:p>
@@ -16349,14 +16557,14 @@
       </p:sp>
       <p:sp>
         <p:nvSpPr>
-          <p:cNvPr id="99" name="Text 97"/>
-          <p:cNvSpPr/>
-          <p:nvPr/>
-        </p:nvSpPr>
-        <p:spPr>
-          <a:xfrm>
-            <a:off x="8220491" y="8937155"/>
-            <a:ext cx="1915540" cy="272407"/>
+          <p:cNvPr id="104" name="Text 102"/>
+          <p:cNvSpPr/>
+          <p:nvPr/>
+        </p:nvSpPr>
+        <p:spPr>
+          <a:xfrm>
+            <a:off x="12692844" y="8937155"/>
+            <a:ext cx="1920126" cy="272407"/>
           </a:xfrm>
           <a:prstGeom prst="rect">
             <a:avLst/>
@@ -16383,7 +16591,7 @@
                 <a:ea typeface="Noto Sans JP" pitchFamily="34" charset="-122"/>
                 <a:cs typeface="Noto Sans JP" pitchFamily="34" charset="-120"/>
               </a:rPr>
-              <a:t>資源事業は長期にわたる。短期的リターンを</a:t>
+              <a:t>幅広い産業接点を通じ、多様なバリューチェ</a:t>
             </a:r>
             <a:endParaRPr lang="en-US" sz="670" dirty="0"/>
           </a:p>
@@ -16403,7 +16611,7 @@
                 <a:ea typeface="Noto Sans JP" pitchFamily="34" charset="-122"/>
                 <a:cs typeface="Noto Sans JP" pitchFamily="34" charset="-120"/>
               </a:rPr>
-              <a:t>求める投資家とは一線を画す。</a:t>
+              <a:t>ーンに知見を提供する。</a:t>
             </a:r>
             <a:endParaRPr lang="en-US" sz="670" dirty="0"/>
           </a:p>
@@ -16411,445 +16619,153 @@
       </p:sp>
       <p:sp>
         <p:nvSpPr>
-          <p:cNvPr id="100" name="Text 98"/>
-          <p:cNvSpPr/>
-          <p:nvPr/>
-        </p:nvSpPr>
-        <p:spPr>
-          <a:xfrm>
-            <a:off x="10456667" y="8632825"/>
-            <a:ext cx="806842" cy="76233"/>
-          </a:xfrm>
-          <a:prstGeom prst="rect">
-            <a:avLst/>
-          </a:prstGeom>
-          <a:noFill/>
-          <a:ln/>
-        </p:spPr>
-        <p:txBody>
-          <a:bodyPr wrap="none" lIns="0" tIns="0" rIns="0" bIns="0" rtlCol="0" anchor="t"/>
-          <a:lstStyle/>
-          <a:p>
-            <a:pPr algn="l" indent="0" marL="0">
-              <a:lnSpc>
-                <a:spcPts val="600"/>
-              </a:lnSpc>
-              <a:buNone/>
-            </a:pPr>
-            <a:r>
-              <a:rPr lang="en-US" sz="560" spc="120" kern="0" dirty="0">
-                <a:solidFill>
-                  <a:srgbClr val="9C7442"/>
-                </a:solidFill>
-                <a:latin typeface="Inter SemiBold" pitchFamily="34" charset="0"/>
-                <a:ea typeface="Inter SemiBold" pitchFamily="34" charset="-122"/>
-                <a:cs typeface="Inter SemiBold" pitchFamily="34" charset="-120"/>
-              </a:rPr>
-              <a:t>RISK SHARING</a:t>
-            </a:r>
-            <a:endParaRPr lang="en-US" sz="560" dirty="0"/>
-          </a:p>
-        </p:txBody>
-      </p:sp>
-      <p:sp>
-        <p:nvSpPr>
-          <p:cNvPr id="101" name="Text 99"/>
-          <p:cNvSpPr/>
-          <p:nvPr/>
-        </p:nvSpPr>
-        <p:spPr>
-          <a:xfrm>
-            <a:off x="10456667" y="8726021"/>
-            <a:ext cx="1169566" cy="169365"/>
-          </a:xfrm>
-          <a:prstGeom prst="rect">
-            <a:avLst/>
-          </a:prstGeom>
-          <a:noFill/>
-          <a:ln/>
-        </p:spPr>
-        <p:txBody>
-          <a:bodyPr wrap="none" lIns="0" tIns="0" rIns="0" bIns="0" rtlCol="0" anchor="t"/>
-          <a:lstStyle/>
-          <a:p>
-            <a:pPr algn="l" indent="0" marL="0">
-              <a:lnSpc>
-                <a:spcPts val="1333"/>
-              </a:lnSpc>
-              <a:buNone/>
-            </a:pPr>
-            <a:r>
-              <a:rPr lang="en-US" sz="860" spc="30" kern="0" dirty="0">
-                <a:solidFill>
-                  <a:srgbClr val="121519"/>
-                </a:solidFill>
-                <a:latin typeface="Noto Sans JP Medium" pitchFamily="34" charset="0"/>
-                <a:ea typeface="Noto Sans JP Medium" pitchFamily="34" charset="-122"/>
-                <a:cs typeface="Noto Sans JP Medium" pitchFamily="34" charset="-120"/>
-              </a:rPr>
-              <a:t>リスクシェアリング</a:t>
-            </a:r>
-            <a:endParaRPr lang="en-US" sz="860" dirty="0"/>
-          </a:p>
-        </p:txBody>
-      </p:sp>
-      <p:sp>
-        <p:nvSpPr>
-          <p:cNvPr id="102" name="Text 100"/>
-          <p:cNvSpPr/>
-          <p:nvPr/>
-        </p:nvSpPr>
-        <p:spPr>
-          <a:xfrm>
-            <a:off x="10456667" y="8937155"/>
-            <a:ext cx="1915540" cy="272407"/>
-          </a:xfrm>
-          <a:prstGeom prst="rect">
-            <a:avLst/>
-          </a:prstGeom>
-          <a:noFill/>
-          <a:ln/>
-        </p:spPr>
-        <p:txBody>
-          <a:bodyPr wrap="none" lIns="0" tIns="0" rIns="0" bIns="0" rtlCol="0" anchor="t"/>
-          <a:lstStyle/>
-          <a:p>
-            <a:pPr algn="l" indent="0" marL="0">
-              <a:lnSpc>
-                <a:spcPts val="1072"/>
-              </a:lnSpc>
-              <a:buNone/>
-            </a:pPr>
-            <a:r>
-              <a:rPr lang="en-US" sz="670" dirty="0">
+          <p:cNvPr id="105" name="Text 103"/>
+          <p:cNvSpPr/>
+          <p:nvPr/>
+        </p:nvSpPr>
+        <p:spPr>
+          <a:xfrm>
+            <a:off x="508222" y="10316906"/>
+            <a:ext cx="202594" cy="88939"/>
+          </a:xfrm>
+          <a:prstGeom prst="rect">
+            <a:avLst/>
+          </a:prstGeom>
+          <a:noFill/>
+          <a:ln/>
+        </p:spPr>
+        <p:txBody>
+          <a:bodyPr wrap="none" lIns="0" tIns="0" rIns="0" bIns="0" rtlCol="0" anchor="t"/>
+          <a:lstStyle/>
+          <a:p>
+            <a:pPr algn="l" indent="0" marL="0">
+              <a:lnSpc>
+                <a:spcPts val="700"/>
+              </a:lnSpc>
+              <a:buNone/>
+            </a:pPr>
+            <a:r>
+              <a:rPr lang="en-US" sz="600" spc="160" kern="0" dirty="0">
                 <a:solidFill>
                   <a:srgbClr val="7D838A"/>
+                </a:solidFill>
+                <a:latin typeface="Inter Medium" pitchFamily="34" charset="0"/>
+                <a:ea typeface="Inter Medium" pitchFamily="34" charset="-122"/>
+                <a:cs typeface="Inter Medium" pitchFamily="34" charset="-120"/>
+              </a:rPr>
+              <a:t>08</a:t>
+            </a:r>
+            <a:endParaRPr lang="en-US" sz="600" dirty="0"/>
+          </a:p>
+        </p:txBody>
+      </p:sp>
+      <p:sp>
+        <p:nvSpPr>
+          <p:cNvPr id="106" name="Text 104"/>
+          <p:cNvSpPr/>
+          <p:nvPr/>
+        </p:nvSpPr>
+        <p:spPr>
+          <a:xfrm>
+            <a:off x="14458915" y="10316906"/>
+            <a:ext cx="202594" cy="88939"/>
+          </a:xfrm>
+          <a:prstGeom prst="rect">
+            <a:avLst/>
+          </a:prstGeom>
+          <a:noFill/>
+          <a:ln/>
+        </p:spPr>
+        <p:txBody>
+          <a:bodyPr wrap="none" lIns="0" tIns="0" rIns="0" bIns="0" rtlCol="0" anchor="t"/>
+          <a:lstStyle/>
+          <a:p>
+            <a:pPr algn="l" indent="0" marL="0">
+              <a:lnSpc>
+                <a:spcPts val="700"/>
+              </a:lnSpc>
+              <a:buNone/>
+            </a:pPr>
+            <a:r>
+              <a:rPr lang="en-US" sz="600" spc="160" kern="0" dirty="0">
+                <a:solidFill>
+                  <a:srgbClr val="7D838A"/>
+                </a:solidFill>
+                <a:latin typeface="Inter Medium" pitchFamily="34" charset="0"/>
+                <a:ea typeface="Inter Medium" pitchFamily="34" charset="-122"/>
+                <a:cs typeface="Inter Medium" pitchFamily="34" charset="-120"/>
+              </a:rPr>
+              <a:t>09</a:t>
+            </a:r>
+            <a:endParaRPr lang="en-US" sz="600" dirty="0"/>
+          </a:p>
+        </p:txBody>
+      </p:sp>
+      <p:sp>
+        <p:nvSpPr>
+          <p:cNvPr id="107" name="Text 105"/>
+          <p:cNvSpPr/>
+          <p:nvPr/>
+        </p:nvSpPr>
+        <p:spPr>
+          <a:xfrm>
+            <a:off x="876683" y="10328977"/>
+            <a:ext cx="6271062" cy="205830"/>
+          </a:xfrm>
+          <a:prstGeom prst="rect">
+            <a:avLst/>
+          </a:prstGeom>
+          <a:noFill/>
+          <a:ln/>
+        </p:spPr>
+        <p:txBody>
+          <a:bodyPr wrap="none" lIns="0" tIns="0" rIns="0" bIns="0" rtlCol="0" anchor="t"/>
+          <a:lstStyle/>
+          <a:p>
+            <a:pPr algn="l" indent="0" marL="0">
+              <a:lnSpc>
+                <a:spcPts val="810"/>
+              </a:lnSpc>
+              <a:buNone/>
+            </a:pPr>
+            <a:r>
+              <a:rPr lang="en-US" sz="540" dirty="0">
+                <a:solidFill>
+                  <a:srgbClr val="A3A8AE"/>
                 </a:solidFill>
                 <a:latin typeface="Noto Sans JP" pitchFamily="34" charset="0"/>
                 <a:ea typeface="Noto Sans JP" pitchFamily="34" charset="-122"/>
                 <a:cs typeface="Noto Sans JP" pitchFamily="34" charset="-120"/>
               </a:rPr>
-              <a:t>リスクの高い案件ほど、資金面の分担を担保</a:t>
-            </a:r>
-            <a:endParaRPr lang="en-US" sz="670" dirty="0"/>
-          </a:p>
-          <a:p>
-            <a:pPr algn="l" indent="0" marL="0">
-              <a:lnSpc>
-                <a:spcPts val="1072"/>
-              </a:lnSpc>
-              <a:buNone/>
-            </a:pPr>
-            <a:r>
-              <a:rPr lang="en-US" sz="670" dirty="0">
-                <a:solidFill>
-                  <a:srgbClr val="7D838A"/>
+              <a:t>台割メモ｜動画06 From Resources to Value。その他資源を6つのカードで（案件名と地域）。銅の品位の変化（1%→20–30%→99.99%）の上に、技術投資（CiDRA・Jetti・DESCycle・</a:t>
+            </a:r>
+            <a:endParaRPr lang="en-US" sz="540" dirty="0"/>
+          </a:p>
+          <a:p>
+            <a:pPr algn="l" indent="0" marL="0">
+              <a:lnSpc>
+                <a:spcPts val="810"/>
+              </a:lnSpc>
+              <a:buNone/>
+            </a:pPr>
+            <a:r>
+              <a:rPr lang="en-US" sz="540" dirty="0">
+                <a:solidFill>
+                  <a:srgbClr val="A3A8AE"/>
                 </a:solidFill>
                 <a:latin typeface="Noto Sans JP" pitchFamily="34" charset="0"/>
                 <a:ea typeface="Noto Sans JP" pitchFamily="34" charset="-122"/>
                 <a:cs typeface="Noto Sans JP" pitchFamily="34" charset="-120"/>
               </a:rPr>
-              <a:t>する。</a:t>
-            </a:r>
-            <a:endParaRPr lang="en-US" sz="670" dirty="0"/>
-          </a:p>
-        </p:txBody>
-      </p:sp>
-      <p:sp>
-        <p:nvSpPr>
-          <p:cNvPr id="103" name="Text 101"/>
-          <p:cNvSpPr/>
-          <p:nvPr/>
-        </p:nvSpPr>
-        <p:spPr>
-          <a:xfrm>
-            <a:off x="12692844" y="8632825"/>
-            <a:ext cx="1309982" cy="76233"/>
-          </a:xfrm>
-          <a:prstGeom prst="rect">
-            <a:avLst/>
-          </a:prstGeom>
-          <a:noFill/>
-          <a:ln/>
-        </p:spPr>
-        <p:txBody>
-          <a:bodyPr wrap="none" lIns="0" tIns="0" rIns="0" bIns="0" rtlCol="0" anchor="t"/>
-          <a:lstStyle/>
-          <a:p>
-            <a:pPr algn="l" indent="0" marL="0">
-              <a:lnSpc>
-                <a:spcPts val="600"/>
-              </a:lnSpc>
-              <a:buNone/>
-            </a:pPr>
-            <a:r>
-              <a:rPr lang="en-US" sz="560" spc="120" kern="0" dirty="0">
-                <a:solidFill>
-                  <a:srgbClr val="9C7442"/>
-                </a:solidFill>
-                <a:latin typeface="Inter SemiBold" pitchFamily="34" charset="0"/>
-                <a:ea typeface="Inter SemiBold" pitchFamily="34" charset="-122"/>
-                <a:cs typeface="Inter SemiBold" pitchFamily="34" charset="-120"/>
-              </a:rPr>
-              <a:t>INTEGRATED STRENGTH</a:t>
-            </a:r>
-            <a:endParaRPr lang="en-US" sz="560" dirty="0"/>
-          </a:p>
-        </p:txBody>
-      </p:sp>
-      <p:sp>
-        <p:nvSpPr>
-          <p:cNvPr id="104" name="Text 102"/>
-          <p:cNvSpPr/>
-          <p:nvPr/>
-        </p:nvSpPr>
-        <p:spPr>
-          <a:xfrm>
-            <a:off x="12692844" y="8726021"/>
-            <a:ext cx="423809" cy="169365"/>
-          </a:xfrm>
-          <a:prstGeom prst="rect">
-            <a:avLst/>
-          </a:prstGeom>
-          <a:noFill/>
-          <a:ln/>
-        </p:spPr>
-        <p:txBody>
-          <a:bodyPr wrap="none" lIns="0" tIns="0" rIns="0" bIns="0" rtlCol="0" anchor="t"/>
-          <a:lstStyle/>
-          <a:p>
-            <a:pPr algn="l" indent="0" marL="0">
-              <a:lnSpc>
-                <a:spcPts val="1333"/>
-              </a:lnSpc>
-              <a:buNone/>
-            </a:pPr>
-            <a:r>
-              <a:rPr lang="en-US" sz="860" spc="30" kern="0" dirty="0">
-                <a:solidFill>
-                  <a:srgbClr val="121519"/>
-                </a:solidFill>
-                <a:latin typeface="Noto Sans JP Medium" pitchFamily="34" charset="0"/>
-                <a:ea typeface="Noto Sans JP Medium" pitchFamily="34" charset="-122"/>
-                <a:cs typeface="Noto Sans JP Medium" pitchFamily="34" charset="-120"/>
-              </a:rPr>
-              <a:t>総合力</a:t>
-            </a:r>
-            <a:endParaRPr lang="en-US" sz="860" dirty="0"/>
-          </a:p>
-        </p:txBody>
-      </p:sp>
-      <p:sp>
-        <p:nvSpPr>
-          <p:cNvPr id="105" name="Text 103"/>
-          <p:cNvSpPr/>
-          <p:nvPr/>
-        </p:nvSpPr>
-        <p:spPr>
-          <a:xfrm>
-            <a:off x="12692844" y="8937155"/>
-            <a:ext cx="1920126" cy="272407"/>
-          </a:xfrm>
-          <a:prstGeom prst="rect">
-            <a:avLst/>
-          </a:prstGeom>
-          <a:noFill/>
-          <a:ln/>
-        </p:spPr>
-        <p:txBody>
-          <a:bodyPr wrap="none" lIns="0" tIns="0" rIns="0" bIns="0" rtlCol="0" anchor="t"/>
-          <a:lstStyle/>
-          <a:p>
-            <a:pPr algn="l" indent="0" marL="0">
-              <a:lnSpc>
-                <a:spcPts val="1072"/>
-              </a:lnSpc>
-              <a:buNone/>
-            </a:pPr>
-            <a:r>
-              <a:rPr lang="en-US" sz="670" dirty="0">
-                <a:solidFill>
-                  <a:srgbClr val="7D838A"/>
-                </a:solidFill>
-                <a:latin typeface="Noto Sans JP" pitchFamily="34" charset="0"/>
-                <a:ea typeface="Noto Sans JP" pitchFamily="34" charset="-122"/>
-                <a:cs typeface="Noto Sans JP" pitchFamily="34" charset="-120"/>
-              </a:rPr>
-              <a:t>幅広い産業接点を通じ、多様なバリューチェ</a:t>
-            </a:r>
-            <a:endParaRPr lang="en-US" sz="670" dirty="0"/>
-          </a:p>
-          <a:p>
-            <a:pPr algn="l" indent="0" marL="0">
-              <a:lnSpc>
-                <a:spcPts val="1072"/>
-              </a:lnSpc>
-              <a:buNone/>
-            </a:pPr>
-            <a:r>
-              <a:rPr lang="en-US" sz="670" dirty="0">
-                <a:solidFill>
-                  <a:srgbClr val="7D838A"/>
-                </a:solidFill>
-                <a:latin typeface="Noto Sans JP" pitchFamily="34" charset="0"/>
-                <a:ea typeface="Noto Sans JP" pitchFamily="34" charset="-122"/>
-                <a:cs typeface="Noto Sans JP" pitchFamily="34" charset="-120"/>
-              </a:rPr>
-              <a:t>ーンに知見を提供する。</a:t>
-            </a:r>
-            <a:endParaRPr lang="en-US" sz="670" dirty="0"/>
-          </a:p>
-        </p:txBody>
-      </p:sp>
-      <p:sp>
-        <p:nvSpPr>
-          <p:cNvPr id="106" name="Text 104"/>
-          <p:cNvSpPr/>
-          <p:nvPr/>
-        </p:nvSpPr>
-        <p:spPr>
-          <a:xfrm>
-            <a:off x="508222" y="10316906"/>
-            <a:ext cx="202594" cy="88939"/>
-          </a:xfrm>
-          <a:prstGeom prst="rect">
-            <a:avLst/>
-          </a:prstGeom>
-          <a:noFill/>
-          <a:ln/>
-        </p:spPr>
-        <p:txBody>
-          <a:bodyPr wrap="none" lIns="0" tIns="0" rIns="0" bIns="0" rtlCol="0" anchor="t"/>
-          <a:lstStyle/>
-          <a:p>
-            <a:pPr algn="l" indent="0" marL="0">
-              <a:lnSpc>
-                <a:spcPts val="700"/>
-              </a:lnSpc>
-              <a:buNone/>
-            </a:pPr>
-            <a:r>
-              <a:rPr lang="en-US" sz="600" spc="160" kern="0" dirty="0">
-                <a:solidFill>
-                  <a:srgbClr val="7D838A"/>
-                </a:solidFill>
-                <a:latin typeface="Inter Medium" pitchFamily="34" charset="0"/>
-                <a:ea typeface="Inter Medium" pitchFamily="34" charset="-122"/>
-                <a:cs typeface="Inter Medium" pitchFamily="34" charset="-120"/>
-              </a:rPr>
-              <a:t>08</a:t>
-            </a:r>
-            <a:endParaRPr lang="en-US" sz="600" dirty="0"/>
-          </a:p>
-        </p:txBody>
-      </p:sp>
-      <p:sp>
-        <p:nvSpPr>
-          <p:cNvPr id="107" name="Text 105"/>
-          <p:cNvSpPr/>
-          <p:nvPr/>
-        </p:nvSpPr>
-        <p:spPr>
-          <a:xfrm>
-            <a:off x="14458915" y="10316906"/>
-            <a:ext cx="202594" cy="88939"/>
-          </a:xfrm>
-          <a:prstGeom prst="rect">
-            <a:avLst/>
-          </a:prstGeom>
-          <a:noFill/>
-          <a:ln/>
-        </p:spPr>
-        <p:txBody>
-          <a:bodyPr wrap="none" lIns="0" tIns="0" rIns="0" bIns="0" rtlCol="0" anchor="t"/>
-          <a:lstStyle/>
-          <a:p>
-            <a:pPr algn="l" indent="0" marL="0">
-              <a:lnSpc>
-                <a:spcPts val="700"/>
-              </a:lnSpc>
-              <a:buNone/>
-            </a:pPr>
-            <a:r>
-              <a:rPr lang="en-US" sz="600" spc="160" kern="0" dirty="0">
-                <a:solidFill>
-                  <a:srgbClr val="7D838A"/>
-                </a:solidFill>
-                <a:latin typeface="Inter Medium" pitchFamily="34" charset="0"/>
-                <a:ea typeface="Inter Medium" pitchFamily="34" charset="-122"/>
-                <a:cs typeface="Inter Medium" pitchFamily="34" charset="-120"/>
-              </a:rPr>
-              <a:t>09</a:t>
-            </a:r>
-            <a:endParaRPr lang="en-US" sz="600" dirty="0"/>
+              <a:t>Triland）を配置。</a:t>
+            </a:r>
+            <a:endParaRPr lang="en-US" sz="540" dirty="0"/>
           </a:p>
         </p:txBody>
       </p:sp>
       <p:sp>
         <p:nvSpPr>
           <p:cNvPr id="108" name="Text 106"/>
-          <p:cNvSpPr/>
-          <p:nvPr/>
-        </p:nvSpPr>
-        <p:spPr>
-          <a:xfrm>
-            <a:off x="876683" y="10328977"/>
-            <a:ext cx="6271062" cy="205830"/>
-          </a:xfrm>
-          <a:prstGeom prst="rect">
-            <a:avLst/>
-          </a:prstGeom>
-          <a:noFill/>
-          <a:ln/>
-        </p:spPr>
-        <p:txBody>
-          <a:bodyPr wrap="none" lIns="0" tIns="0" rIns="0" bIns="0" rtlCol="0" anchor="t"/>
-          <a:lstStyle/>
-          <a:p>
-            <a:pPr algn="l" indent="0" marL="0">
-              <a:lnSpc>
-                <a:spcPts val="810"/>
-              </a:lnSpc>
-              <a:buNone/>
-            </a:pPr>
-            <a:r>
-              <a:rPr lang="en-US" sz="540" dirty="0">
-                <a:solidFill>
-                  <a:srgbClr val="A3A8AE"/>
-                </a:solidFill>
-                <a:latin typeface="Noto Sans JP" pitchFamily="34" charset="0"/>
-                <a:ea typeface="Noto Sans JP" pitchFamily="34" charset="-122"/>
-                <a:cs typeface="Noto Sans JP" pitchFamily="34" charset="-120"/>
-              </a:rPr>
-              <a:t>台割メモ｜動画06 From Resources to Value。その他資源を6つのカードで（案件名と地域）。銅の品位の変化（1%→20–30%→99.99%）の上に、技術投資（CiDRA・Jetti・DESCycle・</a:t>
-            </a:r>
-            <a:endParaRPr lang="en-US" sz="540" dirty="0"/>
-          </a:p>
-          <a:p>
-            <a:pPr algn="l" indent="0" marL="0">
-              <a:lnSpc>
-                <a:spcPts val="810"/>
-              </a:lnSpc>
-              <a:buNone/>
-            </a:pPr>
-            <a:r>
-              <a:rPr lang="en-US" sz="540" dirty="0">
-                <a:solidFill>
-                  <a:srgbClr val="A3A8AE"/>
-                </a:solidFill>
-                <a:latin typeface="Noto Sans JP" pitchFamily="34" charset="0"/>
-                <a:ea typeface="Noto Sans JP" pitchFamily="34" charset="-122"/>
-                <a:cs typeface="Noto Sans JP" pitchFamily="34" charset="-120"/>
-              </a:rPr>
-              <a:t>Triland）を配置。</a:t>
-            </a:r>
-            <a:endParaRPr lang="en-US" sz="540" dirty="0"/>
-          </a:p>
-        </p:txBody>
-      </p:sp>
-      <p:sp>
-        <p:nvSpPr>
-          <p:cNvPr id="109" name="Text 107"/>
           <p:cNvSpPr/>
           <p:nvPr/>
         </p:nvSpPr>

</xml_diff>